<commit_message>
Prezentatsiya: haqiqiy skrinshotlar (Playwright), pitch versiyasi
Co-Authored-By: Claude Sonnet 5.5 <noreply@anthropic.com>
</commit_message>
<xml_diff>
--- a/presentation/InvenTrack-Pitch.pptx
+++ b/presentation/InvenTrack-Pitch.pptx
@@ -4,9 +4,6 @@
   <p:sldMasterIdLst>
     <p:sldMasterId id="2147483648" r:id="rId1"/>
   </p:sldMasterIdLst>
-  <p:notesMasterIdLst>
-    <p:notesMasterId r:id="rId18"/>
-  </p:notesMasterIdLst>
   <p:sldIdLst>
     <p:sldId id="256" r:id="rId2"/>
     <p:sldId id="257" r:id="rId3"/>
@@ -25,7 +22,10 @@
     <p:sldId id="270" r:id="rId16"/>
     <p:sldId id="271" r:id="rId17"/>
   </p:sldIdLst>
-  <p:sldSz cx="9144000" cy="5143500" type="screen16x9"/>
+  <p:notesMasterIdLst>
+    <p:notesMasterId r:id="rId18"/>
+  </p:notesMasterIdLst>
+  <p:sldSz cx="9144000" cy="5143500"/>
   <p:notesSz cx="5143500" cy="9144000"/>
   <p:defaultTextStyle>
     <a:lvl1pPr marL="0" algn="l" defTabSz="914400" rtl="0" eaLnBrk="1" latinLnBrk="0" hangingPunct="1">
@@ -119,11 +119,6 @@
       </a:defRPr>
     </a:lvl9pPr>
   </p:defaultTextStyle>
-  <p:extLst>
-    <p:ext uri="{EFAFB233-063F-42B5-8137-9DF3F51BA10A}">
-      <p15:sldGuideLst xmlns:p15="http://schemas.microsoft.com/office/powerpoint/2012/main"/>
-    </p:ext>
-  </p:extLst>
 </p:presentation>
 </file>
 
@@ -149,10 +144,234 @@
           <a:chExt cx="0" cy="0"/>
         </a:xfrm>
       </p:grpSpPr>
+      <p:sp>
+        <p:nvSpPr>
+          <p:cNvPr id="2" name="Header Placeholder 1"/>
+          <p:cNvSpPr>
+            <a:spLocks noGrp="1"/>
+          </p:cNvSpPr>
+          <p:nvPr>
+            <p:ph type="hdr" sz="quarter"/>
+          </p:nvPr>
+        </p:nvSpPr>
+        <p:spPr>
+          <a:xfrm>
+            <a:off x="0" y="0"/>
+            <a:ext cx="2971800" cy="458788"/>
+          </a:xfrm>
+          <a:prstGeom prst="rect">
+            <a:avLst/>
+          </a:prstGeom>
+        </p:spPr>
+        <p:txBody>
+          <a:bodyPr vert="horz" lIns="91440" tIns="45720" rIns="91440" bIns="45720" rtlCol="0"/>
+          <a:lstStyle>
+            <a:lvl1pPr algn="l">
+              <a:defRPr sz="1200"/>
+            </a:lvl1pPr>
+          </a:lstStyle>
+          <a:p>
+            <a:endParaRPr lang="en-US"/>
+          </a:p>
+        </p:txBody>
+      </p:sp>
+      <p:sp>
+        <p:nvSpPr>
+          <p:cNvPr id="3" name="Date Placeholder 2"/>
+          <p:cNvSpPr>
+            <a:spLocks noGrp="1"/>
+          </p:cNvSpPr>
+          <p:nvPr>
+            <p:ph type="dt" idx="1"/>
+          </p:nvPr>
+        </p:nvSpPr>
+        <p:spPr>
+          <a:xfrm>
+            <a:off x="3884613" y="0"/>
+            <a:ext cx="2971800" cy="458788"/>
+          </a:xfrm>
+          <a:prstGeom prst="rect">
+            <a:avLst/>
+          </a:prstGeom>
+        </p:spPr>
+        <p:txBody>
+          <a:bodyPr vert="horz" lIns="91440" tIns="45720" rIns="91440" bIns="45720" rtlCol="0"/>
+          <a:lstStyle>
+            <a:lvl1pPr algn="r">
+              <a:defRPr sz="1200"/>
+            </a:lvl1pPr>
+          </a:lstStyle>
+          <a:p>
+            <a:fld id="{5282F153-3F37-0F45-9E97-73ACFA13230C}" type="datetimeFigureOut">
+              <a:rPr lang="en-US"/>
+              <a:t>7/23/19</a:t>
+            </a:fld>
+            <a:endParaRPr lang="en-US"/>
+          </a:p>
+        </p:txBody>
+      </p:sp>
+      <p:sp>
+        <p:nvSpPr>
+          <p:cNvPr id="4" name="Slide Image Placeholder 3"/>
+          <p:cNvSpPr>
+            <a:spLocks noGrp="1" noRot="1" noChangeAspect="1"/>
+          </p:cNvSpPr>
+          <p:nvPr>
+            <p:ph type="sldImg" idx="2"/>
+          </p:nvPr>
+        </p:nvSpPr>
+        <p:spPr>
+          <a:xfrm>
+            <a:off x="685800" y="1143000"/>
+            <a:ext cx="5486400" cy="3086100"/>
+          </a:xfrm>
+          <a:prstGeom prst="rect">
+            <a:avLst/>
+          </a:prstGeom>
+          <a:noFill/>
+          <a:ln w="12700">
+            <a:solidFill>
+              <a:prstClr val="black"/>
+            </a:solidFill>
+          </a:ln>
+        </p:spPr>
+        <p:txBody>
+          <a:bodyPr vert="horz" lIns="91440" tIns="45720" rIns="91440" bIns="45720" rtlCol="0" anchor="ctr"/>
+          <a:lstStyle/>
+          <a:p>
+            <a:endParaRPr lang="en-US"/>
+          </a:p>
+        </p:txBody>
+      </p:sp>
+      <p:sp>
+        <p:nvSpPr>
+          <p:cNvPr id="5" name="Notes Placeholder 4"/>
+          <p:cNvSpPr>
+            <a:spLocks noGrp="1"/>
+          </p:cNvSpPr>
+          <p:nvPr>
+            <p:ph type="body" sz="quarter" idx="3"/>
+          </p:nvPr>
+        </p:nvSpPr>
+        <p:spPr>
+          <a:xfrm>
+            <a:off x="685800" y="4400550"/>
+            <a:ext cx="5486400" cy="3600450"/>
+          </a:xfrm>
+          <a:prstGeom prst="rect">
+            <a:avLst/>
+          </a:prstGeom>
+        </p:spPr>
+        <p:txBody>
+          <a:bodyPr vert="horz" lIns="91440" tIns="45720" rIns="91440" bIns="45720" rtlCol="0"/>
+          <a:lstStyle/>
+          <a:p>
+            <a:pPr lvl="0"/>
+            <a:r>
+              <a:rPr lang="en-US"/>
+              <a:t>Click to edit Master text styles</a:t>
+            </a:r>
+          </a:p>
+          <a:p>
+            <a:pPr lvl="1"/>
+            <a:r>
+              <a:rPr lang="en-US"/>
+              <a:t>Second level</a:t>
+            </a:r>
+          </a:p>
+          <a:p>
+            <a:pPr lvl="2"/>
+            <a:r>
+              <a:rPr lang="en-US"/>
+              <a:t>Third level</a:t>
+            </a:r>
+          </a:p>
+          <a:p>
+            <a:pPr lvl="3"/>
+            <a:r>
+              <a:rPr lang="en-US"/>
+              <a:t>Fourth level</a:t>
+            </a:r>
+          </a:p>
+          <a:p>
+            <a:pPr lvl="4"/>
+            <a:r>
+              <a:rPr lang="en-US"/>
+              <a:t>Fifth level</a:t>
+            </a:r>
+          </a:p>
+        </p:txBody>
+      </p:sp>
+      <p:sp>
+        <p:nvSpPr>
+          <p:cNvPr id="6" name="Footer Placeholder 5"/>
+          <p:cNvSpPr>
+            <a:spLocks noGrp="1"/>
+          </p:cNvSpPr>
+          <p:nvPr>
+            <p:ph type="ftr" sz="quarter" idx="4"/>
+          </p:nvPr>
+        </p:nvSpPr>
+        <p:spPr>
+          <a:xfrm>
+            <a:off x="0" y="8685213"/>
+            <a:ext cx="2971800" cy="458787"/>
+          </a:xfrm>
+          <a:prstGeom prst="rect">
+            <a:avLst/>
+          </a:prstGeom>
+        </p:spPr>
+        <p:txBody>
+          <a:bodyPr vert="horz" lIns="91440" tIns="45720" rIns="91440" bIns="45720" rtlCol="0" anchor="b"/>
+          <a:lstStyle>
+            <a:lvl1pPr algn="l">
+              <a:defRPr sz="1200"/>
+            </a:lvl1pPr>
+          </a:lstStyle>
+          <a:p>
+            <a:endParaRPr lang="en-US"/>
+          </a:p>
+        </p:txBody>
+      </p:sp>
+      <p:sp>
+        <p:nvSpPr>
+          <p:cNvPr id="7" name="Slide Number Placeholder 6"/>
+          <p:cNvSpPr>
+            <a:spLocks noGrp="1"/>
+          </p:cNvSpPr>
+          <p:nvPr>
+            <p:ph type="sldNum" sz="quarter" idx="5"/>
+          </p:nvPr>
+        </p:nvSpPr>
+        <p:spPr>
+          <a:xfrm>
+            <a:off x="3884613" y="8685213"/>
+            <a:ext cx="2971800" cy="458787"/>
+          </a:xfrm>
+          <a:prstGeom prst="rect">
+            <a:avLst/>
+          </a:prstGeom>
+        </p:spPr>
+        <p:txBody>
+          <a:bodyPr vert="horz" lIns="91440" tIns="45720" rIns="91440" bIns="45720" rtlCol="0" anchor="b"/>
+          <a:lstStyle>
+            <a:lvl1pPr algn="r">
+              <a:defRPr sz="1200"/>
+            </a:lvl1pPr>
+          </a:lstStyle>
+          <a:p>
+            <a:fld id="{CE5E9CC1-C706-0F49-92D6-E571CC5EEA8F}" type="slidenum">
+              <a:rPr lang="en-US"/>
+              <a:t>‹#›</a:t>
+            </a:fld>
+            <a:endParaRPr lang="en-US"/>
+          </a:p>
+        </p:txBody>
+      </p:sp>
     </p:spTree>
     <p:extLst>
       <p:ext uri="{BB962C8B-B14F-4D97-AF65-F5344CB8AC3E}">
-        <p14:creationId xmlns:p14="http://schemas.microsoft.com/office/powerpoint/2010/main" val="692931839"/>
+        <p14:creationId xmlns:p14="http://schemas.microsoft.com/office/powerpoint/2010/main" val="1024086991"/>
       </p:ext>
     </p:extLst>
   </p:cSld>
@@ -300,6 +519,7 @@
               <a:rPr lang="en-US" dirty="0"/>
               <a:t>Assalomu alaykum! Biz 404 Found jamoasimiz. Bugun sizga InvenTrack — tashkilotdagi kompyuter va texnik vositalarni elektron hisobga olish tizimini taqdim etamiz. Shiorimiz: har bir jihoz hisobda, har bir o'zgarish tarixda.</a:t>
             </a:r>
+            <a:endParaRPr lang="en-US" dirty="0"/>
           </a:p>
         </p:txBody>
       </p:sp>
@@ -387,6 +607,7 @@
               <a:rPr lang="en-US" dirty="0"/>
               <a:t>Uch rol: Administrator hamma narsani boshqaradi, Mas'ul shaxs o'z jihozlarini yangilaydi, Xodim faqat ko'ra oladi. Ruxsatlar serverda tekshiriladi.</a:t>
             </a:r>
+            <a:endParaRPr lang="en-US" dirty="0"/>
           </a:p>
         </p:txBody>
       </p:sp>
@@ -474,6 +695,7 @@
               <a:rPr lang="en-US" dirty="0"/>
               <a:t>Xavfsizlik bo'yicha: parollar bcrypt bilan hashlanadi; JWT qisqa muddatli; ruxsatlar frontendda emas, serverda tekshiriladi; barcha kirish ma'lumotlari Zod bilan tekshiriladi, Prisma parametrlangan so'rovlar ishlatadi; Helmet, CORS va login urinishlari cheklanadi; barcha o'zgarishlar tarixga yoziladi; kalitlar kodda emas, .env faylida.</a:t>
             </a:r>
+            <a:endParaRPr lang="en-US" dirty="0"/>
           </a:p>
         </p:txBody>
       </p:sp>
@@ -561,6 +783,7 @@
               <a:rPr lang="en-US" dirty="0"/>
               <a:t>Frontend React va TypeScript, backend Node.js va Express, ma'lumotlar bazasi PostgreSQL, Prisma ORM orqali. Markazda equipment jadvali, unga turlar, xonalar, ta'mirlar va tarix bog'langan.</a:t>
             </a:r>
+            <a:endParaRPr lang="en-US" dirty="0"/>
           </a:p>
         </p:txBody>
       </p:sp>
@@ -648,6 +871,7 @@
               <a:rPr lang="en-US" dirty="0"/>
               <a:t>Hisobotni xona, bo'lim, tur va holat bo'yicha filtrlash mumkin. Natija Excel yoki PDF'ga yuklanadi, chop etishga qulay ko'rinishi ham bor.</a:t>
             </a:r>
+            <a:endParaRPr lang="en-US" dirty="0"/>
           </a:p>
         </p:txBody>
       </p:sp>
@@ -735,6 +959,7 @@
               <a:rPr lang="en-US" dirty="0"/>
               <a:t>Natijada tashkilot jihozlarining yagona, xavfsiz va yangilanib turadigan hisobi paydo bo'ladi. Kelajakda QR skaner, bildirishnomalar va mobil ilova qo'shishni rejalashtirganmiz.</a:t>
             </a:r>
+            <a:endParaRPr lang="en-US" dirty="0"/>
           </a:p>
         </p:txBody>
       </p:sp>
@@ -822,6 +1047,7 @@
               <a:rPr lang="en-US" dirty="0"/>
               <a:t>Jamoamiz 404 Found: dasturlash, dizayn va ma'lumotlar bo'yicha mutaxassislar. Biz tizimni pilot sifatida bitta bo'limda sinab ko'rishga tayyormiz.</a:t>
             </a:r>
+            <a:endParaRPr lang="en-US" dirty="0"/>
           </a:p>
         </p:txBody>
       </p:sp>
@@ -909,6 +1135,7 @@
               <a:rPr lang="en-US" dirty="0"/>
               <a:t>E'tiboringiz uchun rahmat! Savollaringiz bo'lsa, javob beramiz.</a:t>
             </a:r>
+            <a:endParaRPr lang="en-US" dirty="0"/>
           </a:p>
         </p:txBody>
       </p:sp>
@@ -996,6 +1223,7 @@
               <a:rPr lang="en-US" dirty="0"/>
               <a:t>Ko'pchilik tashkilotlarda jihozlar qog'oz yoki Excel'da yuritiladi. Natijada ma'lumot eskiradi, texnika yo'qoladi, inventarizatsiya esa juda ko'p vaqt oladi.</a:t>
             </a:r>
+            <a:endParaRPr lang="en-US" dirty="0"/>
           </a:p>
         </p:txBody>
       </p:sp>
@@ -1083,6 +1311,7 @@
               <a:rPr lang="en-US" dirty="0"/>
               <a:t>Maqsadimiz — jihozlarni bitta web-tizimda hisobga olish. Yechim: yagona baza, avtomatik inventar raqam, to'liq tarix va tez hisobot.</a:t>
             </a:r>
+            <a:endParaRPr lang="en-US" dirty="0"/>
           </a:p>
         </p:txBody>
       </p:sp>
@@ -1170,6 +1399,7 @@
               <a:rPr lang="en-US" dirty="0"/>
               <a:t>Funksiyalarni to'rt guruhga ajratdik: hisobga olish, joylashuv va mas'ul, holat va ta'mir, tarix va hisobot.</a:t>
             </a:r>
+            <a:endParaRPr lang="en-US" dirty="0"/>
           </a:p>
         </p:txBody>
       </p:sp>
@@ -1257,6 +1487,7 @@
               <a:rPr lang="en-US" dirty="0"/>
               <a:t>Tizim yettita asosiy jihoz turini qo'llab-quvvatlaydi. Administrator istalgan vaqtda yangi tur qo'sha oladi.</a:t>
             </a:r>
+            <a:endParaRPr lang="en-US" dirty="0"/>
           </a:p>
         </p:txBody>
       </p:sp>
@@ -1344,6 +1575,7 @@
               <a:rPr lang="en-US" dirty="0"/>
               <a:t>Jarayon: foydalanuvchi kiradi, jihoz qo'shiladi va avtomatik raqam oladi, xona va mas'ulga biriktiriladi, holati yangilanadi, oxirida hisobot olinadi. Har bir qadam tarixga yoziladi.</a:t>
             </a:r>
+            <a:endParaRPr lang="en-US" dirty="0"/>
           </a:p>
         </p:txBody>
       </p:sp>
@@ -1429,8 +1661,9 @@
           <a:p>
             <a:r>
               <a:rPr lang="en-US" dirty="0"/>
-              <a:t>Bu ekranlarning maketi. Ilova tayyor bo'lgach, shu yerga haqiqiy skrinshotlar qo'yiladi. Dashboard, ro'yxat, kartochka va forma.</a:t>
-            </a:r>
+              <a:t>Bu ilovaning haqiqiy skrinshotlari: dashboard, jihozlar ro'yxati, jihoz kartochkasi QR-kod va tarix bilan, hamda qo'shish formasi. Ma'lumotlar sinov uchun.</a:t>
+            </a:r>
+            <a:endParaRPr lang="en-US" dirty="0"/>
           </a:p>
         </p:txBody>
       </p:sp>
@@ -1518,6 +1751,7 @@
               <a:rPr lang="en-US" dirty="0"/>
               <a:t>Bu bitta jihozning tarixi: kim, qachon, nima o'zgargani yozilgan. Misol uchun sinov ma'lumotlari ishlatilgan. Tarix yozuvlari o'zgartirilmaydi.</a:t>
             </a:r>
+            <a:endParaRPr lang="en-US" dirty="0"/>
           </a:p>
         </p:txBody>
       </p:sp>
@@ -1605,6 +1839,7 @@
               <a:rPr lang="en-US" dirty="0"/>
               <a:t>Tizimga AI yordamchi qo'shiladi: foydalanuvchi oddiy o'zbek tilida savol beradi, masalan qaysi bo'limda nosoz jihoz ko'p. Agent faqat oldindan belgilangan xavfsiz asboblarni chaqiradi, bazani o'zgartira olmaydi va foydalanuvchi roliga ko'ra ma'lumot oladi. Model OpenRouter orqali bepul modellar zanjiri bilan ishlaydi, biri javob bermasa keyingisi ishga tushadi.</a:t>
             </a:r>
+            <a:endParaRPr lang="en-US" dirty="0"/>
           </a:p>
         </p:txBody>
       </p:sp>
@@ -1677,11 +1912,6 @@
 <file path=ppt/slideMasters/slideMaster1.xml><?xml version="1.0" encoding="utf-8"?>
 <p:sldMaster xmlns:a="http://schemas.openxmlformats.org/drawingml/2006/main" xmlns:r="http://schemas.openxmlformats.org/officeDocument/2006/relationships" xmlns:p="http://schemas.openxmlformats.org/presentationml/2006/main">
   <p:cSld>
-    <p:bg>
-      <p:bgRef idx="1001">
-        <a:schemeClr val="bg1"/>
-      </p:bgRef>
-    </p:bg>
     <p:spTree>
       <p:nvGrpSpPr>
         <p:cNvPr id="1" name=""/>
@@ -1964,7 +2194,6 @@
         <a:solidFill>
           <a:srgbClr val="0B3C49"/>
         </a:solidFill>
-        <a:effectLst/>
       </p:bgPr>
     </p:bg>
     <p:spTree>
@@ -2058,14 +2287,14 @@
       </p:sp>
       <p:pic>
         <p:nvPicPr>
-          <p:cNvPr id="5" name="Image 0" descr="preencoded.png"/>
+          <p:cNvPr id="5" name="Image 0" descr="preencoded.png">    </p:cNvPr>
           <p:cNvPicPr>
             <a:picLocks noChangeAspect="1"/>
           </p:cNvPicPr>
           <p:nvPr/>
         </p:nvPicPr>
         <p:blipFill>
-          <a:blip r:embed="rId3"/>
+          <a:blip r:embed="rId1"/>
           <a:stretch>
             <a:fillRect/>
           </a:stretch>
@@ -2101,7 +2330,7 @@
           <a:bodyPr wrap="square" lIns="0" tIns="0" rIns="0" bIns="0" rtlCol="0" anchor="ctr"/>
           <a:lstStyle/>
           <a:p>
-            <a:pPr marL="0" indent="0">
+            <a:pPr indent="0" marL="0">
               <a:buNone/>
             </a:pPr>
             <a:r>
@@ -2140,7 +2369,7 @@
           <a:bodyPr wrap="square" lIns="0" tIns="0" rIns="0" bIns="0" rtlCol="0" anchor="ctr"/>
           <a:lstStyle/>
           <a:p>
-            <a:pPr marL="0" indent="0">
+            <a:pPr indent="0" marL="0">
               <a:buNone/>
             </a:pPr>
             <a:r>
@@ -2179,7 +2408,7 @@
           <a:bodyPr wrap="square" lIns="0" tIns="0" rIns="0" bIns="0" rtlCol="0" anchor="ctr"/>
           <a:lstStyle/>
           <a:p>
-            <a:pPr marL="0" indent="0">
+            <a:pPr indent="0" marL="0">
               <a:buNone/>
             </a:pPr>
             <a:r>
@@ -2196,11 +2425,11 @@
             <a:endParaRPr lang="en-US" sz="1600" dirty="0"/>
           </a:p>
           <a:p>
-            <a:pPr marL="0" indent="0">
-              <a:buNone/>
-            </a:pPr>
-            <a:r>
-              <a:rPr lang="en-US" sz="1600" dirty="0" err="1">
+            <a:pPr indent="0" marL="0">
+              <a:buNone/>
+            </a:pPr>
+            <a:r>
+              <a:rPr lang="en-US" sz="1600" dirty="0">
                 <a:solidFill>
                   <a:srgbClr val="FFFFFF"/>
                 </a:solidFill>
@@ -2208,18 +2437,7 @@
                 <a:ea typeface="Calibri" pitchFamily="34" charset="-122"/>
                 <a:cs typeface="Calibri" pitchFamily="34" charset="-120"/>
               </a:rPr>
-              <a:t>A'zo</a:t>
-            </a:r>
-            <a:r>
-              <a:rPr lang="en-US" sz="1600" dirty="0">
-                <a:solidFill>
-                  <a:srgbClr val="FFFFFF"/>
-                </a:solidFill>
-                <a:latin typeface="Calibri" pitchFamily="34" charset="0"/>
-                <a:ea typeface="Calibri" pitchFamily="34" charset="-122"/>
-                <a:cs typeface="Calibri" pitchFamily="34" charset="-120"/>
-              </a:rPr>
-              <a:t> 1  ·  A'zo 2  ·  A'zo 3  ·  A'zo 4</a:t>
+              <a:t>A'zo 1  ·  A'zo 2  ·  A'zo 3  ·  A'zo 4</a:t>
             </a:r>
             <a:endParaRPr lang="en-US" sz="1600" dirty="0"/>
           </a:p>
@@ -2241,7 +2459,6 @@
         <a:solidFill>
           <a:srgbClr val="FFFFFF"/>
         </a:solidFill>
-        <a:effectLst/>
       </p:bgPr>
     </p:bg>
     <p:spTree>
@@ -2279,7 +2496,7 @@
           <a:bodyPr wrap="square" lIns="0" tIns="0" rIns="0" bIns="0" rtlCol="0" anchor="ctr"/>
           <a:lstStyle/>
           <a:p>
-            <a:pPr marL="0" indent="0">
+            <a:pPr indent="0" marL="0">
               <a:buNone/>
             </a:pPr>
             <a:r>
@@ -2351,14 +2568,14 @@
       </p:sp>
       <p:pic>
         <p:nvPicPr>
-          <p:cNvPr id="5" name="Image 0" descr="preencoded.png"/>
+          <p:cNvPr id="5" name="Image 0" descr="preencoded.png">    </p:cNvPr>
           <p:cNvPicPr>
             <a:picLocks noChangeAspect="1"/>
           </p:cNvPicPr>
           <p:nvPr/>
         </p:nvPicPr>
         <p:blipFill>
-          <a:blip r:embed="rId3"/>
+          <a:blip r:embed="rId1"/>
           <a:stretch>
             <a:fillRect/>
           </a:stretch>
@@ -2394,7 +2611,7 @@
           <a:bodyPr wrap="square" lIns="0" tIns="0" rIns="0" bIns="0" rtlCol="0" anchor="ctr"/>
           <a:lstStyle/>
           <a:p>
-            <a:pPr marL="0" indent="0" algn="ctr">
+            <a:pPr algn="ctr" indent="0" marL="0">
               <a:buNone/>
             </a:pPr>
             <a:r>
@@ -2433,7 +2650,7 @@
           <a:bodyPr wrap="square" lIns="0" tIns="0" rIns="0" bIns="0" rtlCol="0" anchor="ctr"/>
           <a:lstStyle/>
           <a:p>
-            <a:pPr marL="0" indent="0" algn="ctr">
+            <a:pPr algn="ctr" indent="0" marL="0">
               <a:buNone/>
             </a:pPr>
             <a:r>
@@ -2505,14 +2722,14 @@
       </p:sp>
       <p:pic>
         <p:nvPicPr>
-          <p:cNvPr id="10" name="Image 1" descr="preencoded.png"/>
+          <p:cNvPr id="10" name="Image 1" descr="preencoded.png">    </p:cNvPr>
           <p:cNvPicPr>
             <a:picLocks noChangeAspect="1"/>
           </p:cNvPicPr>
           <p:nvPr/>
         </p:nvPicPr>
         <p:blipFill>
-          <a:blip r:embed="rId4"/>
+          <a:blip r:embed="rId2"/>
           <a:stretch>
             <a:fillRect/>
           </a:stretch>
@@ -2548,7 +2765,7 @@
           <a:bodyPr wrap="square" lIns="0" tIns="0" rIns="0" bIns="0" rtlCol="0" anchor="ctr"/>
           <a:lstStyle/>
           <a:p>
-            <a:pPr marL="0" indent="0" algn="ctr">
+            <a:pPr algn="ctr" indent="0" marL="0">
               <a:buNone/>
             </a:pPr>
             <a:r>
@@ -2587,7 +2804,7 @@
           <a:bodyPr wrap="square" lIns="0" tIns="0" rIns="0" bIns="0" rtlCol="0" anchor="ctr"/>
           <a:lstStyle/>
           <a:p>
-            <a:pPr marL="0" indent="0" algn="ctr">
+            <a:pPr algn="ctr" indent="0" marL="0">
               <a:buNone/>
             </a:pPr>
             <a:r>
@@ -2659,14 +2876,14 @@
       </p:sp>
       <p:pic>
         <p:nvPicPr>
-          <p:cNvPr id="15" name="Image 2" descr="preencoded.png"/>
+          <p:cNvPr id="15" name="Image 2" descr="preencoded.png">    </p:cNvPr>
           <p:cNvPicPr>
             <a:picLocks noChangeAspect="1"/>
           </p:cNvPicPr>
           <p:nvPr/>
         </p:nvPicPr>
         <p:blipFill>
-          <a:blip r:embed="rId5"/>
+          <a:blip r:embed="rId3"/>
           <a:stretch>
             <a:fillRect/>
           </a:stretch>
@@ -2702,7 +2919,7 @@
           <a:bodyPr wrap="square" lIns="0" tIns="0" rIns="0" bIns="0" rtlCol="0" anchor="ctr"/>
           <a:lstStyle/>
           <a:p>
-            <a:pPr marL="0" indent="0" algn="ctr">
+            <a:pPr algn="ctr" indent="0" marL="0">
               <a:buNone/>
             </a:pPr>
             <a:r>
@@ -2741,7 +2958,7 @@
           <a:bodyPr wrap="square" lIns="0" tIns="0" rIns="0" bIns="0" rtlCol="0" anchor="ctr"/>
           <a:lstStyle/>
           <a:p>
-            <a:pPr marL="0" indent="0" algn="ctr">
+            <a:pPr algn="ctr" indent="0" marL="0">
               <a:buNone/>
             </a:pPr>
             <a:r>
@@ -2775,7 +2992,6 @@
         <a:solidFill>
           <a:srgbClr val="0B3C49"/>
         </a:solidFill>
-        <a:effectLst/>
       </p:bgPr>
     </p:bg>
     <p:spTree>
@@ -2813,7 +3029,7 @@
           <a:bodyPr wrap="square" lIns="0" tIns="0" rIns="0" bIns="0" rtlCol="0" anchor="ctr"/>
           <a:lstStyle/>
           <a:p>
-            <a:pPr marL="0" indent="0">
+            <a:pPr indent="0" marL="0">
               <a:buNone/>
             </a:pPr>
             <a:r>
@@ -2885,14 +3101,14 @@
       </p:sp>
       <p:pic>
         <p:nvPicPr>
-          <p:cNvPr id="5" name="Image 0" descr="preencoded.png"/>
+          <p:cNvPr id="5" name="Image 0" descr="preencoded.png">    </p:cNvPr>
           <p:cNvPicPr>
             <a:picLocks noChangeAspect="1"/>
           </p:cNvPicPr>
           <p:nvPr/>
         </p:nvPicPr>
         <p:blipFill>
-          <a:blip r:embed="rId3"/>
+          <a:blip r:embed="rId1"/>
           <a:stretch>
             <a:fillRect/>
           </a:stretch>
@@ -2928,7 +3144,7 @@
           <a:bodyPr wrap="square" lIns="0" tIns="0" rIns="0" bIns="0" rtlCol="0" anchor="ctr"/>
           <a:lstStyle/>
           <a:p>
-            <a:pPr marL="0" indent="0">
+            <a:pPr indent="0" marL="0">
               <a:buNone/>
             </a:pPr>
             <a:r>
@@ -2967,7 +3183,7 @@
           <a:bodyPr wrap="square" lIns="0" tIns="0" rIns="0" bIns="0" rtlCol="0" anchor="ctr"/>
           <a:lstStyle/>
           <a:p>
-            <a:pPr marL="0" indent="0">
+            <a:pPr indent="0" marL="0">
               <a:buNone/>
             </a:pPr>
             <a:r>
@@ -3039,14 +3255,14 @@
       </p:sp>
       <p:pic>
         <p:nvPicPr>
-          <p:cNvPr id="10" name="Image 1" descr="preencoded.png"/>
+          <p:cNvPr id="10" name="Image 1" descr="preencoded.png">    </p:cNvPr>
           <p:cNvPicPr>
             <a:picLocks noChangeAspect="1"/>
           </p:cNvPicPr>
           <p:nvPr/>
         </p:nvPicPr>
         <p:blipFill>
-          <a:blip r:embed="rId4"/>
+          <a:blip r:embed="rId2"/>
           <a:stretch>
             <a:fillRect/>
           </a:stretch>
@@ -3082,7 +3298,7 @@
           <a:bodyPr wrap="square" lIns="0" tIns="0" rIns="0" bIns="0" rtlCol="0" anchor="ctr"/>
           <a:lstStyle/>
           <a:p>
-            <a:pPr marL="0" indent="0">
+            <a:pPr indent="0" marL="0">
               <a:buNone/>
             </a:pPr>
             <a:r>
@@ -3121,7 +3337,7 @@
           <a:bodyPr wrap="square" lIns="0" tIns="0" rIns="0" bIns="0" rtlCol="0" anchor="ctr"/>
           <a:lstStyle/>
           <a:p>
-            <a:pPr marL="0" indent="0">
+            <a:pPr indent="0" marL="0">
               <a:buNone/>
             </a:pPr>
             <a:r>
@@ -3193,14 +3409,14 @@
       </p:sp>
       <p:pic>
         <p:nvPicPr>
-          <p:cNvPr id="15" name="Image 2" descr="preencoded.png"/>
+          <p:cNvPr id="15" name="Image 2" descr="preencoded.png">    </p:cNvPr>
           <p:cNvPicPr>
             <a:picLocks noChangeAspect="1"/>
           </p:cNvPicPr>
           <p:nvPr/>
         </p:nvPicPr>
         <p:blipFill>
-          <a:blip r:embed="rId5"/>
+          <a:blip r:embed="rId3"/>
           <a:stretch>
             <a:fillRect/>
           </a:stretch>
@@ -3236,7 +3452,7 @@
           <a:bodyPr wrap="square" lIns="0" tIns="0" rIns="0" bIns="0" rtlCol="0" anchor="ctr"/>
           <a:lstStyle/>
           <a:p>
-            <a:pPr marL="0" indent="0">
+            <a:pPr indent="0" marL="0">
               <a:buNone/>
             </a:pPr>
             <a:r>
@@ -3275,7 +3491,7 @@
           <a:bodyPr wrap="square" lIns="0" tIns="0" rIns="0" bIns="0" rtlCol="0" anchor="ctr"/>
           <a:lstStyle/>
           <a:p>
-            <a:pPr marL="0" indent="0">
+            <a:pPr indent="0" marL="0">
               <a:buNone/>
             </a:pPr>
             <a:r>
@@ -3347,14 +3563,14 @@
       </p:sp>
       <p:pic>
         <p:nvPicPr>
-          <p:cNvPr id="20" name="Image 3" descr="preencoded.png"/>
+          <p:cNvPr id="20" name="Image 3" descr="preencoded.png">    </p:cNvPr>
           <p:cNvPicPr>
             <a:picLocks noChangeAspect="1"/>
           </p:cNvPicPr>
           <p:nvPr/>
         </p:nvPicPr>
         <p:blipFill>
-          <a:blip r:embed="rId6"/>
+          <a:blip r:embed="rId4"/>
           <a:stretch>
             <a:fillRect/>
           </a:stretch>
@@ -3390,7 +3606,7 @@
           <a:bodyPr wrap="square" lIns="0" tIns="0" rIns="0" bIns="0" rtlCol="0" anchor="ctr"/>
           <a:lstStyle/>
           <a:p>
-            <a:pPr marL="0" indent="0">
+            <a:pPr indent="0" marL="0">
               <a:buNone/>
             </a:pPr>
             <a:r>
@@ -3429,7 +3645,7 @@
           <a:bodyPr wrap="square" lIns="0" tIns="0" rIns="0" bIns="0" rtlCol="0" anchor="ctr"/>
           <a:lstStyle/>
           <a:p>
-            <a:pPr marL="0" indent="0">
+            <a:pPr indent="0" marL="0">
               <a:buNone/>
             </a:pPr>
             <a:r>
@@ -3501,14 +3717,14 @@
       </p:sp>
       <p:pic>
         <p:nvPicPr>
-          <p:cNvPr id="25" name="Image 4" descr="preencoded.png"/>
+          <p:cNvPr id="25" name="Image 4" descr="preencoded.png">    </p:cNvPr>
           <p:cNvPicPr>
             <a:picLocks noChangeAspect="1"/>
           </p:cNvPicPr>
           <p:nvPr/>
         </p:nvPicPr>
         <p:blipFill>
-          <a:blip r:embed="rId7"/>
+          <a:blip r:embed="rId5"/>
           <a:stretch>
             <a:fillRect/>
           </a:stretch>
@@ -3544,7 +3760,7 @@
           <a:bodyPr wrap="square" lIns="0" tIns="0" rIns="0" bIns="0" rtlCol="0" anchor="ctr"/>
           <a:lstStyle/>
           <a:p>
-            <a:pPr marL="0" indent="0">
+            <a:pPr indent="0" marL="0">
               <a:buNone/>
             </a:pPr>
             <a:r>
@@ -3583,7 +3799,7 @@
           <a:bodyPr wrap="square" lIns="0" tIns="0" rIns="0" bIns="0" rtlCol="0" anchor="ctr"/>
           <a:lstStyle/>
           <a:p>
-            <a:pPr marL="0" indent="0">
+            <a:pPr indent="0" marL="0">
               <a:buNone/>
             </a:pPr>
             <a:r>
@@ -3655,14 +3871,14 @@
       </p:sp>
       <p:pic>
         <p:nvPicPr>
-          <p:cNvPr id="30" name="Image 5" descr="preencoded.png"/>
+          <p:cNvPr id="30" name="Image 5" descr="preencoded.png">    </p:cNvPr>
           <p:cNvPicPr>
             <a:picLocks noChangeAspect="1"/>
           </p:cNvPicPr>
           <p:nvPr/>
         </p:nvPicPr>
         <p:blipFill>
-          <a:blip r:embed="rId8"/>
+          <a:blip r:embed="rId6"/>
           <a:stretch>
             <a:fillRect/>
           </a:stretch>
@@ -3698,7 +3914,7 @@
           <a:bodyPr wrap="square" lIns="0" tIns="0" rIns="0" bIns="0" rtlCol="0" anchor="ctr"/>
           <a:lstStyle/>
           <a:p>
-            <a:pPr marL="0" indent="0">
+            <a:pPr indent="0" marL="0">
               <a:buNone/>
             </a:pPr>
             <a:r>
@@ -3737,7 +3953,7 @@
           <a:bodyPr wrap="square" lIns="0" tIns="0" rIns="0" bIns="0" rtlCol="0" anchor="ctr"/>
           <a:lstStyle/>
           <a:p>
-            <a:pPr marL="0" indent="0">
+            <a:pPr indent="0" marL="0">
               <a:buNone/>
             </a:pPr>
             <a:r>
@@ -3771,7 +3987,6 @@
         <a:solidFill>
           <a:srgbClr val="FFFFFF"/>
         </a:solidFill>
-        <a:effectLst/>
       </p:bgPr>
     </p:bg>
     <p:spTree>
@@ -3809,7 +4024,7 @@
           <a:bodyPr wrap="square" lIns="0" tIns="0" rIns="0" bIns="0" rtlCol="0" anchor="ctr"/>
           <a:lstStyle/>
           <a:p>
-            <a:pPr marL="0" indent="0">
+            <a:pPr indent="0" marL="0">
               <a:buNone/>
             </a:pPr>
             <a:r>
@@ -3875,7 +4090,7 @@
           <a:bodyPr wrap="square" lIns="0" tIns="0" rIns="0" bIns="0" rtlCol="0" anchor="ctr"/>
           <a:lstStyle/>
           <a:p>
-            <a:pPr marL="0" indent="0">
+            <a:pPr indent="0" marL="0">
               <a:buNone/>
             </a:pPr>
             <a:r>
@@ -3914,7 +4129,7 @@
           <a:bodyPr wrap="square" lIns="0" tIns="0" rIns="0" bIns="0" rtlCol="0" anchor="ctr"/>
           <a:lstStyle/>
           <a:p>
-            <a:pPr marL="0" indent="0">
+            <a:pPr indent="0" marL="0">
               <a:buNone/>
             </a:pPr>
             <a:r>
@@ -3980,7 +4195,7 @@
           <a:bodyPr wrap="square" lIns="0" tIns="0" rIns="0" bIns="0" rtlCol="0" anchor="ctr"/>
           <a:lstStyle/>
           <a:p>
-            <a:pPr marL="0" indent="0">
+            <a:pPr indent="0" marL="0">
               <a:buNone/>
             </a:pPr>
             <a:r>
@@ -4019,7 +4234,7 @@
           <a:bodyPr wrap="square" lIns="0" tIns="0" rIns="0" bIns="0" rtlCol="0" anchor="ctr"/>
           <a:lstStyle/>
           <a:p>
-            <a:pPr marL="0" indent="0">
+            <a:pPr indent="0" marL="0">
               <a:buNone/>
             </a:pPr>
             <a:r>
@@ -4085,7 +4300,7 @@
           <a:bodyPr wrap="square" lIns="0" tIns="0" rIns="0" bIns="0" rtlCol="0" anchor="ctr"/>
           <a:lstStyle/>
           <a:p>
-            <a:pPr marL="0" indent="0">
+            <a:pPr indent="0" marL="0">
               <a:buNone/>
             </a:pPr>
             <a:r>
@@ -4124,7 +4339,7 @@
           <a:bodyPr wrap="square" lIns="0" tIns="0" rIns="0" bIns="0" rtlCol="0" anchor="ctr"/>
           <a:lstStyle/>
           <a:p>
-            <a:pPr marL="0" indent="0">
+            <a:pPr indent="0" marL="0">
               <a:buNone/>
             </a:pPr>
             <a:r>
@@ -4190,7 +4405,7 @@
           <a:bodyPr wrap="square" lIns="0" tIns="0" rIns="0" bIns="0" rtlCol="0" anchor="ctr"/>
           <a:lstStyle/>
           <a:p>
-            <a:pPr marL="0" indent="0">
+            <a:pPr indent="0" marL="0">
               <a:buNone/>
             </a:pPr>
             <a:r>
@@ -4229,7 +4444,7 @@
           <a:bodyPr wrap="square" lIns="0" tIns="0" rIns="0" bIns="0" rtlCol="0" anchor="ctr"/>
           <a:lstStyle/>
           <a:p>
-            <a:pPr marL="0" indent="0">
+            <a:pPr indent="0" marL="0">
               <a:buNone/>
             </a:pPr>
             <a:r>
@@ -4295,7 +4510,7 @@
           <a:bodyPr wrap="square" lIns="0" tIns="0" rIns="0" bIns="0" rtlCol="0" anchor="ctr"/>
           <a:lstStyle/>
           <a:p>
-            <a:pPr marL="0" indent="0">
+            <a:pPr indent="0" marL="0">
               <a:buNone/>
             </a:pPr>
             <a:r>
@@ -4334,7 +4549,7 @@
           <a:bodyPr wrap="square" lIns="0" tIns="0" rIns="0" bIns="0" rtlCol="0" anchor="ctr"/>
           <a:lstStyle/>
           <a:p>
-            <a:pPr marL="0" indent="0">
+            <a:pPr indent="0" marL="0">
               <a:buNone/>
             </a:pPr>
             <a:r>
@@ -4400,7 +4615,7 @@
           <a:bodyPr wrap="square" lIns="0" tIns="0" rIns="0" bIns="0" rtlCol="0" anchor="ctr"/>
           <a:lstStyle/>
           <a:p>
-            <a:pPr marL="0" indent="0" algn="ctr">
+            <a:pPr algn="ctr" indent="0" marL="0">
               <a:buNone/>
             </a:pPr>
             <a:r>
@@ -4466,7 +4681,7 @@
           <a:bodyPr wrap="square" lIns="0" tIns="0" rIns="0" bIns="0" rtlCol="0" anchor="ctr"/>
           <a:lstStyle/>
           <a:p>
-            <a:pPr marL="0" indent="0" algn="ctr">
+            <a:pPr algn="ctr" indent="0" marL="0">
               <a:buNone/>
             </a:pPr>
             <a:r>
@@ -4532,7 +4747,7 @@
           <a:bodyPr wrap="square" lIns="0" tIns="0" rIns="0" bIns="0" rtlCol="0" anchor="ctr"/>
           <a:lstStyle/>
           <a:p>
-            <a:pPr marL="0" indent="0" algn="ctr">
+            <a:pPr algn="ctr" indent="0" marL="0">
               <a:buNone/>
             </a:pPr>
             <a:r>
@@ -4598,7 +4813,7 @@
           <a:bodyPr wrap="square" lIns="0" tIns="0" rIns="0" bIns="0" rtlCol="0" anchor="ctr"/>
           <a:lstStyle/>
           <a:p>
-            <a:pPr marL="0" indent="0" algn="ctr">
+            <a:pPr algn="ctr" indent="0" marL="0">
               <a:buNone/>
             </a:pPr>
             <a:r>
@@ -4664,7 +4879,7 @@
           <a:bodyPr wrap="square" lIns="0" tIns="0" rIns="0" bIns="0" rtlCol="0" anchor="ctr"/>
           <a:lstStyle/>
           <a:p>
-            <a:pPr marL="0" indent="0" algn="ctr">
+            <a:pPr algn="ctr" indent="0" marL="0">
               <a:buNone/>
             </a:pPr>
             <a:r>
@@ -4730,7 +4945,7 @@
           <a:bodyPr wrap="square" lIns="0" tIns="0" rIns="0" bIns="0" rtlCol="0" anchor="ctr"/>
           <a:lstStyle/>
           <a:p>
-            <a:pPr marL="0" indent="0" algn="ctr">
+            <a:pPr algn="ctr" indent="0" marL="0">
               <a:buNone/>
             </a:pPr>
             <a:r>
@@ -4796,7 +5011,7 @@
           <a:bodyPr wrap="square" lIns="0" tIns="0" rIns="0" bIns="0" rtlCol="0" anchor="ctr"/>
           <a:lstStyle/>
           <a:p>
-            <a:pPr marL="0" indent="0" algn="ctr">
+            <a:pPr algn="ctr" indent="0" marL="0">
               <a:buNone/>
             </a:pPr>
             <a:r>
@@ -4830,7 +5045,6 @@
         <a:solidFill>
           <a:srgbClr val="FFFFFF"/>
         </a:solidFill>
-        <a:effectLst/>
       </p:bgPr>
     </p:bg>
     <p:spTree>
@@ -4868,7 +5082,7 @@
           <a:bodyPr wrap="square" lIns="0" tIns="0" rIns="0" bIns="0" rtlCol="0" anchor="ctr"/>
           <a:lstStyle/>
           <a:p>
-            <a:pPr marL="0" indent="0">
+            <a:pPr indent="0" marL="0">
               <a:buNone/>
             </a:pPr>
             <a:r>
@@ -4895,7 +5109,7 @@
         <p:spPr>
           <a:xfrm>
             <a:off x="548640" y="1371600"/>
-            <a:ext cx="1143000" cy="457200"/>
+            <a:ext cx="1005840" cy="457200"/>
           </a:xfrm>
           <a:prstGeom prst="roundRect">
             <a:avLst>
@@ -4922,19 +5136,19 @@
         <p:spPr>
           <a:xfrm>
             <a:off x="548640" y="1371600"/>
-            <a:ext cx="1143000" cy="457200"/>
-          </a:xfrm>
-          <a:prstGeom prst="rect">
-            <a:avLst/>
-          </a:prstGeom>
-          <a:noFill/>
-          <a:ln/>
-        </p:spPr>
-        <p:txBody>
-          <a:bodyPr wrap="square" lIns="0" tIns="0" rIns="0" bIns="0" rtlCol="0" anchor="ctr"/>
-          <a:lstStyle/>
-          <a:p>
-            <a:pPr marL="0" indent="0" algn="ctr">
+            <a:ext cx="1005840" cy="457200"/>
+          </a:xfrm>
+          <a:prstGeom prst="rect">
+            <a:avLst/>
+          </a:prstGeom>
+          <a:noFill/>
+          <a:ln/>
+        </p:spPr>
+        <p:txBody>
+          <a:bodyPr wrap="square" lIns="0" tIns="0" rIns="0" bIns="0" rtlCol="0" anchor="ctr"/>
+          <a:lstStyle/>
+          <a:p>
+            <a:pPr algn="ctr" indent="0" marL="0">
               <a:buNone/>
             </a:pPr>
             <a:r>
@@ -4960,8 +5174,8 @@
         </p:nvSpPr>
         <p:spPr>
           <a:xfrm>
-            <a:off x="1783080" y="1371600"/>
-            <a:ext cx="1143000" cy="457200"/>
+            <a:off x="1645920" y="1371600"/>
+            <a:ext cx="1005840" cy="457200"/>
           </a:xfrm>
           <a:prstGeom prst="roundRect">
             <a:avLst>
@@ -4987,20 +5201,20 @@
         </p:nvSpPr>
         <p:spPr>
           <a:xfrm>
-            <a:off x="1783080" y="1371600"/>
-            <a:ext cx="1143000" cy="457200"/>
-          </a:xfrm>
-          <a:prstGeom prst="rect">
-            <a:avLst/>
-          </a:prstGeom>
-          <a:noFill/>
-          <a:ln/>
-        </p:spPr>
-        <p:txBody>
-          <a:bodyPr wrap="square" lIns="0" tIns="0" rIns="0" bIns="0" rtlCol="0" anchor="ctr"/>
-          <a:lstStyle/>
-          <a:p>
-            <a:pPr marL="0" indent="0" algn="ctr">
+            <a:off x="1645920" y="1371600"/>
+            <a:ext cx="1005840" cy="457200"/>
+          </a:xfrm>
+          <a:prstGeom prst="rect">
+            <a:avLst/>
+          </a:prstGeom>
+          <a:noFill/>
+          <a:ln/>
+        </p:spPr>
+        <p:txBody>
+          <a:bodyPr wrap="square" lIns="0" tIns="0" rIns="0" bIns="0" rtlCol="0" anchor="ctr"/>
+          <a:lstStyle/>
+          <a:p>
+            <a:pPr algn="ctr" indent="0" marL="0">
               <a:buNone/>
             </a:pPr>
             <a:r>
@@ -5026,8 +5240,8 @@
         </p:nvSpPr>
         <p:spPr>
           <a:xfrm>
-            <a:off x="3017520" y="1371600"/>
-            <a:ext cx="1143000" cy="457200"/>
+            <a:off x="548640" y="1920240"/>
+            <a:ext cx="1005840" cy="457200"/>
           </a:xfrm>
           <a:prstGeom prst="roundRect">
             <a:avLst>
@@ -5053,20 +5267,20 @@
         </p:nvSpPr>
         <p:spPr>
           <a:xfrm>
-            <a:off x="3017520" y="1371600"/>
-            <a:ext cx="1143000" cy="457200"/>
-          </a:xfrm>
-          <a:prstGeom prst="rect">
-            <a:avLst/>
-          </a:prstGeom>
-          <a:noFill/>
-          <a:ln/>
-        </p:spPr>
-        <p:txBody>
-          <a:bodyPr wrap="square" lIns="0" tIns="0" rIns="0" bIns="0" rtlCol="0" anchor="ctr"/>
-          <a:lstStyle/>
-          <a:p>
-            <a:pPr marL="0" indent="0" algn="ctr">
+            <a:off x="548640" y="1920240"/>
+            <a:ext cx="1005840" cy="457200"/>
+          </a:xfrm>
+          <a:prstGeom prst="rect">
+            <a:avLst/>
+          </a:prstGeom>
+          <a:noFill/>
+          <a:ln/>
+        </p:spPr>
+        <p:txBody>
+          <a:bodyPr wrap="square" lIns="0" tIns="0" rIns="0" bIns="0" rtlCol="0" anchor="ctr"/>
+          <a:lstStyle/>
+          <a:p>
+            <a:pPr algn="ctr" indent="0" marL="0">
               <a:buNone/>
             </a:pPr>
             <a:r>
@@ -5092,8 +5306,8 @@
         </p:nvSpPr>
         <p:spPr>
           <a:xfrm>
-            <a:off x="4251960" y="1371600"/>
-            <a:ext cx="1143000" cy="457200"/>
+            <a:off x="1645920" y="1920240"/>
+            <a:ext cx="1005840" cy="457200"/>
           </a:xfrm>
           <a:prstGeom prst="roundRect">
             <a:avLst>
@@ -5119,20 +5333,20 @@
         </p:nvSpPr>
         <p:spPr>
           <a:xfrm>
-            <a:off x="4251960" y="1371600"/>
-            <a:ext cx="1143000" cy="457200"/>
-          </a:xfrm>
-          <a:prstGeom prst="rect">
-            <a:avLst/>
-          </a:prstGeom>
-          <a:noFill/>
-          <a:ln/>
-        </p:spPr>
-        <p:txBody>
-          <a:bodyPr wrap="square" lIns="0" tIns="0" rIns="0" bIns="0" rtlCol="0" anchor="ctr"/>
-          <a:lstStyle/>
-          <a:p>
-            <a:pPr marL="0" indent="0" algn="ctr">
+            <a:off x="1645920" y="1920240"/>
+            <a:ext cx="1005840" cy="457200"/>
+          </a:xfrm>
+          <a:prstGeom prst="rect">
+            <a:avLst/>
+          </a:prstGeom>
+          <a:noFill/>
+          <a:ln/>
+        </p:spPr>
+        <p:txBody>
+          <a:bodyPr wrap="square" lIns="0" tIns="0" rIns="0" bIns="0" rtlCol="0" anchor="ctr"/>
+          <a:lstStyle/>
+          <a:p>
+            <a:pPr algn="ctr" indent="0" marL="0">
               <a:buNone/>
             </a:pPr>
             <a:r>
@@ -5158,24 +5372,24 @@
         </p:nvSpPr>
         <p:spPr>
           <a:xfrm>
-            <a:off x="548640" y="2194560"/>
-            <a:ext cx="6400800" cy="457200"/>
-          </a:xfrm>
-          <a:prstGeom prst="rect">
-            <a:avLst/>
-          </a:prstGeom>
-          <a:noFill/>
-          <a:ln/>
-        </p:spPr>
-        <p:txBody>
-          <a:bodyPr wrap="square" lIns="0" tIns="0" rIns="0" bIns="0" rtlCol="0" anchor="ctr"/>
-          <a:lstStyle/>
-          <a:p>
-            <a:pPr marL="0" indent="0">
-              <a:buNone/>
-            </a:pPr>
-            <a:r>
-              <a:rPr lang="en-US" sz="2000" dirty="0">
+            <a:off x="548640" y="2514600"/>
+            <a:ext cx="4023360" cy="365760"/>
+          </a:xfrm>
+          <a:prstGeom prst="rect">
+            <a:avLst/>
+          </a:prstGeom>
+          <a:noFill/>
+          <a:ln/>
+        </p:spPr>
+        <p:txBody>
+          <a:bodyPr wrap="square" lIns="0" tIns="0" rIns="0" bIns="0" rtlCol="0" anchor="ctr"/>
+          <a:lstStyle/>
+          <a:p>
+            <a:pPr indent="0" marL="0">
+              <a:buNone/>
+            </a:pPr>
+            <a:r>
+              <a:rPr lang="en-US" sz="1600" dirty="0">
                 <a:solidFill>
                   <a:srgbClr val="0B3C49"/>
                 </a:solidFill>
@@ -5185,7 +5399,7 @@
               </a:rPr>
               <a:t>Filtrlang → ko'ring → yuklab oling</a:t>
             </a:r>
-            <a:endParaRPr lang="en-US" sz="2000" dirty="0"/>
+            <a:endParaRPr lang="en-US" sz="1600" dirty="0"/>
           </a:p>
         </p:txBody>
       </p:sp>
@@ -5197,8 +5411,56 @@
         </p:nvSpPr>
         <p:spPr>
           <a:xfrm>
-            <a:off x="548640" y="2926080"/>
-            <a:ext cx="1005840" cy="1005840"/>
+            <a:off x="4727448" y="1344168"/>
+            <a:ext cx="3895344" cy="2980944"/>
+          </a:xfrm>
+          <a:prstGeom prst="rect">
+            <a:avLst/>
+          </a:prstGeom>
+          <a:solidFill>
+            <a:srgbClr val="B8CED3"/>
+          </a:solidFill>
+          <a:ln w="12700">
+            <a:solidFill>
+              <a:srgbClr val="B8CED3"/>
+            </a:solidFill>
+            <a:prstDash val="solid"/>
+          </a:ln>
+        </p:spPr>
+      </p:sp>
+      <p:pic>
+        <p:nvPicPr>
+          <p:cNvPr id="13" name="Image 0" descr="screenshots/report.png">    </p:cNvPr>
+          <p:cNvPicPr>
+            <a:picLocks noChangeAspect="1"/>
+          </p:cNvPicPr>
+          <p:nvPr/>
+        </p:nvPicPr>
+        <p:blipFill>
+          <a:blip r:embed="rId1"/>
+          <a:srcRect l="0" r="0" t="0" b="0"/>
+          <a:stretch/>
+        </p:blipFill>
+        <p:spPr>
+          <a:xfrm>
+            <a:off x="4754880" y="1371600"/>
+            <a:ext cx="3840480" cy="2926080"/>
+          </a:xfrm>
+          <a:prstGeom prst="rect">
+            <a:avLst/>
+          </a:prstGeom>
+        </p:spPr>
+      </p:pic>
+      <p:sp>
+        <p:nvSpPr>
+          <p:cNvPr id="14" name="Shape 11"/>
+          <p:cNvSpPr/>
+          <p:nvPr/>
+        </p:nvSpPr>
+        <p:spPr>
+          <a:xfrm>
+            <a:off x="548640" y="3017520"/>
+            <a:ext cx="731520" cy="731520"/>
           </a:xfrm>
           <a:prstGeom prst="ellipse">
             <a:avLst/>
@@ -5216,22 +5478,22 @@
       </p:sp>
       <p:pic>
         <p:nvPicPr>
-          <p:cNvPr id="13" name="Image 0" descr="preencoded.png"/>
+          <p:cNvPr id="15" name="Image 1" descr="preencoded.png">    </p:cNvPr>
           <p:cNvPicPr>
             <a:picLocks noChangeAspect="1"/>
           </p:cNvPicPr>
           <p:nvPr/>
         </p:nvPicPr>
         <p:blipFill>
-          <a:blip r:embed="rId3"/>
+          <a:blip r:embed="rId2"/>
           <a:stretch>
             <a:fillRect/>
           </a:stretch>
         </p:blipFill>
         <p:spPr>
           <a:xfrm>
-            <a:off x="800100" y="3177540"/>
-            <a:ext cx="502920" cy="502920"/>
+            <a:off x="731520" y="3200400"/>
+            <a:ext cx="365760" cy="365760"/>
           </a:xfrm>
           <a:prstGeom prst="rect">
             <a:avLst/>
@@ -5240,30 +5502,30 @@
       </p:pic>
       <p:sp>
         <p:nvSpPr>
-          <p:cNvPr id="14" name="Text 11"/>
-          <p:cNvSpPr txBox="1"/>
-          <p:nvPr/>
-        </p:nvSpPr>
-        <p:spPr>
-          <a:xfrm>
-            <a:off x="1737360" y="2926080"/>
-            <a:ext cx="1828800" cy="1005840"/>
-          </a:xfrm>
-          <a:prstGeom prst="rect">
-            <a:avLst/>
-          </a:prstGeom>
-          <a:noFill/>
-          <a:ln/>
-        </p:spPr>
-        <p:txBody>
-          <a:bodyPr wrap="square" lIns="0" tIns="0" rIns="0" bIns="0" rtlCol="0" anchor="ctr"/>
-          <a:lstStyle/>
-          <a:p>
-            <a:pPr marL="0" indent="0">
-              <a:buNone/>
-            </a:pPr>
-            <a:r>
-              <a:rPr lang="en-US" sz="2000" b="1" dirty="0">
+          <p:cNvPr id="16" name="Text 12"/>
+          <p:cNvSpPr txBox="1"/>
+          <p:nvPr/>
+        </p:nvSpPr>
+        <p:spPr>
+          <a:xfrm>
+            <a:off x="1463040" y="3017520"/>
+            <a:ext cx="2286000" cy="731520"/>
+          </a:xfrm>
+          <a:prstGeom prst="rect">
+            <a:avLst/>
+          </a:prstGeom>
+          <a:noFill/>
+          <a:ln/>
+        </p:spPr>
+        <p:txBody>
+          <a:bodyPr wrap="square" lIns="0" tIns="0" rIns="0" bIns="0" rtlCol="0" anchor="ctr"/>
+          <a:lstStyle/>
+          <a:p>
+            <a:pPr indent="0" marL="0">
+              <a:buNone/>
+            </a:pPr>
+            <a:r>
+              <a:rPr lang="en-US" sz="1600" b="1" dirty="0">
                 <a:solidFill>
                   <a:srgbClr val="0B3C49"/>
                 </a:solidFill>
@@ -5273,20 +5535,20 @@
               </a:rPr>
               <a:t>Excel (.xlsx)</a:t>
             </a:r>
-            <a:endParaRPr lang="en-US" sz="2000" dirty="0"/>
-          </a:p>
-        </p:txBody>
-      </p:sp>
-      <p:sp>
-        <p:nvSpPr>
-          <p:cNvPr id="15" name="Shape 12"/>
+            <a:endParaRPr lang="en-US" sz="1600" dirty="0"/>
+          </a:p>
+        </p:txBody>
+      </p:sp>
+      <p:sp>
+        <p:nvSpPr>
+          <p:cNvPr id="17" name="Shape 13"/>
           <p:cNvSpPr/>
           <p:nvPr/>
         </p:nvSpPr>
         <p:spPr>
           <a:xfrm>
-            <a:off x="3749040" y="2926080"/>
-            <a:ext cx="1005840" cy="1005840"/>
+            <a:off x="548640" y="3840480"/>
+            <a:ext cx="731520" cy="731520"/>
           </a:xfrm>
           <a:prstGeom prst="ellipse">
             <a:avLst/>
@@ -5304,22 +5566,22 @@
       </p:sp>
       <p:pic>
         <p:nvPicPr>
-          <p:cNvPr id="16" name="Image 1" descr="preencoded.png"/>
+          <p:cNvPr id="18" name="Image 2" descr="preencoded.png">    </p:cNvPr>
           <p:cNvPicPr>
             <a:picLocks noChangeAspect="1"/>
           </p:cNvPicPr>
           <p:nvPr/>
         </p:nvPicPr>
         <p:blipFill>
-          <a:blip r:embed="rId4"/>
+          <a:blip r:embed="rId3"/>
           <a:stretch>
             <a:fillRect/>
           </a:stretch>
         </p:blipFill>
         <p:spPr>
           <a:xfrm>
-            <a:off x="4000500" y="3177540"/>
-            <a:ext cx="502920" cy="502920"/>
+            <a:off x="731520" y="4023360"/>
+            <a:ext cx="365760" cy="365760"/>
           </a:xfrm>
           <a:prstGeom prst="rect">
             <a:avLst/>
@@ -5328,30 +5590,30 @@
       </p:pic>
       <p:sp>
         <p:nvSpPr>
-          <p:cNvPr id="17" name="Text 13"/>
-          <p:cNvSpPr txBox="1"/>
-          <p:nvPr/>
-        </p:nvSpPr>
-        <p:spPr>
-          <a:xfrm>
-            <a:off x="4937760" y="2926080"/>
-            <a:ext cx="1097280" cy="1005840"/>
-          </a:xfrm>
-          <a:prstGeom prst="rect">
-            <a:avLst/>
-          </a:prstGeom>
-          <a:noFill/>
-          <a:ln/>
-        </p:spPr>
-        <p:txBody>
-          <a:bodyPr wrap="square" lIns="0" tIns="0" rIns="0" bIns="0" rtlCol="0" anchor="ctr"/>
-          <a:lstStyle/>
-          <a:p>
-            <a:pPr marL="0" indent="0">
-              <a:buNone/>
-            </a:pPr>
-            <a:r>
-              <a:rPr lang="en-US" sz="2000" b="1" dirty="0">
+          <p:cNvPr id="19" name="Text 14"/>
+          <p:cNvSpPr txBox="1"/>
+          <p:nvPr/>
+        </p:nvSpPr>
+        <p:spPr>
+          <a:xfrm>
+            <a:off x="1463040" y="3840480"/>
+            <a:ext cx="2286000" cy="731520"/>
+          </a:xfrm>
+          <a:prstGeom prst="rect">
+            <a:avLst/>
+          </a:prstGeom>
+          <a:noFill/>
+          <a:ln/>
+        </p:spPr>
+        <p:txBody>
+          <a:bodyPr wrap="square" lIns="0" tIns="0" rIns="0" bIns="0" rtlCol="0" anchor="ctr"/>
+          <a:lstStyle/>
+          <a:p>
+            <a:pPr indent="0" marL="0">
+              <a:buNone/>
+            </a:pPr>
+            <a:r>
+              <a:rPr lang="en-US" sz="1600" b="1" dirty="0">
                 <a:solidFill>
                   <a:srgbClr val="0B3C49"/>
                 </a:solidFill>
@@ -5361,20 +5623,20 @@
               </a:rPr>
               <a:t>PDF</a:t>
             </a:r>
-            <a:endParaRPr lang="en-US" sz="2000" dirty="0"/>
-          </a:p>
-        </p:txBody>
-      </p:sp>
-      <p:sp>
-        <p:nvSpPr>
-          <p:cNvPr id="18" name="Shape 14"/>
+            <a:endParaRPr lang="en-US" sz="1600" dirty="0"/>
+          </a:p>
+        </p:txBody>
+      </p:sp>
+      <p:sp>
+        <p:nvSpPr>
+          <p:cNvPr id="20" name="Shape 15"/>
           <p:cNvSpPr/>
           <p:nvPr/>
         </p:nvSpPr>
         <p:spPr>
           <a:xfrm>
-            <a:off x="6309360" y="2926080"/>
-            <a:ext cx="1005840" cy="1005840"/>
+            <a:off x="2743200" y="3429000"/>
+            <a:ext cx="731520" cy="731520"/>
           </a:xfrm>
           <a:prstGeom prst="ellipse">
             <a:avLst/>
@@ -5392,22 +5654,22 @@
       </p:sp>
       <p:pic>
         <p:nvPicPr>
-          <p:cNvPr id="19" name="Image 2" descr="preencoded.png"/>
+          <p:cNvPr id="21" name="Image 3" descr="preencoded.png">    </p:cNvPr>
           <p:cNvPicPr>
             <a:picLocks noChangeAspect="1"/>
           </p:cNvPicPr>
           <p:nvPr/>
         </p:nvPicPr>
         <p:blipFill>
-          <a:blip r:embed="rId5"/>
+          <a:blip r:embed="rId4"/>
           <a:stretch>
             <a:fillRect/>
           </a:stretch>
         </p:blipFill>
         <p:spPr>
           <a:xfrm>
-            <a:off x="6560820" y="3177540"/>
-            <a:ext cx="502920" cy="502920"/>
+            <a:off x="2926080" y="3611880"/>
+            <a:ext cx="365760" cy="365760"/>
           </a:xfrm>
           <a:prstGeom prst="rect">
             <a:avLst/>
@@ -5416,30 +5678,30 @@
       </p:pic>
       <p:sp>
         <p:nvSpPr>
-          <p:cNvPr id="20" name="Text 15"/>
-          <p:cNvSpPr txBox="1"/>
-          <p:nvPr/>
-        </p:nvSpPr>
-        <p:spPr>
-          <a:xfrm>
-            <a:off x="7498080" y="2926080"/>
-            <a:ext cx="1371600" cy="1005840"/>
-          </a:xfrm>
-          <a:prstGeom prst="rect">
-            <a:avLst/>
-          </a:prstGeom>
-          <a:noFill/>
-          <a:ln/>
-        </p:spPr>
-        <p:txBody>
-          <a:bodyPr wrap="square" lIns="0" tIns="0" rIns="0" bIns="0" rtlCol="0" anchor="ctr"/>
-          <a:lstStyle/>
-          <a:p>
-            <a:pPr marL="0" indent="0">
-              <a:buNone/>
-            </a:pPr>
-            <a:r>
-              <a:rPr lang="en-US" sz="2000" b="1" dirty="0">
+          <p:cNvPr id="22" name="Text 16"/>
+          <p:cNvSpPr txBox="1"/>
+          <p:nvPr/>
+        </p:nvSpPr>
+        <p:spPr>
+          <a:xfrm>
+            <a:off x="3566160" y="3429000"/>
+            <a:ext cx="1097280" cy="731520"/>
+          </a:xfrm>
+          <a:prstGeom prst="rect">
+            <a:avLst/>
+          </a:prstGeom>
+          <a:noFill/>
+          <a:ln/>
+        </p:spPr>
+        <p:txBody>
+          <a:bodyPr wrap="square" lIns="0" tIns="0" rIns="0" bIns="0" rtlCol="0" anchor="ctr"/>
+          <a:lstStyle/>
+          <a:p>
+            <a:pPr indent="0" marL="0">
+              <a:buNone/>
+            </a:pPr>
+            <a:r>
+              <a:rPr lang="en-US" sz="1600" b="1" dirty="0">
                 <a:solidFill>
                   <a:srgbClr val="0B3C49"/>
                 </a:solidFill>
@@ -5449,7 +5711,7 @@
               </a:rPr>
               <a:t>Chop etish</a:t>
             </a:r>
-            <a:endParaRPr lang="en-US" sz="2000" dirty="0"/>
+            <a:endParaRPr lang="en-US" sz="1600" dirty="0"/>
           </a:p>
         </p:txBody>
       </p:sp>
@@ -5469,7 +5731,6 @@
         <a:solidFill>
           <a:srgbClr val="FFFFFF"/>
         </a:solidFill>
-        <a:effectLst/>
       </p:bgPr>
     </p:bg>
     <p:spTree>
@@ -5507,7 +5768,7 @@
           <a:bodyPr wrap="square" lIns="0" tIns="0" rIns="0" bIns="0" rtlCol="0" anchor="ctr"/>
           <a:lstStyle/>
           <a:p>
-            <a:pPr marL="0" indent="0">
+            <a:pPr indent="0" marL="0">
               <a:buNone/>
             </a:pPr>
             <a:r>
@@ -5600,7 +5861,7 @@
           <a:bodyPr wrap="square" lIns="0" tIns="0" rIns="0" bIns="0" rtlCol="0" anchor="ctr"/>
           <a:lstStyle/>
           <a:p>
-            <a:pPr marL="0" indent="0">
+            <a:pPr indent="0" marL="0">
               <a:buNone/>
             </a:pPr>
             <a:r>
@@ -5766,7 +6027,7 @@
           <a:bodyPr wrap="square" lIns="0" tIns="0" rIns="0" bIns="0" rtlCol="0" anchor="ctr"/>
           <a:lstStyle/>
           <a:p>
-            <a:pPr marL="0" indent="0">
+            <a:pPr indent="0" marL="0">
               <a:buNone/>
             </a:pPr>
             <a:r>
@@ -5906,7 +6167,6 @@
         <a:solidFill>
           <a:srgbClr val="FFFFFF"/>
         </a:solidFill>
-        <a:effectLst/>
       </p:bgPr>
     </p:bg>
     <p:spTree>
@@ -5944,7 +6204,7 @@
           <a:bodyPr wrap="square" lIns="0" tIns="0" rIns="0" bIns="0" rtlCol="0" anchor="ctr"/>
           <a:lstStyle/>
           <a:p>
-            <a:pPr marL="0" indent="0">
+            <a:pPr indent="0" marL="0">
               <a:buNone/>
             </a:pPr>
             <a:r>
@@ -6016,14 +6276,14 @@
       </p:sp>
       <p:pic>
         <p:nvPicPr>
-          <p:cNvPr id="5" name="Image 0" descr="preencoded.png"/>
+          <p:cNvPr id="5" name="Image 0" descr="preencoded.png">    </p:cNvPr>
           <p:cNvPicPr>
             <a:picLocks noChangeAspect="1"/>
           </p:cNvPicPr>
           <p:nvPr/>
         </p:nvPicPr>
         <p:blipFill>
-          <a:blip r:embed="rId3"/>
+          <a:blip r:embed="rId1"/>
           <a:stretch>
             <a:fillRect/>
           </a:stretch>
@@ -6059,7 +6319,7 @@
           <a:bodyPr wrap="square" lIns="0" tIns="0" rIns="0" bIns="0" rtlCol="0" anchor="ctr"/>
           <a:lstStyle/>
           <a:p>
-            <a:pPr marL="0" indent="0" algn="ctr">
+            <a:pPr algn="ctr" indent="0" marL="0">
               <a:buNone/>
             </a:pPr>
             <a:r>
@@ -6098,7 +6358,7 @@
           <a:bodyPr wrap="square" lIns="0" tIns="0" rIns="0" bIns="0" rtlCol="0" anchor="ctr"/>
           <a:lstStyle/>
           <a:p>
-            <a:pPr marL="0" indent="0" algn="ctr">
+            <a:pPr algn="ctr" indent="0" marL="0">
               <a:buNone/>
             </a:pPr>
             <a:r>
@@ -6170,14 +6430,14 @@
       </p:sp>
       <p:pic>
         <p:nvPicPr>
-          <p:cNvPr id="10" name="Image 1" descr="preencoded.png"/>
+          <p:cNvPr id="10" name="Image 1" descr="preencoded.png">    </p:cNvPr>
           <p:cNvPicPr>
             <a:picLocks noChangeAspect="1"/>
           </p:cNvPicPr>
           <p:nvPr/>
         </p:nvPicPr>
         <p:blipFill>
-          <a:blip r:embed="rId3"/>
+          <a:blip r:embed="rId2"/>
           <a:stretch>
             <a:fillRect/>
           </a:stretch>
@@ -6213,7 +6473,7 @@
           <a:bodyPr wrap="square" lIns="0" tIns="0" rIns="0" bIns="0" rtlCol="0" anchor="ctr"/>
           <a:lstStyle/>
           <a:p>
-            <a:pPr marL="0" indent="0" algn="ctr">
+            <a:pPr algn="ctr" indent="0" marL="0">
               <a:buNone/>
             </a:pPr>
             <a:r>
@@ -6252,7 +6512,7 @@
           <a:bodyPr wrap="square" lIns="0" tIns="0" rIns="0" bIns="0" rtlCol="0" anchor="ctr"/>
           <a:lstStyle/>
           <a:p>
-            <a:pPr marL="0" indent="0" algn="ctr">
+            <a:pPr algn="ctr" indent="0" marL="0">
               <a:buNone/>
             </a:pPr>
             <a:r>
@@ -6324,7 +6584,7 @@
       </p:sp>
       <p:pic>
         <p:nvPicPr>
-          <p:cNvPr id="15" name="Image 2" descr="preencoded.png"/>
+          <p:cNvPr id="15" name="Image 2" descr="preencoded.png">    </p:cNvPr>
           <p:cNvPicPr>
             <a:picLocks noChangeAspect="1"/>
           </p:cNvPicPr>
@@ -6367,7 +6627,7 @@
           <a:bodyPr wrap="square" lIns="0" tIns="0" rIns="0" bIns="0" rtlCol="0" anchor="ctr"/>
           <a:lstStyle/>
           <a:p>
-            <a:pPr marL="0" indent="0" algn="ctr">
+            <a:pPr algn="ctr" indent="0" marL="0">
               <a:buNone/>
             </a:pPr>
             <a:r>
@@ -6406,7 +6666,7 @@
           <a:bodyPr wrap="square" lIns="0" tIns="0" rIns="0" bIns="0" rtlCol="0" anchor="ctr"/>
           <a:lstStyle/>
           <a:p>
-            <a:pPr marL="0" indent="0" algn="ctr">
+            <a:pPr algn="ctr" indent="0" marL="0">
               <a:buNone/>
             </a:pPr>
             <a:r>
@@ -6478,14 +6738,14 @@
       </p:sp>
       <p:pic>
         <p:nvPicPr>
-          <p:cNvPr id="20" name="Image 3" descr="preencoded.png"/>
+          <p:cNvPr id="20" name="Image 3" descr="preencoded.png">    </p:cNvPr>
           <p:cNvPicPr>
             <a:picLocks noChangeAspect="1"/>
           </p:cNvPicPr>
           <p:nvPr/>
         </p:nvPicPr>
         <p:blipFill>
-          <a:blip r:embed="rId3"/>
+          <a:blip r:embed="rId4"/>
           <a:stretch>
             <a:fillRect/>
           </a:stretch>
@@ -6521,7 +6781,7 @@
           <a:bodyPr wrap="square" lIns="0" tIns="0" rIns="0" bIns="0" rtlCol="0" anchor="ctr"/>
           <a:lstStyle/>
           <a:p>
-            <a:pPr marL="0" indent="0" algn="ctr">
+            <a:pPr algn="ctr" indent="0" marL="0">
               <a:buNone/>
             </a:pPr>
             <a:r>
@@ -6560,7 +6820,7 @@
           <a:bodyPr wrap="square" lIns="0" tIns="0" rIns="0" bIns="0" rtlCol="0" anchor="ctr"/>
           <a:lstStyle/>
           <a:p>
-            <a:pPr marL="0" indent="0" algn="ctr">
+            <a:pPr algn="ctr" indent="0" marL="0">
               <a:buNone/>
             </a:pPr>
             <a:r>
@@ -6599,7 +6859,7 @@
           <a:bodyPr wrap="square" lIns="0" tIns="0" rIns="0" bIns="0" rtlCol="0" anchor="ctr"/>
           <a:lstStyle/>
           <a:p>
-            <a:pPr marL="0" indent="0">
+            <a:pPr indent="0" marL="0">
               <a:buNone/>
             </a:pPr>
             <a:r>
@@ -6633,7 +6893,6 @@
         <a:solidFill>
           <a:srgbClr val="0B3C49"/>
         </a:solidFill>
-        <a:effectLst/>
       </p:bgPr>
     </p:bg>
     <p:spTree>
@@ -6696,7 +6955,7 @@
           <a:bodyPr wrap="square" lIns="0" tIns="0" rIns="0" bIns="0" rtlCol="0" anchor="ctr"/>
           <a:lstStyle/>
           <a:p>
-            <a:pPr marL="0" indent="0" algn="ctr">
+            <a:pPr algn="ctr" indent="0" marL="0">
               <a:buNone/>
             </a:pPr>
             <a:r>
@@ -6735,7 +6994,7 @@
           <a:bodyPr wrap="square" lIns="0" tIns="0" rIns="0" bIns="0" rtlCol="0" anchor="ctr"/>
           <a:lstStyle/>
           <a:p>
-            <a:pPr marL="0" indent="0" algn="ctr">
+            <a:pPr algn="ctr" indent="0" marL="0">
               <a:buNone/>
             </a:pPr>
             <a:r>
@@ -6774,7 +7033,7 @@
           <a:bodyPr wrap="square" lIns="0" tIns="0" rIns="0" bIns="0" rtlCol="0" anchor="ctr"/>
           <a:lstStyle/>
           <a:p>
-            <a:pPr marL="0" indent="0" algn="ctr">
+            <a:pPr algn="ctr" indent="0" marL="0">
               <a:buNone/>
             </a:pPr>
             <a:r>
@@ -6808,7 +7067,6 @@
         <a:solidFill>
           <a:srgbClr val="FFFFFF"/>
         </a:solidFill>
-        <a:effectLst/>
       </p:bgPr>
     </p:bg>
     <p:spTree>
@@ -6846,7 +7104,7 @@
           <a:bodyPr wrap="square" lIns="0" tIns="0" rIns="0" bIns="0" rtlCol="0" anchor="ctr"/>
           <a:lstStyle/>
           <a:p>
-            <a:pPr marL="0" indent="0">
+            <a:pPr indent="0" marL="0">
               <a:buNone/>
             </a:pPr>
             <a:r>
@@ -6918,14 +7176,14 @@
       </p:sp>
       <p:pic>
         <p:nvPicPr>
-          <p:cNvPr id="5" name="Image 0" descr="preencoded.png"/>
+          <p:cNvPr id="5" name="Image 0" descr="preencoded.png">    </p:cNvPr>
           <p:cNvPicPr>
             <a:picLocks noChangeAspect="1"/>
           </p:cNvPicPr>
           <p:nvPr/>
         </p:nvPicPr>
         <p:blipFill>
-          <a:blip r:embed="rId3"/>
+          <a:blip r:embed="rId1"/>
           <a:stretch>
             <a:fillRect/>
           </a:stretch>
@@ -6961,7 +7219,7 @@
           <a:bodyPr wrap="square" lIns="0" tIns="0" rIns="0" bIns="0" rtlCol="0" anchor="ctr"/>
           <a:lstStyle/>
           <a:p>
-            <a:pPr marL="0" indent="0">
+            <a:pPr indent="0" marL="0">
               <a:buNone/>
             </a:pPr>
             <a:r>
@@ -7000,7 +7258,7 @@
           <a:bodyPr wrap="square" lIns="0" tIns="0" rIns="0" bIns="0" rtlCol="0" anchor="ctr"/>
           <a:lstStyle/>
           <a:p>
-            <a:pPr marL="0" indent="0">
+            <a:pPr indent="0" marL="0">
               <a:buNone/>
             </a:pPr>
             <a:r>
@@ -7072,14 +7330,14 @@
       </p:sp>
       <p:pic>
         <p:nvPicPr>
-          <p:cNvPr id="10" name="Image 1" descr="preencoded.png"/>
+          <p:cNvPr id="10" name="Image 1" descr="preencoded.png">    </p:cNvPr>
           <p:cNvPicPr>
             <a:picLocks noChangeAspect="1"/>
           </p:cNvPicPr>
           <p:nvPr/>
         </p:nvPicPr>
         <p:blipFill>
-          <a:blip r:embed="rId4"/>
+          <a:blip r:embed="rId2"/>
           <a:stretch>
             <a:fillRect/>
           </a:stretch>
@@ -7115,7 +7373,7 @@
           <a:bodyPr wrap="square" lIns="0" tIns="0" rIns="0" bIns="0" rtlCol="0" anchor="ctr"/>
           <a:lstStyle/>
           <a:p>
-            <a:pPr marL="0" indent="0">
+            <a:pPr indent="0" marL="0">
               <a:buNone/>
             </a:pPr>
             <a:r>
@@ -7154,7 +7412,7 @@
           <a:bodyPr wrap="square" lIns="0" tIns="0" rIns="0" bIns="0" rtlCol="0" anchor="ctr"/>
           <a:lstStyle/>
           <a:p>
-            <a:pPr marL="0" indent="0">
+            <a:pPr indent="0" marL="0">
               <a:buNone/>
             </a:pPr>
             <a:r>
@@ -7226,14 +7484,14 @@
       </p:sp>
       <p:pic>
         <p:nvPicPr>
-          <p:cNvPr id="15" name="Image 2" descr="preencoded.png"/>
+          <p:cNvPr id="15" name="Image 2" descr="preencoded.png">    </p:cNvPr>
           <p:cNvPicPr>
             <a:picLocks noChangeAspect="1"/>
           </p:cNvPicPr>
           <p:nvPr/>
         </p:nvPicPr>
         <p:blipFill>
-          <a:blip r:embed="rId5"/>
+          <a:blip r:embed="rId3"/>
           <a:stretch>
             <a:fillRect/>
           </a:stretch>
@@ -7269,7 +7527,7 @@
           <a:bodyPr wrap="square" lIns="0" tIns="0" rIns="0" bIns="0" rtlCol="0" anchor="ctr"/>
           <a:lstStyle/>
           <a:p>
-            <a:pPr marL="0" indent="0">
+            <a:pPr indent="0" marL="0">
               <a:buNone/>
             </a:pPr>
             <a:r>
@@ -7308,7 +7566,7 @@
           <a:bodyPr wrap="square" lIns="0" tIns="0" rIns="0" bIns="0" rtlCol="0" anchor="ctr"/>
           <a:lstStyle/>
           <a:p>
-            <a:pPr marL="0" indent="0">
+            <a:pPr indent="0" marL="0">
               <a:buNone/>
             </a:pPr>
             <a:r>
@@ -7380,14 +7638,14 @@
       </p:sp>
       <p:pic>
         <p:nvPicPr>
-          <p:cNvPr id="20" name="Image 3" descr="preencoded.png"/>
+          <p:cNvPr id="20" name="Image 3" descr="preencoded.png">    </p:cNvPr>
           <p:cNvPicPr>
             <a:picLocks noChangeAspect="1"/>
           </p:cNvPicPr>
           <p:nvPr/>
         </p:nvPicPr>
         <p:blipFill>
-          <a:blip r:embed="rId6"/>
+          <a:blip r:embed="rId4"/>
           <a:stretch>
             <a:fillRect/>
           </a:stretch>
@@ -7423,7 +7681,7 @@
           <a:bodyPr wrap="square" lIns="0" tIns="0" rIns="0" bIns="0" rtlCol="0" anchor="ctr"/>
           <a:lstStyle/>
           <a:p>
-            <a:pPr marL="0" indent="0">
+            <a:pPr indent="0" marL="0">
               <a:buNone/>
             </a:pPr>
             <a:r>
@@ -7462,7 +7720,7 @@
           <a:bodyPr wrap="square" lIns="0" tIns="0" rIns="0" bIns="0" rtlCol="0" anchor="ctr"/>
           <a:lstStyle/>
           <a:p>
-            <a:pPr marL="0" indent="0">
+            <a:pPr indent="0" marL="0">
               <a:buNone/>
             </a:pPr>
             <a:r>
@@ -7496,7 +7754,6 @@
         <a:solidFill>
           <a:srgbClr val="FFFFFF"/>
         </a:solidFill>
-        <a:effectLst/>
       </p:bgPr>
     </p:bg>
     <p:spTree>
@@ -7534,7 +7791,7 @@
           <a:bodyPr wrap="square" lIns="0" tIns="0" rIns="0" bIns="0" rtlCol="0" anchor="ctr"/>
           <a:lstStyle/>
           <a:p>
-            <a:pPr marL="0" indent="0">
+            <a:pPr indent="0" marL="0">
               <a:buNone/>
             </a:pPr>
             <a:r>
@@ -7627,7 +7884,7 @@
           <a:bodyPr wrap="square" lIns="0" tIns="0" rIns="0" bIns="0" rtlCol="0" anchor="ctr"/>
           <a:lstStyle/>
           <a:p>
-            <a:pPr marL="0" indent="0">
+            <a:pPr indent="0" marL="0">
               <a:buNone/>
             </a:pPr>
             <a:r>
@@ -7666,7 +7923,7 @@
           <a:bodyPr wrap="square" lIns="0" tIns="0" rIns="0" bIns="0" rtlCol="0" anchor="ctr"/>
           <a:lstStyle/>
           <a:p>
-            <a:pPr marL="0" indent="0">
+            <a:pPr indent="0" marL="0">
               <a:buNone/>
             </a:pPr>
             <a:r>
@@ -7705,7 +7962,7 @@
           <a:bodyPr wrap="square" lIns="0" tIns="0" rIns="0" bIns="0" rtlCol="0" anchor="ctr"/>
           <a:lstStyle/>
           <a:p>
-            <a:pPr marL="0" indent="0">
+            <a:pPr indent="0" marL="0">
               <a:buNone/>
             </a:pPr>
             <a:r>
@@ -7845,7 +8102,6 @@
         <a:solidFill>
           <a:srgbClr val="FFFFFF"/>
         </a:solidFill>
-        <a:effectLst/>
       </p:bgPr>
     </p:bg>
     <p:spTree>
@@ -7883,7 +8139,7 @@
           <a:bodyPr wrap="square" lIns="0" tIns="0" rIns="0" bIns="0" rtlCol="0" anchor="ctr"/>
           <a:lstStyle/>
           <a:p>
-            <a:pPr marL="0" indent="0">
+            <a:pPr indent="0" marL="0">
               <a:buNone/>
             </a:pPr>
             <a:r>
@@ -7955,14 +8211,14 @@
       </p:sp>
       <p:pic>
         <p:nvPicPr>
-          <p:cNvPr id="5" name="Image 0" descr="preencoded.png"/>
+          <p:cNvPr id="5" name="Image 0" descr="preencoded.png">    </p:cNvPr>
           <p:cNvPicPr>
             <a:picLocks noChangeAspect="1"/>
           </p:cNvPicPr>
           <p:nvPr/>
         </p:nvPicPr>
         <p:blipFill>
-          <a:blip r:embed="rId3"/>
+          <a:blip r:embed="rId1"/>
           <a:stretch>
             <a:fillRect/>
           </a:stretch>
@@ -7998,7 +8254,7 @@
           <a:bodyPr wrap="square" lIns="0" tIns="0" rIns="0" bIns="0" rtlCol="0" anchor="ctr"/>
           <a:lstStyle/>
           <a:p>
-            <a:pPr marL="0" indent="0">
+            <a:pPr indent="0" marL="0">
               <a:buNone/>
             </a:pPr>
             <a:r>
@@ -8037,7 +8293,7 @@
           <a:bodyPr wrap="square" lIns="0" tIns="0" rIns="0" bIns="0" rtlCol="0" anchor="ctr"/>
           <a:lstStyle/>
           <a:p>
-            <a:pPr marL="0" indent="0">
+            <a:pPr indent="0" marL="0">
               <a:buNone/>
             </a:pPr>
             <a:r>
@@ -8109,14 +8365,14 @@
       </p:sp>
       <p:pic>
         <p:nvPicPr>
-          <p:cNvPr id="10" name="Image 1" descr="preencoded.png"/>
+          <p:cNvPr id="10" name="Image 1" descr="preencoded.png">    </p:cNvPr>
           <p:cNvPicPr>
             <a:picLocks noChangeAspect="1"/>
           </p:cNvPicPr>
           <p:nvPr/>
         </p:nvPicPr>
         <p:blipFill>
-          <a:blip r:embed="rId4"/>
+          <a:blip r:embed="rId2"/>
           <a:stretch>
             <a:fillRect/>
           </a:stretch>
@@ -8152,7 +8408,7 @@
           <a:bodyPr wrap="square" lIns="0" tIns="0" rIns="0" bIns="0" rtlCol="0" anchor="ctr"/>
           <a:lstStyle/>
           <a:p>
-            <a:pPr marL="0" indent="0">
+            <a:pPr indent="0" marL="0">
               <a:buNone/>
             </a:pPr>
             <a:r>
@@ -8191,7 +8447,7 @@
           <a:bodyPr wrap="square" lIns="0" tIns="0" rIns="0" bIns="0" rtlCol="0" anchor="ctr"/>
           <a:lstStyle/>
           <a:p>
-            <a:pPr marL="0" indent="0">
+            <a:pPr indent="0" marL="0">
               <a:buNone/>
             </a:pPr>
             <a:r>
@@ -8263,14 +8519,14 @@
       </p:sp>
       <p:pic>
         <p:nvPicPr>
-          <p:cNvPr id="15" name="Image 2" descr="preencoded.png"/>
+          <p:cNvPr id="15" name="Image 2" descr="preencoded.png">    </p:cNvPr>
           <p:cNvPicPr>
             <a:picLocks noChangeAspect="1"/>
           </p:cNvPicPr>
           <p:nvPr/>
         </p:nvPicPr>
         <p:blipFill>
-          <a:blip r:embed="rId5"/>
+          <a:blip r:embed="rId3"/>
           <a:stretch>
             <a:fillRect/>
           </a:stretch>
@@ -8306,7 +8562,7 @@
           <a:bodyPr wrap="square" lIns="0" tIns="0" rIns="0" bIns="0" rtlCol="0" anchor="ctr"/>
           <a:lstStyle/>
           <a:p>
-            <a:pPr marL="0" indent="0">
+            <a:pPr indent="0" marL="0">
               <a:buNone/>
             </a:pPr>
             <a:r>
@@ -8345,7 +8601,7 @@
           <a:bodyPr wrap="square" lIns="0" tIns="0" rIns="0" bIns="0" rtlCol="0" anchor="ctr"/>
           <a:lstStyle/>
           <a:p>
-            <a:pPr marL="0" indent="0">
+            <a:pPr indent="0" marL="0">
               <a:buNone/>
             </a:pPr>
             <a:r>
@@ -8417,14 +8673,14 @@
       </p:sp>
       <p:pic>
         <p:nvPicPr>
-          <p:cNvPr id="20" name="Image 3" descr="preencoded.png"/>
+          <p:cNvPr id="20" name="Image 3" descr="preencoded.png">    </p:cNvPr>
           <p:cNvPicPr>
             <a:picLocks noChangeAspect="1"/>
           </p:cNvPicPr>
           <p:nvPr/>
         </p:nvPicPr>
         <p:blipFill>
-          <a:blip r:embed="rId6"/>
+          <a:blip r:embed="rId4"/>
           <a:stretch>
             <a:fillRect/>
           </a:stretch>
@@ -8460,7 +8716,7 @@
           <a:bodyPr wrap="square" lIns="0" tIns="0" rIns="0" bIns="0" rtlCol="0" anchor="ctr"/>
           <a:lstStyle/>
           <a:p>
-            <a:pPr marL="0" indent="0">
+            <a:pPr indent="0" marL="0">
               <a:buNone/>
             </a:pPr>
             <a:r>
@@ -8499,7 +8755,7 @@
           <a:bodyPr wrap="square" lIns="0" tIns="0" rIns="0" bIns="0" rtlCol="0" anchor="ctr"/>
           <a:lstStyle/>
           <a:p>
-            <a:pPr marL="0" indent="0">
+            <a:pPr indent="0" marL="0">
               <a:buNone/>
             </a:pPr>
             <a:r>
@@ -8533,7 +8789,6 @@
         <a:solidFill>
           <a:srgbClr val="0B3C49"/>
         </a:solidFill>
-        <a:effectLst/>
       </p:bgPr>
     </p:bg>
     <p:spTree>
@@ -8571,7 +8826,7 @@
           <a:bodyPr wrap="square" lIns="0" tIns="0" rIns="0" bIns="0" rtlCol="0" anchor="ctr"/>
           <a:lstStyle/>
           <a:p>
-            <a:pPr marL="0" indent="0">
+            <a:pPr indent="0" marL="0">
               <a:buNone/>
             </a:pPr>
             <a:r>
@@ -8616,14 +8871,14 @@
       </p:sp>
       <p:pic>
         <p:nvPicPr>
-          <p:cNvPr id="4" name="Image 0" descr="preencoded.png"/>
+          <p:cNvPr id="4" name="Image 0" descr="preencoded.png">    </p:cNvPr>
           <p:cNvPicPr>
             <a:picLocks noChangeAspect="1"/>
           </p:cNvPicPr>
           <p:nvPr/>
         </p:nvPicPr>
         <p:blipFill>
-          <a:blip r:embed="rId3"/>
+          <a:blip r:embed="rId1"/>
           <a:stretch>
             <a:fillRect/>
           </a:stretch>
@@ -8659,7 +8914,7 @@
           <a:bodyPr wrap="square" lIns="0" tIns="0" rIns="0" bIns="0" rtlCol="0" anchor="ctr"/>
           <a:lstStyle/>
           <a:p>
-            <a:pPr marL="0" indent="0" algn="ctr">
+            <a:pPr algn="ctr" indent="0" marL="0">
               <a:buNone/>
             </a:pPr>
             <a:r>
@@ -8704,14 +8959,14 @@
       </p:sp>
       <p:pic>
         <p:nvPicPr>
-          <p:cNvPr id="7" name="Image 1" descr="preencoded.png"/>
+          <p:cNvPr id="7" name="Image 1" descr="preencoded.png">    </p:cNvPr>
           <p:cNvPicPr>
             <a:picLocks noChangeAspect="1"/>
           </p:cNvPicPr>
           <p:nvPr/>
         </p:nvPicPr>
         <p:blipFill>
-          <a:blip r:embed="rId4"/>
+          <a:blip r:embed="rId2"/>
           <a:stretch>
             <a:fillRect/>
           </a:stretch>
@@ -8747,7 +9002,7 @@
           <a:bodyPr wrap="square" lIns="0" tIns="0" rIns="0" bIns="0" rtlCol="0" anchor="ctr"/>
           <a:lstStyle/>
           <a:p>
-            <a:pPr marL="0" indent="0" algn="ctr">
+            <a:pPr algn="ctr" indent="0" marL="0">
               <a:buNone/>
             </a:pPr>
             <a:r>
@@ -8792,14 +9047,14 @@
       </p:sp>
       <p:pic>
         <p:nvPicPr>
-          <p:cNvPr id="10" name="Image 2" descr="preencoded.png"/>
+          <p:cNvPr id="10" name="Image 2" descr="preencoded.png">    </p:cNvPr>
           <p:cNvPicPr>
             <a:picLocks noChangeAspect="1"/>
           </p:cNvPicPr>
           <p:nvPr/>
         </p:nvPicPr>
         <p:blipFill>
-          <a:blip r:embed="rId5"/>
+          <a:blip r:embed="rId3"/>
           <a:stretch>
             <a:fillRect/>
           </a:stretch>
@@ -8835,7 +9090,7 @@
           <a:bodyPr wrap="square" lIns="0" tIns="0" rIns="0" bIns="0" rtlCol="0" anchor="ctr"/>
           <a:lstStyle/>
           <a:p>
-            <a:pPr marL="0" indent="0" algn="ctr">
+            <a:pPr algn="ctr" indent="0" marL="0">
               <a:buNone/>
             </a:pPr>
             <a:r>
@@ -8880,14 +9135,14 @@
       </p:sp>
       <p:pic>
         <p:nvPicPr>
-          <p:cNvPr id="13" name="Image 3" descr="preencoded.png"/>
+          <p:cNvPr id="13" name="Image 3" descr="preencoded.png">    </p:cNvPr>
           <p:cNvPicPr>
             <a:picLocks noChangeAspect="1"/>
           </p:cNvPicPr>
           <p:nvPr/>
         </p:nvPicPr>
         <p:blipFill>
-          <a:blip r:embed="rId6"/>
+          <a:blip r:embed="rId4"/>
           <a:stretch>
             <a:fillRect/>
           </a:stretch>
@@ -8923,7 +9178,7 @@
           <a:bodyPr wrap="square" lIns="0" tIns="0" rIns="0" bIns="0" rtlCol="0" anchor="ctr"/>
           <a:lstStyle/>
           <a:p>
-            <a:pPr marL="0" indent="0" algn="ctr">
+            <a:pPr algn="ctr" indent="0" marL="0">
               <a:buNone/>
             </a:pPr>
             <a:r>
@@ -8968,14 +9223,14 @@
       </p:sp>
       <p:pic>
         <p:nvPicPr>
-          <p:cNvPr id="16" name="Image 4" descr="preencoded.png"/>
+          <p:cNvPr id="16" name="Image 4" descr="preencoded.png">    </p:cNvPr>
           <p:cNvPicPr>
             <a:picLocks noChangeAspect="1"/>
           </p:cNvPicPr>
           <p:nvPr/>
         </p:nvPicPr>
         <p:blipFill>
-          <a:blip r:embed="rId7"/>
+          <a:blip r:embed="rId5"/>
           <a:stretch>
             <a:fillRect/>
           </a:stretch>
@@ -9011,7 +9266,7 @@
           <a:bodyPr wrap="square" lIns="0" tIns="0" rIns="0" bIns="0" rtlCol="0" anchor="ctr"/>
           <a:lstStyle/>
           <a:p>
-            <a:pPr marL="0" indent="0" algn="ctr">
+            <a:pPr algn="ctr" indent="0" marL="0">
               <a:buNone/>
             </a:pPr>
             <a:r>
@@ -9056,14 +9311,14 @@
       </p:sp>
       <p:pic>
         <p:nvPicPr>
-          <p:cNvPr id="19" name="Image 5" descr="preencoded.png"/>
+          <p:cNvPr id="19" name="Image 5" descr="preencoded.png">    </p:cNvPr>
           <p:cNvPicPr>
             <a:picLocks noChangeAspect="1"/>
           </p:cNvPicPr>
           <p:nvPr/>
         </p:nvPicPr>
         <p:blipFill>
-          <a:blip r:embed="rId8"/>
+          <a:blip r:embed="rId6"/>
           <a:stretch>
             <a:fillRect/>
           </a:stretch>
@@ -9099,7 +9354,7 @@
           <a:bodyPr wrap="square" lIns="0" tIns="0" rIns="0" bIns="0" rtlCol="0" anchor="ctr"/>
           <a:lstStyle/>
           <a:p>
-            <a:pPr marL="0" indent="0" algn="ctr">
+            <a:pPr algn="ctr" indent="0" marL="0">
               <a:buNone/>
             </a:pPr>
             <a:r>
@@ -9144,14 +9399,14 @@
       </p:sp>
       <p:pic>
         <p:nvPicPr>
-          <p:cNvPr id="22" name="Image 6" descr="preencoded.png"/>
+          <p:cNvPr id="22" name="Image 6" descr="preencoded.png">    </p:cNvPr>
           <p:cNvPicPr>
             <a:picLocks noChangeAspect="1"/>
           </p:cNvPicPr>
           <p:nvPr/>
         </p:nvPicPr>
         <p:blipFill>
-          <a:blip r:embed="rId9"/>
+          <a:blip r:embed="rId7"/>
           <a:stretch>
             <a:fillRect/>
           </a:stretch>
@@ -9187,7 +9442,7 @@
           <a:bodyPr wrap="square" lIns="0" tIns="0" rIns="0" bIns="0" rtlCol="0" anchor="ctr"/>
           <a:lstStyle/>
           <a:p>
-            <a:pPr marL="0" indent="0" algn="ctr">
+            <a:pPr algn="ctr" indent="0" marL="0">
               <a:buNone/>
             </a:pPr>
             <a:r>
@@ -9232,14 +9487,14 @@
       </p:sp>
       <p:pic>
         <p:nvPicPr>
-          <p:cNvPr id="25" name="Image 7" descr="preencoded.png"/>
+          <p:cNvPr id="25" name="Image 7" descr="preencoded.png">    </p:cNvPr>
           <p:cNvPicPr>
             <a:picLocks noChangeAspect="1"/>
           </p:cNvPicPr>
           <p:nvPr/>
         </p:nvPicPr>
         <p:blipFill>
-          <a:blip r:embed="rId10"/>
+          <a:blip r:embed="rId8"/>
           <a:stretch>
             <a:fillRect/>
           </a:stretch>
@@ -9275,7 +9530,7 @@
           <a:bodyPr wrap="square" lIns="0" tIns="0" rIns="0" bIns="0" rtlCol="0" anchor="ctr"/>
           <a:lstStyle/>
           <a:p>
-            <a:pPr marL="0" indent="0" algn="ctr">
+            <a:pPr algn="ctr" indent="0" marL="0">
               <a:buNone/>
             </a:pPr>
             <a:r>
@@ -9309,7 +9564,6 @@
         <a:solidFill>
           <a:srgbClr val="FFFFFF"/>
         </a:solidFill>
-        <a:effectLst/>
       </p:bgPr>
     </p:bg>
     <p:spTree>
@@ -9347,7 +9601,7 @@
           <a:bodyPr wrap="square" lIns="0" tIns="0" rIns="0" bIns="0" rtlCol="0" anchor="ctr"/>
           <a:lstStyle/>
           <a:p>
-            <a:pPr marL="0" indent="0">
+            <a:pPr indent="0" marL="0">
               <a:buNone/>
             </a:pPr>
             <a:r>
@@ -9411,7 +9665,7 @@
           <a:bodyPr wrap="square" lIns="0" tIns="0" rIns="0" bIns="0" rtlCol="0" anchor="ctr"/>
           <a:lstStyle/>
           <a:p>
-            <a:pPr marL="0" indent="0" algn="ctr">
+            <a:pPr algn="ctr" indent="0" marL="0">
               <a:buNone/>
             </a:pPr>
             <a:r>
@@ -9450,7 +9704,7 @@
           <a:bodyPr wrap="square" lIns="0" tIns="0" rIns="0" bIns="0" rtlCol="0" anchor="ctr"/>
           <a:lstStyle/>
           <a:p>
-            <a:pPr marL="0" indent="0" algn="ctr">
+            <a:pPr algn="ctr" indent="0" marL="0">
               <a:buNone/>
             </a:pPr>
             <a:r>
@@ -9489,7 +9743,7 @@
           <a:bodyPr wrap="square" lIns="0" tIns="0" rIns="0" bIns="0" rtlCol="0" anchor="ctr"/>
           <a:lstStyle/>
           <a:p>
-            <a:pPr marL="0" indent="0" algn="ctr">
+            <a:pPr algn="ctr" indent="0" marL="0">
               <a:buNone/>
             </a:pPr>
             <a:r>
@@ -9553,7 +9807,7 @@
           <a:bodyPr wrap="square" lIns="0" tIns="0" rIns="0" bIns="0" rtlCol="0" anchor="ctr"/>
           <a:lstStyle/>
           <a:p>
-            <a:pPr marL="0" indent="0" algn="ctr">
+            <a:pPr algn="ctr" indent="0" marL="0">
               <a:buNone/>
             </a:pPr>
             <a:r>
@@ -9592,7 +9846,7 @@
           <a:bodyPr wrap="square" lIns="0" tIns="0" rIns="0" bIns="0" rtlCol="0" anchor="ctr"/>
           <a:lstStyle/>
           <a:p>
-            <a:pPr marL="0" indent="0" algn="ctr">
+            <a:pPr algn="ctr" indent="0" marL="0">
               <a:buNone/>
             </a:pPr>
             <a:r>
@@ -9631,7 +9885,7 @@
           <a:bodyPr wrap="square" lIns="0" tIns="0" rIns="0" bIns="0" rtlCol="0" anchor="ctr"/>
           <a:lstStyle/>
           <a:p>
-            <a:pPr marL="0" indent="0" algn="ctr">
+            <a:pPr algn="ctr" indent="0" marL="0">
               <a:buNone/>
             </a:pPr>
             <a:r>
@@ -9695,7 +9949,7 @@
           <a:bodyPr wrap="square" lIns="0" tIns="0" rIns="0" bIns="0" rtlCol="0" anchor="ctr"/>
           <a:lstStyle/>
           <a:p>
-            <a:pPr marL="0" indent="0" algn="ctr">
+            <a:pPr algn="ctr" indent="0" marL="0">
               <a:buNone/>
             </a:pPr>
             <a:r>
@@ -9734,7 +9988,7 @@
           <a:bodyPr wrap="square" lIns="0" tIns="0" rIns="0" bIns="0" rtlCol="0" anchor="ctr"/>
           <a:lstStyle/>
           <a:p>
-            <a:pPr marL="0" indent="0" algn="ctr">
+            <a:pPr algn="ctr" indent="0" marL="0">
               <a:buNone/>
             </a:pPr>
             <a:r>
@@ -9773,7 +10027,7 @@
           <a:bodyPr wrap="square" lIns="0" tIns="0" rIns="0" bIns="0" rtlCol="0" anchor="ctr"/>
           <a:lstStyle/>
           <a:p>
-            <a:pPr marL="0" indent="0" algn="ctr">
+            <a:pPr algn="ctr" indent="0" marL="0">
               <a:buNone/>
             </a:pPr>
             <a:r>
@@ -9837,7 +10091,7 @@
           <a:bodyPr wrap="square" lIns="0" tIns="0" rIns="0" bIns="0" rtlCol="0" anchor="ctr"/>
           <a:lstStyle/>
           <a:p>
-            <a:pPr marL="0" indent="0" algn="ctr">
+            <a:pPr algn="ctr" indent="0" marL="0">
               <a:buNone/>
             </a:pPr>
             <a:r>
@@ -9876,7 +10130,7 @@
           <a:bodyPr wrap="square" lIns="0" tIns="0" rIns="0" bIns="0" rtlCol="0" anchor="ctr"/>
           <a:lstStyle/>
           <a:p>
-            <a:pPr marL="0" indent="0" algn="ctr">
+            <a:pPr algn="ctr" indent="0" marL="0">
               <a:buNone/>
             </a:pPr>
             <a:r>
@@ -9915,7 +10169,7 @@
           <a:bodyPr wrap="square" lIns="0" tIns="0" rIns="0" bIns="0" rtlCol="0" anchor="ctr"/>
           <a:lstStyle/>
           <a:p>
-            <a:pPr marL="0" indent="0" algn="ctr">
+            <a:pPr algn="ctr" indent="0" marL="0">
               <a:buNone/>
             </a:pPr>
             <a:r>
@@ -9979,7 +10233,7 @@
           <a:bodyPr wrap="square" lIns="0" tIns="0" rIns="0" bIns="0" rtlCol="0" anchor="ctr"/>
           <a:lstStyle/>
           <a:p>
-            <a:pPr marL="0" indent="0" algn="ctr">
+            <a:pPr algn="ctr" indent="0" marL="0">
               <a:buNone/>
             </a:pPr>
             <a:r>
@@ -10018,7 +10272,7 @@
           <a:bodyPr wrap="square" lIns="0" tIns="0" rIns="0" bIns="0" rtlCol="0" anchor="ctr"/>
           <a:lstStyle/>
           <a:p>
-            <a:pPr marL="0" indent="0" algn="ctr">
+            <a:pPr algn="ctr" indent="0" marL="0">
               <a:buNone/>
             </a:pPr>
             <a:r>
@@ -10057,7 +10311,7 @@
           <a:bodyPr wrap="square" lIns="0" tIns="0" rIns="0" bIns="0" rtlCol="0" anchor="ctr"/>
           <a:lstStyle/>
           <a:p>
-            <a:pPr marL="0" indent="0" algn="ctr">
+            <a:pPr algn="ctr" indent="0" marL="0">
               <a:buNone/>
             </a:pPr>
             <a:r>
@@ -10091,7 +10345,6 @@
         <a:solidFill>
           <a:srgbClr val="FFFFFF"/>
         </a:solidFill>
-        <a:effectLst/>
       </p:bgPr>
     </p:bg>
     <p:spTree>
@@ -10129,7 +10382,7 @@
           <a:bodyPr wrap="square" lIns="0" tIns="0" rIns="0" bIns="0" rtlCol="0" anchor="ctr"/>
           <a:lstStyle/>
           <a:p>
-            <a:pPr marL="0" indent="0">
+            <a:pPr indent="0" marL="0">
               <a:buNone/>
             </a:pPr>
             <a:r>
@@ -10155,767 +10408,8 @@
         </p:nvSpPr>
         <p:spPr>
           <a:xfrm>
-            <a:off x="548640" y="1188720"/>
-            <a:ext cx="3840480" cy="1508760"/>
-          </a:xfrm>
-          <a:prstGeom prst="roundRect">
-            <a:avLst>
-              <a:gd name="adj" fmla="val 3636"/>
-            </a:avLst>
-          </a:prstGeom>
-          <a:solidFill>
-            <a:srgbClr val="FFFFFF"/>
-          </a:solidFill>
-          <a:ln w="12700">
-            <a:solidFill>
-              <a:srgbClr val="B8CED3"/>
-            </a:solidFill>
-            <a:prstDash val="solid"/>
-          </a:ln>
-        </p:spPr>
-      </p:sp>
-      <p:sp>
-        <p:nvSpPr>
-          <p:cNvPr id="4" name="Shape 2"/>
-          <p:cNvSpPr/>
-          <p:nvPr/>
-        </p:nvSpPr>
-        <p:spPr>
-          <a:xfrm>
-            <a:off x="557784" y="1197864"/>
-            <a:ext cx="3822192" cy="201168"/>
-          </a:xfrm>
-          <a:prstGeom prst="rect">
-            <a:avLst/>
-          </a:prstGeom>
-          <a:solidFill>
-            <a:srgbClr val="0B3C49"/>
-          </a:solidFill>
-          <a:ln w="12700">
-            <a:solidFill>
-              <a:srgbClr val="0B3C49"/>
-            </a:solidFill>
-            <a:prstDash val="solid"/>
-          </a:ln>
-        </p:spPr>
-      </p:sp>
-      <p:sp>
-        <p:nvSpPr>
-          <p:cNvPr id="5" name="Shape 3"/>
-          <p:cNvSpPr/>
-          <p:nvPr/>
-        </p:nvSpPr>
-        <p:spPr>
-          <a:xfrm>
-            <a:off x="557784" y="1399032"/>
-            <a:ext cx="502920" cy="1289304"/>
-          </a:xfrm>
-          <a:prstGeom prst="rect">
-            <a:avLst/>
-          </a:prstGeom>
-          <a:solidFill>
-            <a:srgbClr val="E8F4F3"/>
-          </a:solidFill>
-          <a:ln w="12700">
-            <a:solidFill>
-              <a:srgbClr val="E8F4F3"/>
-            </a:solidFill>
-            <a:prstDash val="solid"/>
-          </a:ln>
-        </p:spPr>
-      </p:sp>
-      <p:sp>
-        <p:nvSpPr>
-          <p:cNvPr id="6" name="Shape 4"/>
-          <p:cNvSpPr/>
-          <p:nvPr/>
-        </p:nvSpPr>
-        <p:spPr>
-          <a:xfrm>
-            <a:off x="1188720" y="1554480"/>
-            <a:ext cx="947928" cy="365760"/>
-          </a:xfrm>
-          <a:prstGeom prst="rect">
-            <a:avLst/>
-          </a:prstGeom>
-          <a:solidFill>
-            <a:srgbClr val="0E7C86"/>
-          </a:solidFill>
-          <a:ln w="12700">
-            <a:solidFill>
-              <a:srgbClr val="FFFFFF"/>
-            </a:solidFill>
-            <a:prstDash val="solid"/>
-          </a:ln>
-        </p:spPr>
-      </p:sp>
-      <p:sp>
-        <p:nvSpPr>
-          <p:cNvPr id="7" name="Shape 5"/>
-          <p:cNvSpPr/>
-          <p:nvPr/>
-        </p:nvSpPr>
-        <p:spPr>
-          <a:xfrm>
-            <a:off x="2209800" y="1554480"/>
-            <a:ext cx="947928" cy="365760"/>
-          </a:xfrm>
-          <a:prstGeom prst="rect">
-            <a:avLst/>
-          </a:prstGeom>
-          <a:solidFill>
-            <a:srgbClr val="14A3A8"/>
-          </a:solidFill>
-          <a:ln w="12700">
-            <a:solidFill>
-              <a:srgbClr val="FFFFFF"/>
-            </a:solidFill>
-            <a:prstDash val="solid"/>
-          </a:ln>
-        </p:spPr>
-      </p:sp>
-      <p:sp>
-        <p:nvSpPr>
-          <p:cNvPr id="8" name="Shape 6"/>
-          <p:cNvSpPr/>
-          <p:nvPr/>
-        </p:nvSpPr>
-        <p:spPr>
-          <a:xfrm>
-            <a:off x="3230880" y="1554480"/>
-            <a:ext cx="947928" cy="365760"/>
-          </a:xfrm>
-          <a:prstGeom prst="rect">
-            <a:avLst/>
-          </a:prstGeom>
-          <a:solidFill>
-            <a:srgbClr val="F2A541"/>
-          </a:solidFill>
-          <a:ln w="12700">
-            <a:solidFill>
-              <a:srgbClr val="FFFFFF"/>
-            </a:solidFill>
-            <a:prstDash val="solid"/>
-          </a:ln>
-        </p:spPr>
-      </p:sp>
-      <p:sp>
-        <p:nvSpPr>
-          <p:cNvPr id="9" name="Shape 7"/>
-          <p:cNvSpPr/>
-          <p:nvPr/>
-        </p:nvSpPr>
-        <p:spPr>
-          <a:xfrm>
-            <a:off x="1371727" y="2238502"/>
-            <a:ext cx="274320" cy="457200"/>
-          </a:xfrm>
-          <a:prstGeom prst="rect">
-            <a:avLst/>
-          </a:prstGeom>
-          <a:solidFill>
-            <a:srgbClr val="0E7C86"/>
-          </a:solidFill>
-          <a:ln w="12700">
-            <a:solidFill>
-              <a:srgbClr val="0E7C86"/>
-            </a:solidFill>
-            <a:prstDash val="solid"/>
-          </a:ln>
-        </p:spPr>
-      </p:sp>
-      <p:sp>
-        <p:nvSpPr>
-          <p:cNvPr id="10" name="Shape 8"/>
-          <p:cNvSpPr/>
-          <p:nvPr/>
-        </p:nvSpPr>
-        <p:spPr>
-          <a:xfrm>
-            <a:off x="1774190" y="2052828"/>
-            <a:ext cx="274320" cy="640080"/>
-          </a:xfrm>
-          <a:prstGeom prst="rect">
-            <a:avLst/>
-          </a:prstGeom>
-          <a:solidFill>
-            <a:srgbClr val="0E7C86"/>
-          </a:solidFill>
-          <a:ln w="12700">
-            <a:solidFill>
-              <a:srgbClr val="0E7C86"/>
-            </a:solidFill>
-            <a:prstDash val="solid"/>
-          </a:ln>
-        </p:spPr>
-      </p:sp>
-      <p:sp>
-        <p:nvSpPr>
-          <p:cNvPr id="11" name="Shape 9"/>
-          <p:cNvSpPr/>
-          <p:nvPr/>
-        </p:nvSpPr>
-        <p:spPr>
-          <a:xfrm>
-            <a:off x="2176272" y="2221992"/>
-            <a:ext cx="274320" cy="480060"/>
-          </a:xfrm>
-          <a:prstGeom prst="rect">
-            <a:avLst/>
-          </a:prstGeom>
-          <a:solidFill>
-            <a:srgbClr val="0E7C86"/>
-          </a:solidFill>
-          <a:ln w="12700">
-            <a:solidFill>
-              <a:srgbClr val="0E7C86"/>
-            </a:solidFill>
-            <a:prstDash val="solid"/>
-          </a:ln>
-        </p:spPr>
-      </p:sp>
-      <p:sp>
-        <p:nvSpPr>
-          <p:cNvPr id="12" name="Shape 10"/>
-          <p:cNvSpPr/>
-          <p:nvPr/>
-        </p:nvSpPr>
-        <p:spPr>
-          <a:xfrm>
-            <a:off x="2579370" y="2329942"/>
-            <a:ext cx="274320" cy="365760"/>
-          </a:xfrm>
-          <a:prstGeom prst="rect">
-            <a:avLst/>
-          </a:prstGeom>
-          <a:solidFill>
-            <a:srgbClr val="0E7C86"/>
-          </a:solidFill>
-          <a:ln w="12700">
-            <a:solidFill>
-              <a:srgbClr val="0E7C86"/>
-            </a:solidFill>
-            <a:prstDash val="solid"/>
-          </a:ln>
-        </p:spPr>
-      </p:sp>
-      <p:sp>
-        <p:nvSpPr>
-          <p:cNvPr id="13" name="Shape 11"/>
-          <p:cNvSpPr/>
-          <p:nvPr/>
-        </p:nvSpPr>
-        <p:spPr>
-          <a:xfrm>
-            <a:off x="3509772" y="2036445"/>
-            <a:ext cx="596138" cy="596138"/>
-          </a:xfrm>
-          <a:prstGeom prst="ellipse">
-            <a:avLst/>
-          </a:prstGeom>
-          <a:solidFill>
-            <a:srgbClr val="14A3A8"/>
-          </a:solidFill>
-          <a:ln w="76200">
-            <a:solidFill>
-              <a:srgbClr val="F2A541"/>
-            </a:solidFill>
-            <a:prstDash val="solid"/>
-          </a:ln>
-        </p:spPr>
-      </p:sp>
-      <p:sp>
-        <p:nvSpPr>
-          <p:cNvPr id="14" name="Text 12"/>
-          <p:cNvSpPr txBox="1"/>
-          <p:nvPr/>
-        </p:nvSpPr>
-        <p:spPr>
-          <a:xfrm>
-            <a:off x="548640" y="2743200"/>
-            <a:ext cx="3840480" cy="256032"/>
-          </a:xfrm>
-          <a:prstGeom prst="rect">
-            <a:avLst/>
-          </a:prstGeom>
-          <a:noFill/>
-          <a:ln/>
-        </p:spPr>
-        <p:txBody>
-          <a:bodyPr wrap="square" lIns="0" tIns="0" rIns="0" bIns="0" rtlCol="0" anchor="ctr"/>
-          <a:lstStyle/>
-          <a:p>
-            <a:pPr marL="0" indent="0" algn="ctr">
-              <a:buNone/>
-            </a:pPr>
-            <a:r>
-              <a:rPr lang="en-US" sz="1300" dirty="0">
-                <a:solidFill>
-                  <a:srgbClr val="5E7480"/>
-                </a:solidFill>
-                <a:latin typeface="Calibri" pitchFamily="34" charset="0"/>
-                <a:ea typeface="Calibri" pitchFamily="34" charset="-122"/>
-                <a:cs typeface="Calibri" pitchFamily="34" charset="-120"/>
-              </a:rPr>
-              <a:t>Dashboard</a:t>
-            </a:r>
-            <a:endParaRPr lang="en-US" sz="1300" dirty="0"/>
-          </a:p>
-        </p:txBody>
-      </p:sp>
-      <p:sp>
-        <p:nvSpPr>
-          <p:cNvPr id="15" name="Shape 13"/>
-          <p:cNvSpPr/>
-          <p:nvPr/>
-        </p:nvSpPr>
-        <p:spPr>
-          <a:xfrm>
-            <a:off x="4663440" y="1188720"/>
-            <a:ext cx="3840480" cy="1508760"/>
-          </a:xfrm>
-          <a:prstGeom prst="roundRect">
-            <a:avLst>
-              <a:gd name="adj" fmla="val 3636"/>
-            </a:avLst>
-          </a:prstGeom>
-          <a:solidFill>
-            <a:srgbClr val="FFFFFF"/>
-          </a:solidFill>
-          <a:ln w="12700">
-            <a:solidFill>
-              <a:srgbClr val="B8CED3"/>
-            </a:solidFill>
-            <a:prstDash val="solid"/>
-          </a:ln>
-        </p:spPr>
-      </p:sp>
-      <p:sp>
-        <p:nvSpPr>
-          <p:cNvPr id="16" name="Shape 14"/>
-          <p:cNvSpPr/>
-          <p:nvPr/>
-        </p:nvSpPr>
-        <p:spPr>
-          <a:xfrm>
-            <a:off x="4672584" y="1197864"/>
-            <a:ext cx="3822192" cy="201168"/>
-          </a:xfrm>
-          <a:prstGeom prst="rect">
-            <a:avLst/>
-          </a:prstGeom>
-          <a:solidFill>
-            <a:srgbClr val="0B3C49"/>
-          </a:solidFill>
-          <a:ln w="12700">
-            <a:solidFill>
-              <a:srgbClr val="0B3C49"/>
-            </a:solidFill>
-            <a:prstDash val="solid"/>
-          </a:ln>
-        </p:spPr>
-      </p:sp>
-      <p:sp>
-        <p:nvSpPr>
-          <p:cNvPr id="17" name="Shape 15"/>
-          <p:cNvSpPr/>
-          <p:nvPr/>
-        </p:nvSpPr>
-        <p:spPr>
-          <a:xfrm>
-            <a:off x="4672584" y="1399032"/>
-            <a:ext cx="502920" cy="1289304"/>
-          </a:xfrm>
-          <a:prstGeom prst="rect">
-            <a:avLst/>
-          </a:prstGeom>
-          <a:solidFill>
-            <a:srgbClr val="E8F4F3"/>
-          </a:solidFill>
-          <a:ln w="12700">
-            <a:solidFill>
-              <a:srgbClr val="E8F4F3"/>
-            </a:solidFill>
-            <a:prstDash val="solid"/>
-          </a:ln>
-        </p:spPr>
-      </p:sp>
-      <p:sp>
-        <p:nvSpPr>
-          <p:cNvPr id="18" name="Shape 16"/>
-          <p:cNvSpPr/>
-          <p:nvPr/>
-        </p:nvSpPr>
-        <p:spPr>
-          <a:xfrm>
-            <a:off x="5303520" y="1452880"/>
-            <a:ext cx="1837944" cy="182880"/>
-          </a:xfrm>
-          <a:prstGeom prst="rect">
-            <a:avLst/>
-          </a:prstGeom>
-          <a:solidFill>
-            <a:srgbClr val="E8F4F3"/>
-          </a:solidFill>
-          <a:ln w="12700">
-            <a:solidFill>
-              <a:srgbClr val="B8CED3"/>
-            </a:solidFill>
-            <a:prstDash val="solid"/>
-          </a:ln>
-        </p:spPr>
-      </p:sp>
-      <p:sp>
-        <p:nvSpPr>
-          <p:cNvPr id="19" name="Shape 17"/>
-          <p:cNvSpPr/>
-          <p:nvPr/>
-        </p:nvSpPr>
-        <p:spPr>
-          <a:xfrm>
-            <a:off x="5303520" y="1732788"/>
-            <a:ext cx="3063240" cy="182880"/>
-          </a:xfrm>
-          <a:prstGeom prst="rect">
-            <a:avLst/>
-          </a:prstGeom>
-          <a:solidFill>
-            <a:srgbClr val="E8F4F3"/>
-          </a:solidFill>
-          <a:ln w="12700">
-            <a:solidFill>
-              <a:srgbClr val="DCE8EA"/>
-            </a:solidFill>
-            <a:prstDash val="solid"/>
-          </a:ln>
-        </p:spPr>
-      </p:sp>
-      <p:sp>
-        <p:nvSpPr>
-          <p:cNvPr id="20" name="Shape 18"/>
-          <p:cNvSpPr/>
-          <p:nvPr/>
-        </p:nvSpPr>
-        <p:spPr>
-          <a:xfrm>
-            <a:off x="7909560" y="1769364"/>
-            <a:ext cx="384048" cy="109728"/>
-          </a:xfrm>
-          <a:prstGeom prst="rect">
-            <a:avLst/>
-          </a:prstGeom>
-          <a:solidFill>
-            <a:srgbClr val="3C9D6B"/>
-          </a:solidFill>
-          <a:ln w="12700">
-            <a:solidFill>
-              <a:srgbClr val="FFFFFF"/>
-            </a:solidFill>
-            <a:prstDash val="solid"/>
-          </a:ln>
-        </p:spPr>
-      </p:sp>
-      <p:sp>
-        <p:nvSpPr>
-          <p:cNvPr id="21" name="Shape 19"/>
-          <p:cNvSpPr/>
-          <p:nvPr/>
-        </p:nvSpPr>
-        <p:spPr>
-          <a:xfrm>
-            <a:off x="5303520" y="1961388"/>
-            <a:ext cx="3063240" cy="182880"/>
-          </a:xfrm>
-          <a:prstGeom prst="rect">
-            <a:avLst/>
-          </a:prstGeom>
-          <a:solidFill>
-            <a:srgbClr val="FFFFFF"/>
-          </a:solidFill>
-          <a:ln w="12700">
-            <a:solidFill>
-              <a:srgbClr val="DCE8EA"/>
-            </a:solidFill>
-            <a:prstDash val="solid"/>
-          </a:ln>
-        </p:spPr>
-      </p:sp>
-      <p:sp>
-        <p:nvSpPr>
-          <p:cNvPr id="22" name="Shape 20"/>
-          <p:cNvSpPr/>
-          <p:nvPr/>
-        </p:nvSpPr>
-        <p:spPr>
-          <a:xfrm>
-            <a:off x="7909560" y="1997964"/>
-            <a:ext cx="384048" cy="109728"/>
-          </a:xfrm>
-          <a:prstGeom prst="rect">
-            <a:avLst/>
-          </a:prstGeom>
-          <a:solidFill>
-            <a:srgbClr val="F2A541"/>
-          </a:solidFill>
-          <a:ln w="12700">
-            <a:solidFill>
-              <a:srgbClr val="FFFFFF"/>
-            </a:solidFill>
-            <a:prstDash val="solid"/>
-          </a:ln>
-        </p:spPr>
-      </p:sp>
-      <p:sp>
-        <p:nvSpPr>
-          <p:cNvPr id="23" name="Shape 21"/>
-          <p:cNvSpPr/>
-          <p:nvPr/>
-        </p:nvSpPr>
-        <p:spPr>
-          <a:xfrm>
-            <a:off x="5303520" y="2189988"/>
-            <a:ext cx="3063240" cy="182880"/>
-          </a:xfrm>
-          <a:prstGeom prst="rect">
-            <a:avLst/>
-          </a:prstGeom>
-          <a:solidFill>
-            <a:srgbClr val="E8F4F3"/>
-          </a:solidFill>
-          <a:ln w="12700">
-            <a:solidFill>
-              <a:srgbClr val="DCE8EA"/>
-            </a:solidFill>
-            <a:prstDash val="solid"/>
-          </a:ln>
-        </p:spPr>
-      </p:sp>
-      <p:sp>
-        <p:nvSpPr>
-          <p:cNvPr id="24" name="Shape 22"/>
-          <p:cNvSpPr/>
-          <p:nvPr/>
-        </p:nvSpPr>
-        <p:spPr>
-          <a:xfrm>
-            <a:off x="7909560" y="2226564"/>
-            <a:ext cx="384048" cy="109728"/>
-          </a:xfrm>
-          <a:prstGeom prst="rect">
-            <a:avLst/>
-          </a:prstGeom>
-          <a:solidFill>
-            <a:srgbClr val="0E7C86"/>
-          </a:solidFill>
-          <a:ln w="12700">
-            <a:solidFill>
-              <a:srgbClr val="FFFFFF"/>
-            </a:solidFill>
-            <a:prstDash val="solid"/>
-          </a:ln>
-        </p:spPr>
-      </p:sp>
-      <p:sp>
-        <p:nvSpPr>
-          <p:cNvPr id="25" name="Shape 23"/>
-          <p:cNvSpPr/>
-          <p:nvPr/>
-        </p:nvSpPr>
-        <p:spPr>
-          <a:xfrm>
-            <a:off x="5303520" y="2418588"/>
-            <a:ext cx="3063240" cy="182880"/>
-          </a:xfrm>
-          <a:prstGeom prst="rect">
-            <a:avLst/>
-          </a:prstGeom>
-          <a:solidFill>
-            <a:srgbClr val="FFFFFF"/>
-          </a:solidFill>
-          <a:ln w="12700">
-            <a:solidFill>
-              <a:srgbClr val="DCE8EA"/>
-            </a:solidFill>
-            <a:prstDash val="solid"/>
-          </a:ln>
-        </p:spPr>
-      </p:sp>
-      <p:sp>
-        <p:nvSpPr>
-          <p:cNvPr id="26" name="Shape 24"/>
-          <p:cNvSpPr/>
-          <p:nvPr/>
-        </p:nvSpPr>
-        <p:spPr>
-          <a:xfrm>
-            <a:off x="7909560" y="2455164"/>
-            <a:ext cx="384048" cy="109728"/>
-          </a:xfrm>
-          <a:prstGeom prst="rect">
-            <a:avLst/>
-          </a:prstGeom>
-          <a:solidFill>
-            <a:srgbClr val="C8553D"/>
-          </a:solidFill>
-          <a:ln w="12700">
-            <a:solidFill>
-              <a:srgbClr val="FFFFFF"/>
-            </a:solidFill>
-            <a:prstDash val="solid"/>
-          </a:ln>
-        </p:spPr>
-      </p:sp>
-      <p:sp>
-        <p:nvSpPr>
-          <p:cNvPr id="29" name="Text 27"/>
-          <p:cNvSpPr txBox="1"/>
-          <p:nvPr/>
-        </p:nvSpPr>
-        <p:spPr>
-          <a:xfrm>
-            <a:off x="4672584" y="2748026"/>
-            <a:ext cx="3840480" cy="256032"/>
-          </a:xfrm>
-          <a:prstGeom prst="rect">
-            <a:avLst/>
-          </a:prstGeom>
-          <a:noFill/>
-          <a:ln/>
-        </p:spPr>
-        <p:txBody>
-          <a:bodyPr wrap="square" lIns="0" tIns="0" rIns="0" bIns="0" rtlCol="0" anchor="ctr"/>
-          <a:lstStyle/>
-          <a:p>
-            <a:pPr marL="0" indent="0" algn="ctr">
-              <a:buNone/>
-            </a:pPr>
-            <a:r>
-              <a:rPr lang="en-US" sz="1300" dirty="0">
-                <a:solidFill>
-                  <a:srgbClr val="5E7480"/>
-                </a:solidFill>
-                <a:latin typeface="Calibri" pitchFamily="34" charset="0"/>
-                <a:ea typeface="Calibri" pitchFamily="34" charset="-122"/>
-                <a:cs typeface="Calibri" pitchFamily="34" charset="-120"/>
-              </a:rPr>
-              <a:t>Jihozlar ro'yxati</a:t>
-            </a:r>
-            <a:endParaRPr lang="en-US" sz="1300" dirty="0"/>
-          </a:p>
-        </p:txBody>
-      </p:sp>
-      <p:sp>
-        <p:nvSpPr>
-          <p:cNvPr id="30" name="Shape 28"/>
-          <p:cNvSpPr/>
-          <p:nvPr/>
-        </p:nvSpPr>
-        <p:spPr>
-          <a:xfrm>
-            <a:off x="548640" y="3017520"/>
-            <a:ext cx="3840480" cy="1508760"/>
-          </a:xfrm>
-          <a:prstGeom prst="roundRect">
-            <a:avLst>
-              <a:gd name="adj" fmla="val 3636"/>
-            </a:avLst>
-          </a:prstGeom>
-          <a:solidFill>
-            <a:srgbClr val="FFFFFF"/>
-          </a:solidFill>
-          <a:ln w="12700">
-            <a:solidFill>
-              <a:srgbClr val="B8CED3"/>
-            </a:solidFill>
-            <a:prstDash val="solid"/>
-          </a:ln>
-        </p:spPr>
-      </p:sp>
-      <p:sp>
-        <p:nvSpPr>
-          <p:cNvPr id="31" name="Shape 29"/>
-          <p:cNvSpPr/>
-          <p:nvPr/>
-        </p:nvSpPr>
-        <p:spPr>
-          <a:xfrm>
-            <a:off x="557784" y="3026664"/>
-            <a:ext cx="3822192" cy="201168"/>
-          </a:xfrm>
-          <a:prstGeom prst="rect">
-            <a:avLst/>
-          </a:prstGeom>
-          <a:solidFill>
-            <a:srgbClr val="0B3C49"/>
-          </a:solidFill>
-          <a:ln w="12700">
-            <a:solidFill>
-              <a:srgbClr val="0B3C49"/>
-            </a:solidFill>
-            <a:prstDash val="solid"/>
-          </a:ln>
-        </p:spPr>
-      </p:sp>
-      <p:sp>
-        <p:nvSpPr>
-          <p:cNvPr id="32" name="Shape 30"/>
-          <p:cNvSpPr/>
-          <p:nvPr/>
-        </p:nvSpPr>
-        <p:spPr>
-          <a:xfrm>
-            <a:off x="557784" y="3227832"/>
-            <a:ext cx="502920" cy="1289304"/>
-          </a:xfrm>
-          <a:prstGeom prst="rect">
-            <a:avLst/>
-          </a:prstGeom>
-          <a:solidFill>
-            <a:srgbClr val="E8F4F3"/>
-          </a:solidFill>
-          <a:ln w="12700">
-            <a:solidFill>
-              <a:srgbClr val="E8F4F3"/>
-            </a:solidFill>
-            <a:prstDash val="solid"/>
-          </a:ln>
-        </p:spPr>
-      </p:sp>
-      <p:sp>
-        <p:nvSpPr>
-          <p:cNvPr id="33" name="Shape 31"/>
-          <p:cNvSpPr/>
-          <p:nvPr/>
-        </p:nvSpPr>
-        <p:spPr>
-          <a:xfrm>
-            <a:off x="1188720" y="3383280"/>
-            <a:ext cx="548640" cy="548640"/>
-          </a:xfrm>
-          <a:prstGeom prst="rect">
-            <a:avLst/>
-          </a:prstGeom>
-          <a:solidFill>
-            <a:srgbClr val="0B3C49"/>
-          </a:solidFill>
-          <a:ln w="12700">
-            <a:solidFill>
-              <a:srgbClr val="0B3C49"/>
-            </a:solidFill>
-            <a:prstDash val="solid"/>
-          </a:ln>
-        </p:spPr>
-      </p:sp>
-      <p:sp>
-        <p:nvSpPr>
-          <p:cNvPr id="34" name="Shape 32"/>
-          <p:cNvSpPr/>
-          <p:nvPr/>
-        </p:nvSpPr>
-        <p:spPr>
-          <a:xfrm>
-            <a:off x="1874520" y="3383280"/>
-            <a:ext cx="1225296" cy="91440"/>
+            <a:off x="521208" y="1115568"/>
+            <a:ext cx="3895344" cy="1426464"/>
           </a:xfrm>
           <a:prstGeom prst="rect">
             <a:avLst/>
@@ -10931,16 +10425,78 @@
           </a:ln>
         </p:spPr>
       </p:sp>
-      <p:sp>
-        <p:nvSpPr>
-          <p:cNvPr id="35" name="Shape 33"/>
+      <p:pic>
+        <p:nvPicPr>
+          <p:cNvPr id="4" name="Image 0" descr="screenshots/dashboard.png">    </p:cNvPr>
+          <p:cNvPicPr>
+            <a:picLocks noChangeAspect="1"/>
+          </p:cNvPicPr>
+          <p:nvPr/>
+        </p:nvPicPr>
+        <p:blipFill>
+          <a:blip r:embed="rId1"/>
+          <a:srcRect l="0" r="0" t="0" b="0"/>
+          <a:stretch/>
+        </p:blipFill>
+        <p:spPr>
+          <a:xfrm>
+            <a:off x="548640" y="1143000"/>
+            <a:ext cx="3840480" cy="1371600"/>
+          </a:xfrm>
+          <a:prstGeom prst="rect">
+            <a:avLst/>
+          </a:prstGeom>
+        </p:spPr>
+      </p:pic>
+      <p:sp>
+        <p:nvSpPr>
+          <p:cNvPr id="5" name="Text 2"/>
+          <p:cNvSpPr txBox="1"/>
+          <p:nvPr/>
+        </p:nvSpPr>
+        <p:spPr>
+          <a:xfrm>
+            <a:off x="548640" y="2587752"/>
+            <a:ext cx="3840480" cy="274320"/>
+          </a:xfrm>
+          <a:prstGeom prst="rect">
+            <a:avLst/>
+          </a:prstGeom>
+          <a:noFill/>
+          <a:ln/>
+        </p:spPr>
+        <p:txBody>
+          <a:bodyPr wrap="square" lIns="0" tIns="0" rIns="0" bIns="0" rtlCol="0" anchor="ctr"/>
+          <a:lstStyle/>
+          <a:p>
+            <a:pPr algn="ctr" indent="0" marL="0">
+              <a:buNone/>
+            </a:pPr>
+            <a:r>
+              <a:rPr lang="en-US" sz="1300" dirty="0">
+                <a:solidFill>
+                  <a:srgbClr val="5E7480"/>
+                </a:solidFill>
+                <a:latin typeface="Calibri" pitchFamily="34" charset="0"/>
+                <a:ea typeface="Calibri" pitchFamily="34" charset="-122"/>
+                <a:cs typeface="Calibri" pitchFamily="34" charset="-120"/>
+              </a:rPr>
+              <a:t>Dashboard</a:t>
+            </a:r>
+            <a:endParaRPr lang="en-US" sz="1300" dirty="0"/>
+          </a:p>
+        </p:txBody>
+      </p:sp>
+      <p:sp>
+        <p:nvSpPr>
+          <p:cNvPr id="6" name="Shape 3"/>
           <p:cNvSpPr/>
           <p:nvPr/>
         </p:nvSpPr>
         <p:spPr>
           <a:xfrm>
-            <a:off x="1874520" y="3538728"/>
-            <a:ext cx="1225296" cy="91440"/>
+            <a:off x="4636008" y="1115568"/>
+            <a:ext cx="3895344" cy="1426464"/>
           </a:xfrm>
           <a:prstGeom prst="rect">
             <a:avLst/>
@@ -10956,16 +10512,78 @@
           </a:ln>
         </p:spPr>
       </p:sp>
-      <p:sp>
-        <p:nvSpPr>
-          <p:cNvPr id="36" name="Shape 34"/>
+      <p:pic>
+        <p:nvPicPr>
+          <p:cNvPr id="7" name="Image 1" descr="screenshots/list.png">    </p:cNvPr>
+          <p:cNvPicPr>
+            <a:picLocks noChangeAspect="1"/>
+          </p:cNvPicPr>
+          <p:nvPr/>
+        </p:nvPicPr>
+        <p:blipFill>
+          <a:blip r:embed="rId2"/>
+          <a:srcRect l="0" r="0" t="0" b="0"/>
+          <a:stretch/>
+        </p:blipFill>
+        <p:spPr>
+          <a:xfrm>
+            <a:off x="4663440" y="1143000"/>
+            <a:ext cx="3840480" cy="1371600"/>
+          </a:xfrm>
+          <a:prstGeom prst="rect">
+            <a:avLst/>
+          </a:prstGeom>
+        </p:spPr>
+      </p:pic>
+      <p:sp>
+        <p:nvSpPr>
+          <p:cNvPr id="8" name="Text 4"/>
+          <p:cNvSpPr txBox="1"/>
+          <p:nvPr/>
+        </p:nvSpPr>
+        <p:spPr>
+          <a:xfrm>
+            <a:off x="4663440" y="2587752"/>
+            <a:ext cx="3840480" cy="274320"/>
+          </a:xfrm>
+          <a:prstGeom prst="rect">
+            <a:avLst/>
+          </a:prstGeom>
+          <a:noFill/>
+          <a:ln/>
+        </p:spPr>
+        <p:txBody>
+          <a:bodyPr wrap="square" lIns="0" tIns="0" rIns="0" bIns="0" rtlCol="0" anchor="ctr"/>
+          <a:lstStyle/>
+          <a:p>
+            <a:pPr algn="ctr" indent="0" marL="0">
+              <a:buNone/>
+            </a:pPr>
+            <a:r>
+              <a:rPr lang="en-US" sz="1300" dirty="0">
+                <a:solidFill>
+                  <a:srgbClr val="5E7480"/>
+                </a:solidFill>
+                <a:latin typeface="Calibri" pitchFamily="34" charset="0"/>
+                <a:ea typeface="Calibri" pitchFamily="34" charset="-122"/>
+                <a:cs typeface="Calibri" pitchFamily="34" charset="-120"/>
+              </a:rPr>
+              <a:t>Jihozlar ro'yxati</a:t>
+            </a:r>
+            <a:endParaRPr lang="en-US" sz="1300" dirty="0"/>
+          </a:p>
+        </p:txBody>
+      </p:sp>
+      <p:sp>
+        <p:nvSpPr>
+          <p:cNvPr id="9" name="Shape 5"/>
           <p:cNvSpPr/>
           <p:nvPr/>
         </p:nvSpPr>
         <p:spPr>
           <a:xfrm>
-            <a:off x="1874520" y="3694176"/>
-            <a:ext cx="1225296" cy="91440"/>
+            <a:off x="521208" y="3035808"/>
+            <a:ext cx="3895344" cy="1426464"/>
           </a:xfrm>
           <a:prstGeom prst="rect">
             <a:avLst/>
@@ -10981,16 +10599,78 @@
           </a:ln>
         </p:spPr>
       </p:sp>
-      <p:sp>
-        <p:nvSpPr>
-          <p:cNvPr id="37" name="Shape 35"/>
+      <p:pic>
+        <p:nvPicPr>
+          <p:cNvPr id="10" name="Image 2" descr="screenshots/detail.png">    </p:cNvPr>
+          <p:cNvPicPr>
+            <a:picLocks noChangeAspect="1"/>
+          </p:cNvPicPr>
+          <p:nvPr/>
+        </p:nvPicPr>
+        <p:blipFill>
+          <a:blip r:embed="rId3"/>
+          <a:srcRect l="0" r="0" t="0" b="0"/>
+          <a:stretch/>
+        </p:blipFill>
+        <p:spPr>
+          <a:xfrm>
+            <a:off x="548640" y="3063240"/>
+            <a:ext cx="3840480" cy="1371600"/>
+          </a:xfrm>
+          <a:prstGeom prst="rect">
+            <a:avLst/>
+          </a:prstGeom>
+        </p:spPr>
+      </p:pic>
+      <p:sp>
+        <p:nvSpPr>
+          <p:cNvPr id="11" name="Text 6"/>
+          <p:cNvSpPr txBox="1"/>
+          <p:nvPr/>
+        </p:nvSpPr>
+        <p:spPr>
+          <a:xfrm>
+            <a:off x="548640" y="4507992"/>
+            <a:ext cx="3840480" cy="274320"/>
+          </a:xfrm>
+          <a:prstGeom prst="rect">
+            <a:avLst/>
+          </a:prstGeom>
+          <a:noFill/>
+          <a:ln/>
+        </p:spPr>
+        <p:txBody>
+          <a:bodyPr wrap="square" lIns="0" tIns="0" rIns="0" bIns="0" rtlCol="0" anchor="ctr"/>
+          <a:lstStyle/>
+          <a:p>
+            <a:pPr algn="ctr" indent="0" marL="0">
+              <a:buNone/>
+            </a:pPr>
+            <a:r>
+              <a:rPr lang="en-US" sz="1300" dirty="0">
+                <a:solidFill>
+                  <a:srgbClr val="5E7480"/>
+                </a:solidFill>
+                <a:latin typeface="Calibri" pitchFamily="34" charset="0"/>
+                <a:ea typeface="Calibri" pitchFamily="34" charset="-122"/>
+                <a:cs typeface="Calibri" pitchFamily="34" charset="-120"/>
+              </a:rPr>
+              <a:t>Jihoz kartochkasi</a:t>
+            </a:r>
+            <a:endParaRPr lang="en-US" sz="1300" dirty="0"/>
+          </a:p>
+        </p:txBody>
+      </p:sp>
+      <p:sp>
+        <p:nvSpPr>
+          <p:cNvPr id="12" name="Shape 7"/>
           <p:cNvSpPr/>
           <p:nvPr/>
         </p:nvSpPr>
         <p:spPr>
           <a:xfrm>
-            <a:off x="1874520" y="3849624"/>
-            <a:ext cx="1225296" cy="91440"/>
+            <a:off x="4636008" y="3035808"/>
+            <a:ext cx="3895344" cy="1426464"/>
           </a:xfrm>
           <a:prstGeom prst="rect">
             <a:avLst/>
@@ -11006,371 +10686,51 @@
           </a:ln>
         </p:spPr>
       </p:sp>
-      <p:sp>
-        <p:nvSpPr>
-          <p:cNvPr id="38" name="Shape 36"/>
-          <p:cNvSpPr/>
-          <p:nvPr/>
-        </p:nvSpPr>
-        <p:spPr>
-          <a:xfrm>
-            <a:off x="1188720" y="4051300"/>
-            <a:ext cx="128016" cy="128016"/>
-          </a:xfrm>
-          <a:prstGeom prst="ellipse">
-            <a:avLst/>
-          </a:prstGeom>
-          <a:solidFill>
-            <a:srgbClr val="0E7C86"/>
-          </a:solidFill>
-          <a:ln w="12700">
-            <a:solidFill>
-              <a:srgbClr val="0E7C86"/>
-            </a:solidFill>
-            <a:prstDash val="solid"/>
-          </a:ln>
-        </p:spPr>
-      </p:sp>
-      <p:sp>
-        <p:nvSpPr>
-          <p:cNvPr id="39" name="Shape 37"/>
-          <p:cNvSpPr/>
-          <p:nvPr/>
-        </p:nvSpPr>
-        <p:spPr>
-          <a:xfrm>
-            <a:off x="1423670" y="4085082"/>
-            <a:ext cx="1837944" cy="73152"/>
-          </a:xfrm>
-          <a:prstGeom prst="rect">
-            <a:avLst/>
-          </a:prstGeom>
-          <a:solidFill>
-            <a:srgbClr val="B8CED3"/>
-          </a:solidFill>
-          <a:ln w="12700">
-            <a:solidFill>
-              <a:srgbClr val="B8CED3"/>
-            </a:solidFill>
-            <a:prstDash val="solid"/>
-          </a:ln>
-        </p:spPr>
-      </p:sp>
-      <p:sp>
-        <p:nvSpPr>
-          <p:cNvPr id="40" name="Shape 38"/>
-          <p:cNvSpPr/>
-          <p:nvPr/>
-        </p:nvSpPr>
-        <p:spPr>
-          <a:xfrm>
-            <a:off x="1188720" y="4250182"/>
-            <a:ext cx="128016" cy="128016"/>
-          </a:xfrm>
-          <a:prstGeom prst="ellipse">
-            <a:avLst/>
-          </a:prstGeom>
-          <a:solidFill>
-            <a:srgbClr val="0E7C86"/>
-          </a:solidFill>
-          <a:ln w="12700">
-            <a:solidFill>
-              <a:srgbClr val="0E7C86"/>
-            </a:solidFill>
-            <a:prstDash val="solid"/>
-          </a:ln>
-        </p:spPr>
-      </p:sp>
-      <p:sp>
-        <p:nvSpPr>
-          <p:cNvPr id="41" name="Shape 39"/>
-          <p:cNvSpPr/>
-          <p:nvPr/>
-        </p:nvSpPr>
-        <p:spPr>
-          <a:xfrm>
-            <a:off x="1417320" y="4271264"/>
-            <a:ext cx="1837944" cy="73152"/>
-          </a:xfrm>
-          <a:prstGeom prst="rect">
-            <a:avLst/>
-          </a:prstGeom>
-          <a:solidFill>
-            <a:srgbClr val="B8CED3"/>
-          </a:solidFill>
-          <a:ln w="12700">
-            <a:solidFill>
-              <a:srgbClr val="B8CED3"/>
-            </a:solidFill>
-            <a:prstDash val="solid"/>
-          </a:ln>
-        </p:spPr>
-      </p:sp>
-      <p:sp>
-        <p:nvSpPr>
-          <p:cNvPr id="44" name="Text 42"/>
-          <p:cNvSpPr txBox="1"/>
-          <p:nvPr/>
-        </p:nvSpPr>
-        <p:spPr>
-          <a:xfrm>
-            <a:off x="530352" y="4640580"/>
-            <a:ext cx="3840480" cy="256032"/>
-          </a:xfrm>
-          <a:prstGeom prst="rect">
-            <a:avLst/>
-          </a:prstGeom>
-          <a:noFill/>
-          <a:ln/>
-        </p:spPr>
-        <p:txBody>
-          <a:bodyPr wrap="square" lIns="0" tIns="0" rIns="0" bIns="0" rtlCol="0" anchor="ctr"/>
-          <a:lstStyle/>
-          <a:p>
-            <a:pPr marL="0" indent="0" algn="ctr">
-              <a:buNone/>
-            </a:pPr>
-            <a:r>
-              <a:rPr lang="en-US" sz="1300" dirty="0">
-                <a:solidFill>
-                  <a:srgbClr val="5E7480"/>
-                </a:solidFill>
-                <a:latin typeface="Calibri" pitchFamily="34" charset="0"/>
-                <a:ea typeface="Calibri" pitchFamily="34" charset="-122"/>
-                <a:cs typeface="Calibri" pitchFamily="34" charset="-120"/>
-              </a:rPr>
-              <a:t>Jihoz kartochkasi</a:t>
-            </a:r>
-            <a:endParaRPr lang="en-US" sz="1300" dirty="0"/>
-          </a:p>
-        </p:txBody>
-      </p:sp>
-      <p:sp>
-        <p:nvSpPr>
-          <p:cNvPr id="45" name="Shape 43"/>
-          <p:cNvSpPr/>
-          <p:nvPr/>
-        </p:nvSpPr>
-        <p:spPr>
-          <a:xfrm>
-            <a:off x="4663440" y="3017520"/>
-            <a:ext cx="3840480" cy="1508760"/>
-          </a:xfrm>
-          <a:prstGeom prst="roundRect">
-            <a:avLst>
-              <a:gd name="adj" fmla="val 3636"/>
-            </a:avLst>
-          </a:prstGeom>
-          <a:solidFill>
-            <a:srgbClr val="FFFFFF"/>
-          </a:solidFill>
-          <a:ln w="12700">
-            <a:solidFill>
-              <a:srgbClr val="B8CED3"/>
-            </a:solidFill>
-            <a:prstDash val="solid"/>
-          </a:ln>
-        </p:spPr>
-      </p:sp>
-      <p:sp>
-        <p:nvSpPr>
-          <p:cNvPr id="46" name="Shape 44"/>
-          <p:cNvSpPr/>
-          <p:nvPr/>
-        </p:nvSpPr>
-        <p:spPr>
-          <a:xfrm>
-            <a:off x="4672584" y="3026664"/>
-            <a:ext cx="3822192" cy="201168"/>
-          </a:xfrm>
-          <a:prstGeom prst="rect">
-            <a:avLst/>
-          </a:prstGeom>
-          <a:solidFill>
-            <a:srgbClr val="0B3C49"/>
-          </a:solidFill>
-          <a:ln w="12700">
-            <a:solidFill>
-              <a:srgbClr val="0B3C49"/>
-            </a:solidFill>
-            <a:prstDash val="solid"/>
-          </a:ln>
-        </p:spPr>
-      </p:sp>
-      <p:sp>
-        <p:nvSpPr>
-          <p:cNvPr id="47" name="Shape 45"/>
-          <p:cNvSpPr/>
-          <p:nvPr/>
-        </p:nvSpPr>
-        <p:spPr>
-          <a:xfrm>
-            <a:off x="4672584" y="3227832"/>
-            <a:ext cx="502920" cy="1289304"/>
-          </a:xfrm>
-          <a:prstGeom prst="rect">
-            <a:avLst/>
-          </a:prstGeom>
-          <a:solidFill>
-            <a:srgbClr val="E8F4F3"/>
-          </a:solidFill>
-          <a:ln w="12700">
-            <a:solidFill>
-              <a:srgbClr val="E8F4F3"/>
-            </a:solidFill>
-            <a:prstDash val="solid"/>
-          </a:ln>
-        </p:spPr>
-      </p:sp>
-      <p:sp>
-        <p:nvSpPr>
-          <p:cNvPr id="48" name="Shape 46"/>
-          <p:cNvSpPr/>
-          <p:nvPr/>
-        </p:nvSpPr>
-        <p:spPr>
-          <a:xfrm>
-            <a:off x="5303520" y="3383280"/>
-            <a:ext cx="1440180" cy="274320"/>
-          </a:xfrm>
-          <a:prstGeom prst="rect">
-            <a:avLst/>
-          </a:prstGeom>
-          <a:solidFill>
-            <a:srgbClr val="FFFFFF"/>
-          </a:solidFill>
-          <a:ln w="12700">
-            <a:solidFill>
-              <a:srgbClr val="8FB0B7"/>
-            </a:solidFill>
-            <a:prstDash val="solid"/>
-          </a:ln>
-        </p:spPr>
-      </p:sp>
-      <p:sp>
-        <p:nvSpPr>
-          <p:cNvPr id="49" name="Shape 47"/>
-          <p:cNvSpPr/>
-          <p:nvPr/>
-        </p:nvSpPr>
-        <p:spPr>
-          <a:xfrm>
-            <a:off x="6835140" y="3383280"/>
-            <a:ext cx="1440180" cy="274320"/>
-          </a:xfrm>
-          <a:prstGeom prst="rect">
-            <a:avLst/>
-          </a:prstGeom>
-          <a:solidFill>
-            <a:srgbClr val="FFFFFF"/>
-          </a:solidFill>
-          <a:ln w="12700">
-            <a:solidFill>
-              <a:srgbClr val="8FB0B7"/>
-            </a:solidFill>
-            <a:prstDash val="solid"/>
-          </a:ln>
-        </p:spPr>
-      </p:sp>
-      <p:sp>
-        <p:nvSpPr>
-          <p:cNvPr id="50" name="Shape 48"/>
-          <p:cNvSpPr/>
-          <p:nvPr/>
-        </p:nvSpPr>
-        <p:spPr>
-          <a:xfrm>
-            <a:off x="5303520" y="3794760"/>
-            <a:ext cx="1440180" cy="274320"/>
-          </a:xfrm>
-          <a:prstGeom prst="rect">
-            <a:avLst/>
-          </a:prstGeom>
-          <a:solidFill>
-            <a:srgbClr val="FFFFFF"/>
-          </a:solidFill>
-          <a:ln w="12700">
-            <a:solidFill>
-              <a:srgbClr val="8FB0B7"/>
-            </a:solidFill>
-            <a:prstDash val="solid"/>
-          </a:ln>
-        </p:spPr>
-      </p:sp>
-      <p:sp>
-        <p:nvSpPr>
-          <p:cNvPr id="51" name="Shape 49"/>
-          <p:cNvSpPr/>
-          <p:nvPr/>
-        </p:nvSpPr>
-        <p:spPr>
-          <a:xfrm>
-            <a:off x="6835140" y="3794760"/>
-            <a:ext cx="1440180" cy="274320"/>
-          </a:xfrm>
-          <a:prstGeom prst="rect">
-            <a:avLst/>
-          </a:prstGeom>
-          <a:solidFill>
-            <a:srgbClr val="FFFFFF"/>
-          </a:solidFill>
-          <a:ln w="12700">
-            <a:solidFill>
-              <a:srgbClr val="8FB0B7"/>
-            </a:solidFill>
-            <a:prstDash val="solid"/>
-          </a:ln>
-        </p:spPr>
-      </p:sp>
-      <p:sp>
-        <p:nvSpPr>
-          <p:cNvPr id="52" name="Shape 50"/>
-          <p:cNvSpPr/>
-          <p:nvPr/>
-        </p:nvSpPr>
-        <p:spPr>
-          <a:xfrm>
-            <a:off x="5303520" y="4236720"/>
-            <a:ext cx="822960" cy="256032"/>
-          </a:xfrm>
-          <a:prstGeom prst="roundRect">
-            <a:avLst>
-              <a:gd name="adj" fmla="val 17857"/>
-            </a:avLst>
-          </a:prstGeom>
-          <a:solidFill>
-            <a:srgbClr val="0E7C86"/>
-          </a:solidFill>
-          <a:ln w="12700">
-            <a:solidFill>
-              <a:srgbClr val="0E7C86"/>
-            </a:solidFill>
-            <a:prstDash val="solid"/>
-          </a:ln>
-        </p:spPr>
-      </p:sp>
-      <p:sp>
-        <p:nvSpPr>
-          <p:cNvPr id="53" name="Text 51"/>
-          <p:cNvSpPr txBox="1"/>
-          <p:nvPr/>
-        </p:nvSpPr>
-        <p:spPr>
-          <a:xfrm>
-            <a:off x="4663440" y="4572000"/>
-            <a:ext cx="3840480" cy="256032"/>
-          </a:xfrm>
-          <a:prstGeom prst="rect">
-            <a:avLst/>
-          </a:prstGeom>
-          <a:noFill/>
-          <a:ln/>
-        </p:spPr>
-        <p:txBody>
-          <a:bodyPr wrap="square" lIns="0" tIns="0" rIns="0" bIns="0" rtlCol="0" anchor="ctr"/>
-          <a:lstStyle/>
-          <a:p>
-            <a:pPr marL="0" indent="0" algn="ctr">
+      <p:pic>
+        <p:nvPicPr>
+          <p:cNvPr id="13" name="Image 3" descr="screenshots/form.png">    </p:cNvPr>
+          <p:cNvPicPr>
+            <a:picLocks noChangeAspect="1"/>
+          </p:cNvPicPr>
+          <p:nvPr/>
+        </p:nvPicPr>
+        <p:blipFill>
+          <a:blip r:embed="rId4"/>
+          <a:srcRect l="0" r="0" t="0" b="0"/>
+          <a:stretch/>
+        </p:blipFill>
+        <p:spPr>
+          <a:xfrm>
+            <a:off x="4663440" y="3063240"/>
+            <a:ext cx="3840480" cy="1371600"/>
+          </a:xfrm>
+          <a:prstGeom prst="rect">
+            <a:avLst/>
+          </a:prstGeom>
+        </p:spPr>
+      </p:pic>
+      <p:sp>
+        <p:nvSpPr>
+          <p:cNvPr id="14" name="Text 8"/>
+          <p:cNvSpPr txBox="1"/>
+          <p:nvPr/>
+        </p:nvSpPr>
+        <p:spPr>
+          <a:xfrm>
+            <a:off x="4663440" y="4507992"/>
+            <a:ext cx="3840480" cy="274320"/>
+          </a:xfrm>
+          <a:prstGeom prst="rect">
+            <a:avLst/>
+          </a:prstGeom>
+          <a:noFill/>
+          <a:ln/>
+        </p:spPr>
+        <p:txBody>
+          <a:bodyPr wrap="square" lIns="0" tIns="0" rIns="0" bIns="0" rtlCol="0" anchor="ctr"/>
+          <a:lstStyle/>
+          <a:p>
+            <a:pPr algn="ctr" indent="0" marL="0">
               <a:buNone/>
             </a:pPr>
             <a:r>
@@ -11404,7 +10764,6 @@
         <a:solidFill>
           <a:srgbClr val="FFFFFF"/>
         </a:solidFill>
-        <a:effectLst/>
       </p:bgPr>
     </p:bg>
     <p:spTree>
@@ -11442,7 +10801,7 @@
           <a:bodyPr wrap="square" lIns="0" tIns="0" rIns="0" bIns="0" rtlCol="0" anchor="ctr"/>
           <a:lstStyle/>
           <a:p>
-            <a:pPr marL="0" indent="0">
+            <a:pPr indent="0" marL="0">
               <a:buNone/>
             </a:pPr>
             <a:r>
@@ -11481,7 +10840,7 @@
           <a:bodyPr wrap="square" lIns="0" tIns="0" rIns="0" bIns="0" rtlCol="0" anchor="ctr"/>
           <a:lstStyle/>
           <a:p>
-            <a:pPr marL="0" indent="0">
+            <a:pPr indent="0" marL="0">
               <a:buNone/>
             </a:pPr>
             <a:r>
@@ -11543,7 +10902,7 @@
           <a:bodyPr wrap="square" lIns="0" tIns="0" rIns="0" bIns="0" rtlCol="0" anchor="ctr"/>
           <a:lstStyle/>
           <a:p>
-            <a:pPr marL="0" indent="0" algn="r">
+            <a:pPr algn="r" indent="0" marL="0">
               <a:buNone/>
             </a:pPr>
             <a:r>
@@ -11607,7 +10966,7 @@
           <a:bodyPr wrap="square" lIns="0" tIns="0" rIns="0" bIns="0" rtlCol="0" anchor="ctr"/>
           <a:lstStyle/>
           <a:p>
-            <a:pPr marL="0" indent="0">
+            <a:pPr indent="0" marL="0">
               <a:buNone/>
             </a:pPr>
             <a:r>
@@ -11621,6 +10980,9 @@
               </a:rPr>
               <a:t>Jihoz qo'shildi  </a:t>
             </a:r>
+            <a:pPr indent="0" marL="0">
+              <a:buNone/>
+            </a:pPr>
             <a:r>
               <a:rPr lang="en-US" sz="1600" dirty="0">
                 <a:solidFill>
@@ -11657,7 +11019,7 @@
           <a:bodyPr wrap="square" lIns="0" tIns="0" rIns="0" bIns="0" rtlCol="0" anchor="ctr"/>
           <a:lstStyle/>
           <a:p>
-            <a:pPr marL="0" indent="0" algn="r">
+            <a:pPr algn="r" indent="0" marL="0">
               <a:buNone/>
             </a:pPr>
             <a:r>
@@ -11721,7 +11083,7 @@
           <a:bodyPr wrap="square" lIns="0" tIns="0" rIns="0" bIns="0" rtlCol="0" anchor="ctr"/>
           <a:lstStyle/>
           <a:p>
-            <a:pPr marL="0" indent="0">
+            <a:pPr indent="0" marL="0">
               <a:buNone/>
             </a:pPr>
             <a:r>
@@ -11735,6 +11097,9 @@
               </a:rPr>
               <a:t>Ko'chirildi  </a:t>
             </a:r>
+            <a:pPr indent="0" marL="0">
+              <a:buNone/>
+            </a:pPr>
             <a:r>
               <a:rPr lang="en-US" sz="1600" dirty="0">
                 <a:solidFill>
@@ -11771,7 +11136,7 @@
           <a:bodyPr wrap="square" lIns="0" tIns="0" rIns="0" bIns="0" rtlCol="0" anchor="ctr"/>
           <a:lstStyle/>
           <a:p>
-            <a:pPr marL="0" indent="0" algn="r">
+            <a:pPr algn="r" indent="0" marL="0">
               <a:buNone/>
             </a:pPr>
             <a:r>
@@ -11835,7 +11200,7 @@
           <a:bodyPr wrap="square" lIns="0" tIns="0" rIns="0" bIns="0" rtlCol="0" anchor="ctr"/>
           <a:lstStyle/>
           <a:p>
-            <a:pPr marL="0" indent="0">
+            <a:pPr indent="0" marL="0">
               <a:buNone/>
             </a:pPr>
             <a:r>
@@ -11849,6 +11214,9 @@
               </a:rPr>
               <a:t>Mas'ul o'zgardi  </a:t>
             </a:r>
+            <a:pPr indent="0" marL="0">
+              <a:buNone/>
+            </a:pPr>
             <a:r>
               <a:rPr lang="en-US" sz="1600" dirty="0">
                 <a:solidFill>
@@ -11885,7 +11253,7 @@
           <a:bodyPr wrap="square" lIns="0" tIns="0" rIns="0" bIns="0" rtlCol="0" anchor="ctr"/>
           <a:lstStyle/>
           <a:p>
-            <a:pPr marL="0" indent="0" algn="r">
+            <a:pPr algn="r" indent="0" marL="0">
               <a:buNone/>
             </a:pPr>
             <a:r>
@@ -11949,7 +11317,7 @@
           <a:bodyPr wrap="square" lIns="0" tIns="0" rIns="0" bIns="0" rtlCol="0" anchor="ctr"/>
           <a:lstStyle/>
           <a:p>
-            <a:pPr marL="0" indent="0">
+            <a:pPr indent="0" marL="0">
               <a:buNone/>
             </a:pPr>
             <a:r>
@@ -11963,6 +11331,9 @@
               </a:rPr>
               <a:t>Ta'mirga yuborildi  </a:t>
             </a:r>
+            <a:pPr indent="0" marL="0">
+              <a:buNone/>
+            </a:pPr>
             <a:r>
               <a:rPr lang="en-US" sz="1600" dirty="0">
                 <a:solidFill>
@@ -11999,7 +11370,7 @@
           <a:bodyPr wrap="square" lIns="0" tIns="0" rIns="0" bIns="0" rtlCol="0" anchor="ctr"/>
           <a:lstStyle/>
           <a:p>
-            <a:pPr marL="0" indent="0" algn="r">
+            <a:pPr algn="r" indent="0" marL="0">
               <a:buNone/>
             </a:pPr>
             <a:r>
@@ -12063,7 +11434,7 @@
           <a:bodyPr wrap="square" lIns="0" tIns="0" rIns="0" bIns="0" rtlCol="0" anchor="ctr"/>
           <a:lstStyle/>
           <a:p>
-            <a:pPr marL="0" indent="0">
+            <a:pPr indent="0" marL="0">
               <a:buNone/>
             </a:pPr>
             <a:r>
@@ -12077,6 +11448,9 @@
               </a:rPr>
               <a:t>Ta'mirdan qaytdi  </a:t>
             </a:r>
+            <a:pPr indent="0" marL="0">
+              <a:buNone/>
+            </a:pPr>
             <a:r>
               <a:rPr lang="en-US" sz="1600" dirty="0">
                 <a:solidFill>
@@ -12108,7 +11482,6 @@
         <a:solidFill>
           <a:srgbClr val="0B3C49"/>
         </a:solidFill>
-        <a:effectLst/>
       </p:bgPr>
     </p:bg>
     <p:spTree>
@@ -12146,7 +11519,7 @@
           <a:bodyPr wrap="square" lIns="0" tIns="0" rIns="0" bIns="0" rtlCol="0" anchor="ctr"/>
           <a:lstStyle/>
           <a:p>
-            <a:pPr marL="0" indent="0">
+            <a:pPr indent="0" marL="0">
               <a:buNone/>
             </a:pPr>
             <a:r>
@@ -12239,7 +11612,7 @@
           <a:bodyPr wrap="square" lIns="0" tIns="0" rIns="0" bIns="0" rtlCol="0" anchor="ctr"/>
           <a:lstStyle/>
           <a:p>
-            <a:pPr marL="0" indent="0">
+            <a:pPr indent="0" marL="0">
               <a:buNone/>
             </a:pPr>
             <a:r>
@@ -12305,7 +11678,7 @@
           <a:bodyPr wrap="square" lIns="0" tIns="0" rIns="0" bIns="0" rtlCol="0" anchor="ctr"/>
           <a:lstStyle/>
           <a:p>
-            <a:pPr marL="0" indent="0">
+            <a:pPr indent="0" marL="0">
               <a:buNone/>
             </a:pPr>
             <a:r>
@@ -12344,7 +11717,7 @@
           <a:bodyPr wrap="square" lIns="0" tIns="0" rIns="0" bIns="0" rtlCol="0" anchor="ctr"/>
           <a:lstStyle/>
           <a:p>
-            <a:pPr marL="0" indent="0">
+            <a:pPr indent="0" marL="0">
               <a:buNone/>
             </a:pPr>
             <a:r>
@@ -12389,14 +11762,14 @@
       </p:sp>
       <p:pic>
         <p:nvPicPr>
-          <p:cNvPr id="10" name="Image 0" descr="preencoded.png"/>
+          <p:cNvPr id="10" name="Image 0" descr="preencoded.png">    </p:cNvPr>
           <p:cNvPicPr>
             <a:picLocks noChangeAspect="1"/>
           </p:cNvPicPr>
           <p:nvPr/>
         </p:nvPicPr>
         <p:blipFill>
-          <a:blip r:embed="rId3"/>
+          <a:blip r:embed="rId1"/>
           <a:stretch>
             <a:fillRect/>
           </a:stretch>
@@ -12432,7 +11805,7 @@
           <a:bodyPr wrap="square" lIns="0" tIns="0" rIns="0" bIns="0" rtlCol="0" anchor="ctr"/>
           <a:lstStyle/>
           <a:p>
-            <a:pPr marL="0" indent="0">
+            <a:pPr indent="0" marL="0">
               <a:buNone/>
             </a:pPr>
             <a:r>
@@ -12477,14 +11850,14 @@
       </p:sp>
       <p:pic>
         <p:nvPicPr>
-          <p:cNvPr id="13" name="Image 1" descr="preencoded.png"/>
+          <p:cNvPr id="13" name="Image 1" descr="preencoded.png">    </p:cNvPr>
           <p:cNvPicPr>
             <a:picLocks noChangeAspect="1"/>
           </p:cNvPicPr>
           <p:nvPr/>
         </p:nvPicPr>
         <p:blipFill>
-          <a:blip r:embed="rId4"/>
+          <a:blip r:embed="rId2"/>
           <a:stretch>
             <a:fillRect/>
           </a:stretch>
@@ -12520,7 +11893,7 @@
           <a:bodyPr wrap="square" lIns="0" tIns="0" rIns="0" bIns="0" rtlCol="0" anchor="ctr"/>
           <a:lstStyle/>
           <a:p>
-            <a:pPr marL="0" indent="0">
+            <a:pPr indent="0" marL="0">
               <a:buNone/>
             </a:pPr>
             <a:r>
@@ -12565,14 +11938,14 @@
       </p:sp>
       <p:pic>
         <p:nvPicPr>
-          <p:cNvPr id="16" name="Image 2" descr="preencoded.png"/>
+          <p:cNvPr id="16" name="Image 2" descr="preencoded.png">    </p:cNvPr>
           <p:cNvPicPr>
             <a:picLocks noChangeAspect="1"/>
           </p:cNvPicPr>
           <p:nvPr/>
         </p:nvPicPr>
         <p:blipFill>
-          <a:blip r:embed="rId5"/>
+          <a:blip r:embed="rId3"/>
           <a:stretch>
             <a:fillRect/>
           </a:stretch>
@@ -12608,7 +11981,7 @@
           <a:bodyPr wrap="square" lIns="0" tIns="0" rIns="0" bIns="0" rtlCol="0" anchor="ctr"/>
           <a:lstStyle/>
           <a:p>
-            <a:pPr marL="0" indent="0">
+            <a:pPr indent="0" marL="0">
               <a:buNone/>
             </a:pPr>
             <a:r>
@@ -12927,299 +12300,4 @@
     </a:ext>
   </a:extLst>
 </a:theme>
-</file>
-
-<file path=ppt/theme/theme2.xml><?xml version="1.0" encoding="utf-8"?>
-<a:theme xmlns:a="http://schemas.openxmlformats.org/drawingml/2006/main" name="Тема Office">
-  <a:themeElements>
-    <a:clrScheme name="Стандартная">
-      <a:dk1>
-        <a:sysClr val="windowText" lastClr="000000"/>
-      </a:dk1>
-      <a:lt1>
-        <a:sysClr val="window" lastClr="FFFFFF"/>
-      </a:lt1>
-      <a:dk2>
-        <a:srgbClr val="44546A"/>
-      </a:dk2>
-      <a:lt2>
-        <a:srgbClr val="E7E6E6"/>
-      </a:lt2>
-      <a:accent1>
-        <a:srgbClr val="4472C4"/>
-      </a:accent1>
-      <a:accent2>
-        <a:srgbClr val="ED7D31"/>
-      </a:accent2>
-      <a:accent3>
-        <a:srgbClr val="A5A5A5"/>
-      </a:accent3>
-      <a:accent4>
-        <a:srgbClr val="FFC000"/>
-      </a:accent4>
-      <a:accent5>
-        <a:srgbClr val="5B9BD5"/>
-      </a:accent5>
-      <a:accent6>
-        <a:srgbClr val="70AD47"/>
-      </a:accent6>
-      <a:hlink>
-        <a:srgbClr val="0563C1"/>
-      </a:hlink>
-      <a:folHlink>
-        <a:srgbClr val="954F72"/>
-      </a:folHlink>
-    </a:clrScheme>
-    <a:fontScheme name="Стандартная">
-      <a:majorFont>
-        <a:latin typeface="Calibri Light" panose="020F0302020204030204"/>
-        <a:ea typeface=""/>
-        <a:cs typeface=""/>
-        <a:font script="Jpan" typeface="游ゴシック Light"/>
-        <a:font script="Hang" typeface="맑은 고딕"/>
-        <a:font script="Hans" typeface="等线 Light"/>
-        <a:font script="Hant" typeface="新細明體"/>
-        <a:font script="Arab" typeface="Times New Roman"/>
-        <a:font script="Hebr" typeface="Times New Roman"/>
-        <a:font script="Thai" typeface="Angsana New"/>
-        <a:font script="Ethi" typeface="Nyala"/>
-        <a:font script="Beng" typeface="Vrinda"/>
-        <a:font script="Gujr" typeface="Shruti"/>
-        <a:font script="Khmr" typeface="MoolBoran"/>
-        <a:font script="Knda" typeface="Tunga"/>
-        <a:font script="Guru" typeface="Raavi"/>
-        <a:font script="Cans" typeface="Euphemia"/>
-        <a:font script="Cher" typeface="Plantagenet Cherokee"/>
-        <a:font script="Yiii" typeface="Microsoft Yi Baiti"/>
-        <a:font script="Tibt" typeface="Microsoft Himalaya"/>
-        <a:font script="Thaa" typeface="MV Boli"/>
-        <a:font script="Deva" typeface="Mangal"/>
-        <a:font script="Telu" typeface="Gautami"/>
-        <a:font script="Taml" typeface="Latha"/>
-        <a:font script="Syrc" typeface="Estrangelo Edessa"/>
-        <a:font script="Orya" typeface="Kalinga"/>
-        <a:font script="Mlym" typeface="Kartika"/>
-        <a:font script="Laoo" typeface="DokChampa"/>
-        <a:font script="Sinh" typeface="Iskoola Pota"/>
-        <a:font script="Mong" typeface="Mongolian Baiti"/>
-        <a:font script="Viet" typeface="Times New Roman"/>
-        <a:font script="Uigh" typeface="Microsoft Uighur"/>
-        <a:font script="Geor" typeface="Sylfaen"/>
-        <a:font script="Armn" typeface="Arial"/>
-        <a:font script="Bugi" typeface="Leelawadee UI"/>
-        <a:font script="Bopo" typeface="Microsoft JhengHei"/>
-        <a:font script="Java" typeface="Javanese Text"/>
-        <a:font script="Lisu" typeface="Segoe UI"/>
-        <a:font script="Mymr" typeface="Myanmar Text"/>
-        <a:font script="Nkoo" typeface="Ebrima"/>
-        <a:font script="Olck" typeface="Nirmala UI"/>
-        <a:font script="Osma" typeface="Ebrima"/>
-        <a:font script="Phag" typeface="Phagspa"/>
-        <a:font script="Syrn" typeface="Estrangelo Edessa"/>
-        <a:font script="Syrj" typeface="Estrangelo Edessa"/>
-        <a:font script="Syre" typeface="Estrangelo Edessa"/>
-        <a:font script="Sora" typeface="Nirmala UI"/>
-        <a:font script="Tale" typeface="Microsoft Tai Le"/>
-        <a:font script="Talu" typeface="Microsoft New Tai Lue"/>
-        <a:font script="Tfng" typeface="Ebrima"/>
-      </a:majorFont>
-      <a:minorFont>
-        <a:latin typeface="Calibri" panose="020F0502020204030204"/>
-        <a:ea typeface=""/>
-        <a:cs typeface=""/>
-        <a:font script="Jpan" typeface="游ゴシック"/>
-        <a:font script="Hang" typeface="맑은 고딕"/>
-        <a:font script="Hans" typeface="等线"/>
-        <a:font script="Hant" typeface="新細明體"/>
-        <a:font script="Arab" typeface="Arial"/>
-        <a:font script="Hebr" typeface="Arial"/>
-        <a:font script="Thai" typeface="Cordia New"/>
-        <a:font script="Ethi" typeface="Nyala"/>
-        <a:font script="Beng" typeface="Vrinda"/>
-        <a:font script="Gujr" typeface="Shruti"/>
-        <a:font script="Khmr" typeface="DaunPenh"/>
-        <a:font script="Knda" typeface="Tunga"/>
-        <a:font script="Guru" typeface="Raavi"/>
-        <a:font script="Cans" typeface="Euphemia"/>
-        <a:font script="Cher" typeface="Plantagenet Cherokee"/>
-        <a:font script="Yiii" typeface="Microsoft Yi Baiti"/>
-        <a:font script="Tibt" typeface="Microsoft Himalaya"/>
-        <a:font script="Thaa" typeface="MV Boli"/>
-        <a:font script="Deva" typeface="Mangal"/>
-        <a:font script="Telu" typeface="Gautami"/>
-        <a:font script="Taml" typeface="Latha"/>
-        <a:font script="Syrc" typeface="Estrangelo Edessa"/>
-        <a:font script="Orya" typeface="Kalinga"/>
-        <a:font script="Mlym" typeface="Kartika"/>
-        <a:font script="Laoo" typeface="DokChampa"/>
-        <a:font script="Sinh" typeface="Iskoola Pota"/>
-        <a:font script="Mong" typeface="Mongolian Baiti"/>
-        <a:font script="Viet" typeface="Arial"/>
-        <a:font script="Uigh" typeface="Microsoft Uighur"/>
-        <a:font script="Geor" typeface="Sylfaen"/>
-        <a:font script="Armn" typeface="Arial"/>
-        <a:font script="Bugi" typeface="Leelawadee UI"/>
-        <a:font script="Bopo" typeface="Microsoft JhengHei"/>
-        <a:font script="Java" typeface="Javanese Text"/>
-        <a:font script="Lisu" typeface="Segoe UI"/>
-        <a:font script="Mymr" typeface="Myanmar Text"/>
-        <a:font script="Nkoo" typeface="Ebrima"/>
-        <a:font script="Olck" typeface="Nirmala UI"/>
-        <a:font script="Osma" typeface="Ebrima"/>
-        <a:font script="Phag" typeface="Phagspa"/>
-        <a:font script="Syrn" typeface="Estrangelo Edessa"/>
-        <a:font script="Syrj" typeface="Estrangelo Edessa"/>
-        <a:font script="Syre" typeface="Estrangelo Edessa"/>
-        <a:font script="Sora" typeface="Nirmala UI"/>
-        <a:font script="Tale" typeface="Microsoft Tai Le"/>
-        <a:font script="Talu" typeface="Microsoft New Tai Lue"/>
-        <a:font script="Tfng" typeface="Ebrima"/>
-      </a:minorFont>
-    </a:fontScheme>
-    <a:fmtScheme name="Стандартная">
-      <a:fillStyleLst>
-        <a:solidFill>
-          <a:schemeClr val="phClr"/>
-        </a:solidFill>
-        <a:gradFill rotWithShape="1">
-          <a:gsLst>
-            <a:gs pos="0">
-              <a:schemeClr val="phClr">
-                <a:lumMod val="110000"/>
-                <a:satMod val="105000"/>
-                <a:tint val="67000"/>
-              </a:schemeClr>
-            </a:gs>
-            <a:gs pos="50000">
-              <a:schemeClr val="phClr">
-                <a:lumMod val="105000"/>
-                <a:satMod val="103000"/>
-                <a:tint val="73000"/>
-              </a:schemeClr>
-            </a:gs>
-            <a:gs pos="100000">
-              <a:schemeClr val="phClr">
-                <a:lumMod val="105000"/>
-                <a:satMod val="109000"/>
-                <a:tint val="81000"/>
-              </a:schemeClr>
-            </a:gs>
-          </a:gsLst>
-          <a:lin ang="5400000" scaled="0"/>
-        </a:gradFill>
-        <a:gradFill rotWithShape="1">
-          <a:gsLst>
-            <a:gs pos="0">
-              <a:schemeClr val="phClr">
-                <a:satMod val="103000"/>
-                <a:lumMod val="102000"/>
-                <a:tint val="94000"/>
-              </a:schemeClr>
-            </a:gs>
-            <a:gs pos="50000">
-              <a:schemeClr val="phClr">
-                <a:satMod val="110000"/>
-                <a:lumMod val="100000"/>
-                <a:shade val="100000"/>
-              </a:schemeClr>
-            </a:gs>
-            <a:gs pos="100000">
-              <a:schemeClr val="phClr">
-                <a:lumMod val="99000"/>
-                <a:satMod val="120000"/>
-                <a:shade val="78000"/>
-              </a:schemeClr>
-            </a:gs>
-          </a:gsLst>
-          <a:lin ang="5400000" scaled="0"/>
-        </a:gradFill>
-      </a:fillStyleLst>
-      <a:lnStyleLst>
-        <a:ln w="6350" cap="flat" cmpd="sng" algn="ctr">
-          <a:solidFill>
-            <a:schemeClr val="phClr"/>
-          </a:solidFill>
-          <a:prstDash val="solid"/>
-          <a:miter lim="800000"/>
-        </a:ln>
-        <a:ln w="12700" cap="flat" cmpd="sng" algn="ctr">
-          <a:solidFill>
-            <a:schemeClr val="phClr"/>
-          </a:solidFill>
-          <a:prstDash val="solid"/>
-          <a:miter lim="800000"/>
-        </a:ln>
-        <a:ln w="19050" cap="flat" cmpd="sng" algn="ctr">
-          <a:solidFill>
-            <a:schemeClr val="phClr"/>
-          </a:solidFill>
-          <a:prstDash val="solid"/>
-          <a:miter lim="800000"/>
-        </a:ln>
-      </a:lnStyleLst>
-      <a:effectStyleLst>
-        <a:effectStyle>
-          <a:effectLst/>
-        </a:effectStyle>
-        <a:effectStyle>
-          <a:effectLst/>
-        </a:effectStyle>
-        <a:effectStyle>
-          <a:effectLst>
-            <a:outerShdw blurRad="57150" dist="19050" dir="5400000" algn="ctr" rotWithShape="0">
-              <a:srgbClr val="000000">
-                <a:alpha val="63000"/>
-              </a:srgbClr>
-            </a:outerShdw>
-          </a:effectLst>
-        </a:effectStyle>
-      </a:effectStyleLst>
-      <a:bgFillStyleLst>
-        <a:solidFill>
-          <a:schemeClr val="phClr"/>
-        </a:solidFill>
-        <a:solidFill>
-          <a:schemeClr val="phClr">
-            <a:tint val="95000"/>
-            <a:satMod val="170000"/>
-          </a:schemeClr>
-        </a:solidFill>
-        <a:gradFill rotWithShape="1">
-          <a:gsLst>
-            <a:gs pos="0">
-              <a:schemeClr val="phClr">
-                <a:tint val="93000"/>
-                <a:satMod val="150000"/>
-                <a:shade val="98000"/>
-                <a:lumMod val="102000"/>
-              </a:schemeClr>
-            </a:gs>
-            <a:gs pos="50000">
-              <a:schemeClr val="phClr">
-                <a:tint val="98000"/>
-                <a:satMod val="130000"/>
-                <a:shade val="90000"/>
-                <a:lumMod val="103000"/>
-              </a:schemeClr>
-            </a:gs>
-            <a:gs pos="100000">
-              <a:schemeClr val="phClr">
-                <a:shade val="63000"/>
-                <a:satMod val="120000"/>
-              </a:schemeClr>
-            </a:gs>
-          </a:gsLst>
-          <a:lin ang="5400000" scaled="0"/>
-        </a:gradFill>
-      </a:bgFillStyleLst>
-    </a:fmtScheme>
-  </a:themeElements>
-  <a:objectDefaults/>
-  <a:extraClrSchemeLst/>
-  <a:extLst>
-    <a:ext uri="{05A4C25C-085E-4340-85A3-A5531E510DB2}">
-      <thm15:themeFamily xmlns:thm15="http://schemas.microsoft.com/office/thememl/2012/main" name="Office Theme" id="{62F939B6-93AF-4DB8-9C6B-D6C7DFDC589F}" vid="{4A3C46E8-61CC-4603-A589-7422A47A8E4A}"/>
-    </a:ext>
-  </a:extLst>
-</a:theme>
 </file>
</xml_diff>

<commit_message>
Prezentatsiya: 15-slaydda 6 ta jamoa a'zosi
Co-Authored-By: Claude Sonnet 5.5 <noreply@anthropic.com>
</commit_message>
<xml_diff>
--- a/presentation/InvenTrack-Pitch.pptx
+++ b/presentation/InvenTrack-Pitch.pptx
@@ -1045,7 +1045,7 @@
           <a:p>
             <a:r>
               <a:rPr lang="en-US" dirty="0"/>
-              <a:t>Jamoamiz 404 Found: dasturlash, dizayn va ma'lumotlar bo'yicha mutaxassislar. Biz tizimni pilot sifatida bitta bo'limda sinab ko'rishga tayyormiz.</a:t>
+              <a:t>Jamoamiz 404 Found, olti kishidan iborat. Nurmuhammad loyihani boshqaradi, Dalerbek arxitektura va AI yordamchi ustida ishladi, G'olibjon backend va xavfsizlikni, Sanobar frontendni qurdi, Feruza hisobot va ko'rsatkichlarni tahlil qildi, Atham testlash va hujjatlarni yuritdi. Biz tizimni pilot sifatida bitta bo'limda sinab ko'rishga tayyormiz.</a:t>
             </a:r>
             <a:endParaRPr lang="en-US" dirty="0"/>
           </a:p>
@@ -2396,7 +2396,7 @@
         <p:spPr>
           <a:xfrm>
             <a:off x="640080" y="3840480"/>
-            <a:ext cx="6400800" cy="731520"/>
+            <a:ext cx="7863840" cy="731520"/>
           </a:xfrm>
           <a:prstGeom prst="rect">
             <a:avLst/>
@@ -2429,7 +2429,7 @@
               <a:buNone/>
             </a:pPr>
             <a:r>
-              <a:rPr lang="en-US" sz="1600" dirty="0">
+              <a:rPr lang="en-US" sz="1300" dirty="0">
                 <a:solidFill>
                   <a:srgbClr val="FFFFFF"/>
                 </a:solidFill>
@@ -2437,7 +2437,7 @@
                 <a:ea typeface="Calibri" pitchFamily="34" charset="-122"/>
                 <a:cs typeface="Calibri" pitchFamily="34" charset="-120"/>
               </a:rPr>
-              <a:t>A'zo 1  ·  A'zo 2  ·  A'zo 3  ·  A'zo 4</a:t>
+              <a:t>Boynazarov N. · Artikmuratov D. · Ro’ziboyev G. · Yo’ldosheva S. · Eshnazarova F. · Tursunov A.</a:t>
             </a:r>
             <a:endParaRPr lang="en-US" sz="1600" dirty="0"/>
           </a:p>
@@ -6230,12 +6230,12 @@
         </p:nvSpPr>
         <p:spPr>
           <a:xfrm>
-            <a:off x="548640" y="1463040"/>
-            <a:ext cx="1920240" cy="2377440"/>
+            <a:off x="548640" y="1280160"/>
+            <a:ext cx="2560320" cy="1600200"/>
           </a:xfrm>
           <a:prstGeom prst="roundRect">
             <a:avLst>
-              <a:gd name="adj" fmla="val 5714"/>
+              <a:gd name="adj" fmla="val 6857"/>
             </a:avLst>
           </a:prstGeom>
           <a:solidFill>
@@ -6257,8 +6257,8 @@
         </p:nvSpPr>
         <p:spPr>
           <a:xfrm>
-            <a:off x="1051560" y="1691640"/>
-            <a:ext cx="914400" cy="914400"/>
+            <a:off x="731520" y="1463040"/>
+            <a:ext cx="548640" cy="548640"/>
           </a:xfrm>
           <a:prstGeom prst="ellipse">
             <a:avLst/>
@@ -6290,8 +6290,8 @@
         </p:blipFill>
         <p:spPr>
           <a:xfrm>
-            <a:off x="1280160" y="1920240"/>
-            <a:ext cx="457200" cy="457200"/>
+            <a:off x="868680" y="1600200"/>
+            <a:ext cx="274320" cy="274320"/>
           </a:xfrm>
           <a:prstGeom prst="rect">
             <a:avLst/>
@@ -6306,24 +6306,24 @@
         </p:nvSpPr>
         <p:spPr>
           <a:xfrm>
-            <a:off x="640080" y="2788920"/>
-            <a:ext cx="1737360" cy="411480"/>
-          </a:xfrm>
-          <a:prstGeom prst="rect">
-            <a:avLst/>
-          </a:prstGeom>
-          <a:noFill/>
-          <a:ln/>
-        </p:spPr>
-        <p:txBody>
-          <a:bodyPr wrap="square" lIns="0" tIns="0" rIns="0" bIns="0" rtlCol="0" anchor="ctr"/>
-          <a:lstStyle/>
-          <a:p>
-            <a:pPr algn="ctr" indent="0" marL="0">
-              <a:buNone/>
-            </a:pPr>
-            <a:r>
-              <a:rPr lang="en-US" sz="1800" b="1" dirty="0">
+            <a:off x="1417320" y="1417320"/>
+            <a:ext cx="1600200" cy="640080"/>
+          </a:xfrm>
+          <a:prstGeom prst="rect">
+            <a:avLst/>
+          </a:prstGeom>
+          <a:noFill/>
+          <a:ln/>
+        </p:spPr>
+        <p:txBody>
+          <a:bodyPr wrap="square" lIns="0" tIns="0" rIns="0" bIns="0" rtlCol="0" anchor="ctr"/>
+          <a:lstStyle/>
+          <a:p>
+            <a:pPr indent="0" marL="0">
+              <a:buNone/>
+            </a:pPr>
+            <a:r>
+              <a:rPr lang="en-US" sz="1300" b="1" dirty="0">
                 <a:solidFill>
                   <a:srgbClr val="0B3C49"/>
                 </a:solidFill>
@@ -6331,9 +6331,9 @@
                 <a:ea typeface="Calibri" pitchFamily="34" charset="-122"/>
                 <a:cs typeface="Calibri" pitchFamily="34" charset="-120"/>
               </a:rPr>
-              <a:t>A'zo 1</a:t>
-            </a:r>
-            <a:endParaRPr lang="en-US" sz="1800" dirty="0"/>
+              <a:t>Boynazarov Nurmuhammad</a:t>
+            </a:r>
+            <a:endParaRPr lang="en-US" sz="1300" dirty="0"/>
           </a:p>
         </p:txBody>
       </p:sp>
@@ -6345,24 +6345,63 @@
         </p:nvSpPr>
         <p:spPr>
           <a:xfrm>
-            <a:off x="640080" y="3200400"/>
-            <a:ext cx="1737360" cy="365760"/>
-          </a:xfrm>
-          <a:prstGeom prst="rect">
-            <a:avLst/>
-          </a:prstGeom>
-          <a:noFill/>
-          <a:ln/>
-        </p:spPr>
-        <p:txBody>
-          <a:bodyPr wrap="square" lIns="0" tIns="0" rIns="0" bIns="0" rtlCol="0" anchor="ctr"/>
-          <a:lstStyle/>
-          <a:p>
-            <a:pPr algn="ctr" indent="0" marL="0">
-              <a:buNone/>
-            </a:pPr>
-            <a:r>
-              <a:rPr lang="en-US" sz="1400" dirty="0">
+            <a:off x="731520" y="2148840"/>
+            <a:ext cx="2240280" cy="274320"/>
+          </a:xfrm>
+          <a:prstGeom prst="rect">
+            <a:avLst/>
+          </a:prstGeom>
+          <a:noFill/>
+          <a:ln/>
+        </p:spPr>
+        <p:txBody>
+          <a:bodyPr wrap="square" lIns="0" tIns="0" rIns="0" bIns="0" rtlCol="0" anchor="ctr"/>
+          <a:lstStyle/>
+          <a:p>
+            <a:pPr indent="0" marL="0">
+              <a:buNone/>
+            </a:pPr>
+            <a:r>
+              <a:rPr lang="en-US" sz="1300" b="1" dirty="0">
+                <a:solidFill>
+                  <a:srgbClr val="0E7C86"/>
+                </a:solidFill>
+                <a:latin typeface="Calibri" pitchFamily="34" charset="0"/>
+                <a:ea typeface="Calibri" pitchFamily="34" charset="-122"/>
+                <a:cs typeface="Calibri" pitchFamily="34" charset="-120"/>
+              </a:rPr>
+              <a:t>Project Manager</a:t>
+            </a:r>
+            <a:endParaRPr lang="en-US" sz="1300" dirty="0"/>
+          </a:p>
+        </p:txBody>
+      </p:sp>
+      <p:sp>
+        <p:nvSpPr>
+          <p:cNvPr id="8" name="Text 5"/>
+          <p:cNvSpPr txBox="1"/>
+          <p:nvPr/>
+        </p:nvSpPr>
+        <p:spPr>
+          <a:xfrm>
+            <a:off x="731520" y="2423160"/>
+            <a:ext cx="2240280" cy="411480"/>
+          </a:xfrm>
+          <a:prstGeom prst="rect">
+            <a:avLst/>
+          </a:prstGeom>
+          <a:noFill/>
+          <a:ln/>
+        </p:spPr>
+        <p:txBody>
+          <a:bodyPr wrap="square" lIns="0" tIns="0" rIns="0" bIns="0" rtlCol="0" anchor="ctr"/>
+          <a:lstStyle/>
+          <a:p>
+            <a:pPr indent="0" marL="0">
+              <a:buNone/>
+            </a:pPr>
+            <a:r>
+              <a:rPr lang="en-US" sz="1100" dirty="0">
                 <a:solidFill>
                   <a:srgbClr val="5E7480"/>
                 </a:solidFill>
@@ -6370,26 +6409,26 @@
                 <a:ea typeface="Calibri" pitchFamily="34" charset="-122"/>
                 <a:cs typeface="Calibri" pitchFamily="34" charset="-120"/>
               </a:rPr>
-              <a:t>Vazifasi</a:t>
-            </a:r>
-            <a:endParaRPr lang="en-US" sz="1400" dirty="0"/>
-          </a:p>
-        </p:txBody>
-      </p:sp>
-      <p:sp>
-        <p:nvSpPr>
-          <p:cNvPr id="8" name="Shape 5"/>
+              <a:t>Reja, vazifalar taqsimoti, muddat va taqdimot</a:t>
+            </a:r>
+            <a:endParaRPr lang="en-US" sz="1100" dirty="0"/>
+          </a:p>
+        </p:txBody>
+      </p:sp>
+      <p:sp>
+        <p:nvSpPr>
+          <p:cNvPr id="9" name="Shape 6"/>
           <p:cNvSpPr/>
           <p:nvPr/>
         </p:nvSpPr>
         <p:spPr>
           <a:xfrm>
-            <a:off x="2651760" y="1463040"/>
-            <a:ext cx="1920240" cy="2377440"/>
+            <a:off x="3291840" y="1280160"/>
+            <a:ext cx="2560320" cy="1600200"/>
           </a:xfrm>
           <a:prstGeom prst="roundRect">
             <a:avLst>
-              <a:gd name="adj" fmla="val 5714"/>
+              <a:gd name="adj" fmla="val 6857"/>
             </a:avLst>
           </a:prstGeom>
           <a:solidFill>
@@ -6405,14 +6444,14 @@
       </p:sp>
       <p:sp>
         <p:nvSpPr>
-          <p:cNvPr id="9" name="Shape 6"/>
+          <p:cNvPr id="10" name="Shape 7"/>
           <p:cNvSpPr/>
           <p:nvPr/>
         </p:nvSpPr>
         <p:spPr>
           <a:xfrm>
-            <a:off x="3154680" y="1691640"/>
-            <a:ext cx="914400" cy="914400"/>
+            <a:off x="3474720" y="1463040"/>
+            <a:ext cx="548640" cy="548640"/>
           </a:xfrm>
           <a:prstGeom prst="ellipse">
             <a:avLst/>
@@ -6430,7 +6469,7 @@
       </p:sp>
       <p:pic>
         <p:nvPicPr>
-          <p:cNvPr id="10" name="Image 1" descr="preencoded.png">    </p:cNvPr>
+          <p:cNvPr id="11" name="Image 1" descr="preencoded.png">    </p:cNvPr>
           <p:cNvPicPr>
             <a:picLocks noChangeAspect="1"/>
           </p:cNvPicPr>
@@ -6444,8 +6483,8 @@
         </p:blipFill>
         <p:spPr>
           <a:xfrm>
-            <a:off x="3383280" y="1920240"/>
-            <a:ext cx="457200" cy="457200"/>
+            <a:off x="3611880" y="1600200"/>
+            <a:ext cx="274320" cy="274320"/>
           </a:xfrm>
           <a:prstGeom prst="rect">
             <a:avLst/>
@@ -6454,30 +6493,30 @@
       </p:pic>
       <p:sp>
         <p:nvSpPr>
-          <p:cNvPr id="11" name="Text 7"/>
-          <p:cNvSpPr txBox="1"/>
-          <p:nvPr/>
-        </p:nvSpPr>
-        <p:spPr>
-          <a:xfrm>
-            <a:off x="2743200" y="2788920"/>
-            <a:ext cx="1737360" cy="411480"/>
-          </a:xfrm>
-          <a:prstGeom prst="rect">
-            <a:avLst/>
-          </a:prstGeom>
-          <a:noFill/>
-          <a:ln/>
-        </p:spPr>
-        <p:txBody>
-          <a:bodyPr wrap="square" lIns="0" tIns="0" rIns="0" bIns="0" rtlCol="0" anchor="ctr"/>
-          <a:lstStyle/>
-          <a:p>
-            <a:pPr algn="ctr" indent="0" marL="0">
-              <a:buNone/>
-            </a:pPr>
-            <a:r>
-              <a:rPr lang="en-US" sz="1800" b="1" dirty="0">
+          <p:cNvPr id="12" name="Text 8"/>
+          <p:cNvSpPr txBox="1"/>
+          <p:nvPr/>
+        </p:nvSpPr>
+        <p:spPr>
+          <a:xfrm>
+            <a:off x="4160520" y="1417320"/>
+            <a:ext cx="1600200" cy="640080"/>
+          </a:xfrm>
+          <a:prstGeom prst="rect">
+            <a:avLst/>
+          </a:prstGeom>
+          <a:noFill/>
+          <a:ln/>
+        </p:spPr>
+        <p:txBody>
+          <a:bodyPr wrap="square" lIns="0" tIns="0" rIns="0" bIns="0" rtlCol="0" anchor="ctr"/>
+          <a:lstStyle/>
+          <a:p>
+            <a:pPr indent="0" marL="0">
+              <a:buNone/>
+            </a:pPr>
+            <a:r>
+              <a:rPr lang="en-US" sz="1300" b="1" dirty="0">
                 <a:solidFill>
                   <a:srgbClr val="0B3C49"/>
                 </a:solidFill>
@@ -6485,38 +6524,77 @@
                 <a:ea typeface="Calibri" pitchFamily="34" charset="-122"/>
                 <a:cs typeface="Calibri" pitchFamily="34" charset="-120"/>
               </a:rPr>
-              <a:t>A'zo 2</a:t>
-            </a:r>
-            <a:endParaRPr lang="en-US" sz="1800" dirty="0"/>
-          </a:p>
-        </p:txBody>
-      </p:sp>
-      <p:sp>
-        <p:nvSpPr>
-          <p:cNvPr id="12" name="Text 8"/>
-          <p:cNvSpPr txBox="1"/>
-          <p:nvPr/>
-        </p:nvSpPr>
-        <p:spPr>
-          <a:xfrm>
-            <a:off x="2743200" y="3200400"/>
-            <a:ext cx="1737360" cy="365760"/>
-          </a:xfrm>
-          <a:prstGeom prst="rect">
-            <a:avLst/>
-          </a:prstGeom>
-          <a:noFill/>
-          <a:ln/>
-        </p:spPr>
-        <p:txBody>
-          <a:bodyPr wrap="square" lIns="0" tIns="0" rIns="0" bIns="0" rtlCol="0" anchor="ctr"/>
-          <a:lstStyle/>
-          <a:p>
-            <a:pPr algn="ctr" indent="0" marL="0">
-              <a:buNone/>
-            </a:pPr>
-            <a:r>
-              <a:rPr lang="en-US" sz="1400" dirty="0">
+              <a:t>Dalerbek Artikmuratov</a:t>
+            </a:r>
+            <a:endParaRPr lang="en-US" sz="1300" dirty="0"/>
+          </a:p>
+        </p:txBody>
+      </p:sp>
+      <p:sp>
+        <p:nvSpPr>
+          <p:cNvPr id="13" name="Text 9"/>
+          <p:cNvSpPr txBox="1"/>
+          <p:nvPr/>
+        </p:nvSpPr>
+        <p:spPr>
+          <a:xfrm>
+            <a:off x="3474720" y="2148840"/>
+            <a:ext cx="2240280" cy="274320"/>
+          </a:xfrm>
+          <a:prstGeom prst="rect">
+            <a:avLst/>
+          </a:prstGeom>
+          <a:noFill/>
+          <a:ln/>
+        </p:spPr>
+        <p:txBody>
+          <a:bodyPr wrap="square" lIns="0" tIns="0" rIns="0" bIns="0" rtlCol="0" anchor="ctr"/>
+          <a:lstStyle/>
+          <a:p>
+            <a:pPr indent="0" marL="0">
+              <a:buNone/>
+            </a:pPr>
+            <a:r>
+              <a:rPr lang="en-US" sz="1300" b="1" dirty="0">
+                <a:solidFill>
+                  <a:srgbClr val="0E7C86"/>
+                </a:solidFill>
+                <a:latin typeface="Calibri" pitchFamily="34" charset="0"/>
+                <a:ea typeface="Calibri" pitchFamily="34" charset="-122"/>
+                <a:cs typeface="Calibri" pitchFamily="34" charset="-120"/>
+              </a:rPr>
+              <a:t>Full-Stack va AI Engineer</a:t>
+            </a:r>
+            <a:endParaRPr lang="en-US" sz="1300" dirty="0"/>
+          </a:p>
+        </p:txBody>
+      </p:sp>
+      <p:sp>
+        <p:nvSpPr>
+          <p:cNvPr id="14" name="Text 10"/>
+          <p:cNvSpPr txBox="1"/>
+          <p:nvPr/>
+        </p:nvSpPr>
+        <p:spPr>
+          <a:xfrm>
+            <a:off x="3474720" y="2423160"/>
+            <a:ext cx="2240280" cy="411480"/>
+          </a:xfrm>
+          <a:prstGeom prst="rect">
+            <a:avLst/>
+          </a:prstGeom>
+          <a:noFill/>
+          <a:ln/>
+        </p:spPr>
+        <p:txBody>
+          <a:bodyPr wrap="square" lIns="0" tIns="0" rIns="0" bIns="0" rtlCol="0" anchor="ctr"/>
+          <a:lstStyle/>
+          <a:p>
+            <a:pPr indent="0" marL="0">
+              <a:buNone/>
+            </a:pPr>
+            <a:r>
+              <a:rPr lang="en-US" sz="1100" dirty="0">
                 <a:solidFill>
                   <a:srgbClr val="5E7480"/>
                 </a:solidFill>
@@ -6524,26 +6602,26 @@
                 <a:ea typeface="Calibri" pitchFamily="34" charset="-122"/>
                 <a:cs typeface="Calibri" pitchFamily="34" charset="-120"/>
               </a:rPr>
-              <a:t>Vazifasi</a:t>
-            </a:r>
-            <a:endParaRPr lang="en-US" sz="1400" dirty="0"/>
-          </a:p>
-        </p:txBody>
-      </p:sp>
-      <p:sp>
-        <p:nvSpPr>
-          <p:cNvPr id="13" name="Shape 9"/>
+              <a:t>Arxitektura, integratsiya, AI yordamchi</a:t>
+            </a:r>
+            <a:endParaRPr lang="en-US" sz="1100" dirty="0"/>
+          </a:p>
+        </p:txBody>
+      </p:sp>
+      <p:sp>
+        <p:nvSpPr>
+          <p:cNvPr id="15" name="Shape 11"/>
           <p:cNvSpPr/>
           <p:nvPr/>
         </p:nvSpPr>
         <p:spPr>
           <a:xfrm>
-            <a:off x="4754880" y="1463040"/>
-            <a:ext cx="1920240" cy="2377440"/>
+            <a:off x="6035040" y="1280160"/>
+            <a:ext cx="2560320" cy="1600200"/>
           </a:xfrm>
           <a:prstGeom prst="roundRect">
             <a:avLst>
-              <a:gd name="adj" fmla="val 5714"/>
+              <a:gd name="adj" fmla="val 6857"/>
             </a:avLst>
           </a:prstGeom>
           <a:solidFill>
@@ -6559,14 +6637,14 @@
       </p:sp>
       <p:sp>
         <p:nvSpPr>
-          <p:cNvPr id="14" name="Shape 10"/>
+          <p:cNvPr id="16" name="Shape 12"/>
           <p:cNvSpPr/>
           <p:nvPr/>
         </p:nvSpPr>
         <p:spPr>
           <a:xfrm>
-            <a:off x="5257800" y="1691640"/>
-            <a:ext cx="914400" cy="914400"/>
+            <a:off x="6217920" y="1463040"/>
+            <a:ext cx="548640" cy="548640"/>
           </a:xfrm>
           <a:prstGeom prst="ellipse">
             <a:avLst/>
@@ -6584,7 +6662,7 @@
       </p:sp>
       <p:pic>
         <p:nvPicPr>
-          <p:cNvPr id="15" name="Image 2" descr="preencoded.png">    </p:cNvPr>
+          <p:cNvPr id="17" name="Image 2" descr="preencoded.png">    </p:cNvPr>
           <p:cNvPicPr>
             <a:picLocks noChangeAspect="1"/>
           </p:cNvPicPr>
@@ -6598,8 +6676,8 @@
         </p:blipFill>
         <p:spPr>
           <a:xfrm>
-            <a:off x="5486400" y="1920240"/>
-            <a:ext cx="457200" cy="457200"/>
+            <a:off x="6355080" y="1600200"/>
+            <a:ext cx="274320" cy="274320"/>
           </a:xfrm>
           <a:prstGeom prst="rect">
             <a:avLst/>
@@ -6608,30 +6686,30 @@
       </p:pic>
       <p:sp>
         <p:nvSpPr>
-          <p:cNvPr id="16" name="Text 11"/>
-          <p:cNvSpPr txBox="1"/>
-          <p:nvPr/>
-        </p:nvSpPr>
-        <p:spPr>
-          <a:xfrm>
-            <a:off x="4846320" y="2788920"/>
-            <a:ext cx="1737360" cy="411480"/>
-          </a:xfrm>
-          <a:prstGeom prst="rect">
-            <a:avLst/>
-          </a:prstGeom>
-          <a:noFill/>
-          <a:ln/>
-        </p:spPr>
-        <p:txBody>
-          <a:bodyPr wrap="square" lIns="0" tIns="0" rIns="0" bIns="0" rtlCol="0" anchor="ctr"/>
-          <a:lstStyle/>
-          <a:p>
-            <a:pPr algn="ctr" indent="0" marL="0">
-              <a:buNone/>
-            </a:pPr>
-            <a:r>
-              <a:rPr lang="en-US" sz="1800" b="1" dirty="0">
+          <p:cNvPr id="18" name="Text 13"/>
+          <p:cNvSpPr txBox="1"/>
+          <p:nvPr/>
+        </p:nvSpPr>
+        <p:spPr>
+          <a:xfrm>
+            <a:off x="6903720" y="1417320"/>
+            <a:ext cx="1600200" cy="640080"/>
+          </a:xfrm>
+          <a:prstGeom prst="rect">
+            <a:avLst/>
+          </a:prstGeom>
+          <a:noFill/>
+          <a:ln/>
+        </p:spPr>
+        <p:txBody>
+          <a:bodyPr wrap="square" lIns="0" tIns="0" rIns="0" bIns="0" rtlCol="0" anchor="ctr"/>
+          <a:lstStyle/>
+          <a:p>
+            <a:pPr indent="0" marL="0">
+              <a:buNone/>
+            </a:pPr>
+            <a:r>
+              <a:rPr lang="en-US" sz="1300" b="1" dirty="0">
                 <a:solidFill>
                   <a:srgbClr val="0B3C49"/>
                 </a:solidFill>
@@ -6639,38 +6717,77 @@
                 <a:ea typeface="Calibri" pitchFamily="34" charset="-122"/>
                 <a:cs typeface="Calibri" pitchFamily="34" charset="-120"/>
               </a:rPr>
-              <a:t>A'zo 3</a:t>
-            </a:r>
-            <a:endParaRPr lang="en-US" sz="1800" dirty="0"/>
-          </a:p>
-        </p:txBody>
-      </p:sp>
-      <p:sp>
-        <p:nvSpPr>
-          <p:cNvPr id="17" name="Text 12"/>
-          <p:cNvSpPr txBox="1"/>
-          <p:nvPr/>
-        </p:nvSpPr>
-        <p:spPr>
-          <a:xfrm>
-            <a:off x="4846320" y="3200400"/>
-            <a:ext cx="1737360" cy="365760"/>
-          </a:xfrm>
-          <a:prstGeom prst="rect">
-            <a:avLst/>
-          </a:prstGeom>
-          <a:noFill/>
-          <a:ln/>
-        </p:spPr>
-        <p:txBody>
-          <a:bodyPr wrap="square" lIns="0" tIns="0" rIns="0" bIns="0" rtlCol="0" anchor="ctr"/>
-          <a:lstStyle/>
-          <a:p>
-            <a:pPr algn="ctr" indent="0" marL="0">
-              <a:buNone/>
-            </a:pPr>
-            <a:r>
-              <a:rPr lang="en-US" sz="1400" dirty="0">
+              <a:t>Ro’ziboyev G’olibjon</a:t>
+            </a:r>
+            <a:endParaRPr lang="en-US" sz="1300" dirty="0"/>
+          </a:p>
+        </p:txBody>
+      </p:sp>
+      <p:sp>
+        <p:nvSpPr>
+          <p:cNvPr id="19" name="Text 14"/>
+          <p:cNvSpPr txBox="1"/>
+          <p:nvPr/>
+        </p:nvSpPr>
+        <p:spPr>
+          <a:xfrm>
+            <a:off x="6217920" y="2148840"/>
+            <a:ext cx="2240280" cy="274320"/>
+          </a:xfrm>
+          <a:prstGeom prst="rect">
+            <a:avLst/>
+          </a:prstGeom>
+          <a:noFill/>
+          <a:ln/>
+        </p:spPr>
+        <p:txBody>
+          <a:bodyPr wrap="square" lIns="0" tIns="0" rIns="0" bIns="0" rtlCol="0" anchor="ctr"/>
+          <a:lstStyle/>
+          <a:p>
+            <a:pPr indent="0" marL="0">
+              <a:buNone/>
+            </a:pPr>
+            <a:r>
+              <a:rPr lang="en-US" sz="1300" b="1" dirty="0">
+                <a:solidFill>
+                  <a:srgbClr val="0E7C86"/>
+                </a:solidFill>
+                <a:latin typeface="Calibri" pitchFamily="34" charset="0"/>
+                <a:ea typeface="Calibri" pitchFamily="34" charset="-122"/>
+                <a:cs typeface="Calibri" pitchFamily="34" charset="-120"/>
+              </a:rPr>
+              <a:t>Backend Developer</a:t>
+            </a:r>
+            <a:endParaRPr lang="en-US" sz="1300" dirty="0"/>
+          </a:p>
+        </p:txBody>
+      </p:sp>
+      <p:sp>
+        <p:nvSpPr>
+          <p:cNvPr id="20" name="Text 15"/>
+          <p:cNvSpPr txBox="1"/>
+          <p:nvPr/>
+        </p:nvSpPr>
+        <p:spPr>
+          <a:xfrm>
+            <a:off x="6217920" y="2423160"/>
+            <a:ext cx="2240280" cy="411480"/>
+          </a:xfrm>
+          <a:prstGeom prst="rect">
+            <a:avLst/>
+          </a:prstGeom>
+          <a:noFill/>
+          <a:ln/>
+        </p:spPr>
+        <p:txBody>
+          <a:bodyPr wrap="square" lIns="0" tIns="0" rIns="0" bIns="0" rtlCol="0" anchor="ctr"/>
+          <a:lstStyle/>
+          <a:p>
+            <a:pPr indent="0" marL="0">
+              <a:buNone/>
+            </a:pPr>
+            <a:r>
+              <a:rPr lang="en-US" sz="1100" dirty="0">
                 <a:solidFill>
                   <a:srgbClr val="5E7480"/>
                 </a:solidFill>
@@ -6678,26 +6795,26 @@
                 <a:ea typeface="Calibri" pitchFamily="34" charset="-122"/>
                 <a:cs typeface="Calibri" pitchFamily="34" charset="-120"/>
               </a:rPr>
-              <a:t>Vazifasi</a:t>
-            </a:r>
-            <a:endParaRPr lang="en-US" sz="1400" dirty="0"/>
-          </a:p>
-        </p:txBody>
-      </p:sp>
-      <p:sp>
-        <p:nvSpPr>
-          <p:cNvPr id="18" name="Shape 13"/>
+              <a:t>API, ma'lumotlar bazasi, xavfsizlik</a:t>
+            </a:r>
+            <a:endParaRPr lang="en-US" sz="1100" dirty="0"/>
+          </a:p>
+        </p:txBody>
+      </p:sp>
+      <p:sp>
+        <p:nvSpPr>
+          <p:cNvPr id="21" name="Shape 16"/>
           <p:cNvSpPr/>
           <p:nvPr/>
         </p:nvSpPr>
         <p:spPr>
           <a:xfrm>
-            <a:off x="6858000" y="1463040"/>
-            <a:ext cx="1920240" cy="2377440"/>
+            <a:off x="548640" y="3063240"/>
+            <a:ext cx="2560320" cy="1600200"/>
           </a:xfrm>
           <a:prstGeom prst="roundRect">
             <a:avLst>
-              <a:gd name="adj" fmla="val 5714"/>
+              <a:gd name="adj" fmla="val 6857"/>
             </a:avLst>
           </a:prstGeom>
           <a:solidFill>
@@ -6713,14 +6830,14 @@
       </p:sp>
       <p:sp>
         <p:nvSpPr>
-          <p:cNvPr id="19" name="Shape 14"/>
+          <p:cNvPr id="22" name="Shape 17"/>
           <p:cNvSpPr/>
           <p:nvPr/>
         </p:nvSpPr>
         <p:spPr>
           <a:xfrm>
-            <a:off x="7360920" y="1691640"/>
-            <a:ext cx="914400" cy="914400"/>
+            <a:off x="731520" y="3246120"/>
+            <a:ext cx="548640" cy="548640"/>
           </a:xfrm>
           <a:prstGeom prst="ellipse">
             <a:avLst/>
@@ -6738,7 +6855,7 @@
       </p:sp>
       <p:pic>
         <p:nvPicPr>
-          <p:cNvPr id="20" name="Image 3" descr="preencoded.png">    </p:cNvPr>
+          <p:cNvPr id="23" name="Image 3" descr="preencoded.png">    </p:cNvPr>
           <p:cNvPicPr>
             <a:picLocks noChangeAspect="1"/>
           </p:cNvPicPr>
@@ -6752,8 +6869,8 @@
         </p:blipFill>
         <p:spPr>
           <a:xfrm>
-            <a:off x="7589520" y="1920240"/>
-            <a:ext cx="457200" cy="457200"/>
+            <a:off x="868680" y="3383280"/>
+            <a:ext cx="274320" cy="274320"/>
           </a:xfrm>
           <a:prstGeom prst="rect">
             <a:avLst/>
@@ -6762,30 +6879,30 @@
       </p:pic>
       <p:sp>
         <p:nvSpPr>
-          <p:cNvPr id="21" name="Text 15"/>
-          <p:cNvSpPr txBox="1"/>
-          <p:nvPr/>
-        </p:nvSpPr>
-        <p:spPr>
-          <a:xfrm>
-            <a:off x="6949440" y="2788920"/>
-            <a:ext cx="1737360" cy="411480"/>
-          </a:xfrm>
-          <a:prstGeom prst="rect">
-            <a:avLst/>
-          </a:prstGeom>
-          <a:noFill/>
-          <a:ln/>
-        </p:spPr>
-        <p:txBody>
-          <a:bodyPr wrap="square" lIns="0" tIns="0" rIns="0" bIns="0" rtlCol="0" anchor="ctr"/>
-          <a:lstStyle/>
-          <a:p>
-            <a:pPr algn="ctr" indent="0" marL="0">
-              <a:buNone/>
-            </a:pPr>
-            <a:r>
-              <a:rPr lang="en-US" sz="1800" b="1" dirty="0">
+          <p:cNvPr id="24" name="Text 18"/>
+          <p:cNvSpPr txBox="1"/>
+          <p:nvPr/>
+        </p:nvSpPr>
+        <p:spPr>
+          <a:xfrm>
+            <a:off x="1417320" y="3200400"/>
+            <a:ext cx="1600200" cy="640080"/>
+          </a:xfrm>
+          <a:prstGeom prst="rect">
+            <a:avLst/>
+          </a:prstGeom>
+          <a:noFill/>
+          <a:ln/>
+        </p:spPr>
+        <p:txBody>
+          <a:bodyPr wrap="square" lIns="0" tIns="0" rIns="0" bIns="0" rtlCol="0" anchor="ctr"/>
+          <a:lstStyle/>
+          <a:p>
+            <a:pPr indent="0" marL="0">
+              <a:buNone/>
+            </a:pPr>
+            <a:r>
+              <a:rPr lang="en-US" sz="1300" b="1" dirty="0">
                 <a:solidFill>
                   <a:srgbClr val="0B3C49"/>
                 </a:solidFill>
@@ -6793,38 +6910,77 @@
                 <a:ea typeface="Calibri" pitchFamily="34" charset="-122"/>
                 <a:cs typeface="Calibri" pitchFamily="34" charset="-120"/>
               </a:rPr>
-              <a:t>A'zo 4</a:t>
-            </a:r>
-            <a:endParaRPr lang="en-US" sz="1800" dirty="0"/>
-          </a:p>
-        </p:txBody>
-      </p:sp>
-      <p:sp>
-        <p:nvSpPr>
-          <p:cNvPr id="22" name="Text 16"/>
-          <p:cNvSpPr txBox="1"/>
-          <p:nvPr/>
-        </p:nvSpPr>
-        <p:spPr>
-          <a:xfrm>
-            <a:off x="6949440" y="3200400"/>
-            <a:ext cx="1737360" cy="365760"/>
-          </a:xfrm>
-          <a:prstGeom prst="rect">
-            <a:avLst/>
-          </a:prstGeom>
-          <a:noFill/>
-          <a:ln/>
-        </p:spPr>
-        <p:txBody>
-          <a:bodyPr wrap="square" lIns="0" tIns="0" rIns="0" bIns="0" rtlCol="0" anchor="ctr"/>
-          <a:lstStyle/>
-          <a:p>
-            <a:pPr algn="ctr" indent="0" marL="0">
-              <a:buNone/>
-            </a:pPr>
-            <a:r>
-              <a:rPr lang="en-US" sz="1400" dirty="0">
+              <a:t>Yo’ldosheva Sanobar</a:t>
+            </a:r>
+            <a:endParaRPr lang="en-US" sz="1300" dirty="0"/>
+          </a:p>
+        </p:txBody>
+      </p:sp>
+      <p:sp>
+        <p:nvSpPr>
+          <p:cNvPr id="25" name="Text 19"/>
+          <p:cNvSpPr txBox="1"/>
+          <p:nvPr/>
+        </p:nvSpPr>
+        <p:spPr>
+          <a:xfrm>
+            <a:off x="731520" y="3931920"/>
+            <a:ext cx="2240280" cy="274320"/>
+          </a:xfrm>
+          <a:prstGeom prst="rect">
+            <a:avLst/>
+          </a:prstGeom>
+          <a:noFill/>
+          <a:ln/>
+        </p:spPr>
+        <p:txBody>
+          <a:bodyPr wrap="square" lIns="0" tIns="0" rIns="0" bIns="0" rtlCol="0" anchor="ctr"/>
+          <a:lstStyle/>
+          <a:p>
+            <a:pPr indent="0" marL="0">
+              <a:buNone/>
+            </a:pPr>
+            <a:r>
+              <a:rPr lang="en-US" sz="1300" b="1" dirty="0">
+                <a:solidFill>
+                  <a:srgbClr val="0E7C86"/>
+                </a:solidFill>
+                <a:latin typeface="Calibri" pitchFamily="34" charset="0"/>
+                <a:ea typeface="Calibri" pitchFamily="34" charset="-122"/>
+                <a:cs typeface="Calibri" pitchFamily="34" charset="-120"/>
+              </a:rPr>
+              <a:t>Frontend Developer</a:t>
+            </a:r>
+            <a:endParaRPr lang="en-US" sz="1300" dirty="0"/>
+          </a:p>
+        </p:txBody>
+      </p:sp>
+      <p:sp>
+        <p:nvSpPr>
+          <p:cNvPr id="26" name="Text 20"/>
+          <p:cNvSpPr txBox="1"/>
+          <p:nvPr/>
+        </p:nvSpPr>
+        <p:spPr>
+          <a:xfrm>
+            <a:off x="731520" y="4206240"/>
+            <a:ext cx="2240280" cy="411480"/>
+          </a:xfrm>
+          <a:prstGeom prst="rect">
+            <a:avLst/>
+          </a:prstGeom>
+          <a:noFill/>
+          <a:ln/>
+        </p:spPr>
+        <p:txBody>
+          <a:bodyPr wrap="square" lIns="0" tIns="0" rIns="0" bIns="0" rtlCol="0" anchor="ctr"/>
+          <a:lstStyle/>
+          <a:p>
+            <a:pPr indent="0" marL="0">
+              <a:buNone/>
+            </a:pPr>
+            <a:r>
+              <a:rPr lang="en-US" sz="1100" dirty="0">
                 <a:solidFill>
                   <a:srgbClr val="5E7480"/>
                 </a:solidFill>
@@ -6832,22 +6988,98 @@
                 <a:ea typeface="Calibri" pitchFamily="34" charset="-122"/>
                 <a:cs typeface="Calibri" pitchFamily="34" charset="-120"/>
               </a:rPr>
-              <a:t>Vazifasi</a:t>
-            </a:r>
-            <a:endParaRPr lang="en-US" sz="1400" dirty="0"/>
-          </a:p>
-        </p:txBody>
-      </p:sp>
-      <p:sp>
-        <p:nvSpPr>
-          <p:cNvPr id="23" name="Text 17"/>
-          <p:cNvSpPr txBox="1"/>
-          <p:nvPr/>
-        </p:nvSpPr>
-        <p:spPr>
-          <a:xfrm>
-            <a:off x="548640" y="4114800"/>
-            <a:ext cx="8046720" cy="457200"/>
+              <a:t>Interfeys, dashboard, responsive dizayn</a:t>
+            </a:r>
+            <a:endParaRPr lang="en-US" sz="1100" dirty="0"/>
+          </a:p>
+        </p:txBody>
+      </p:sp>
+      <p:sp>
+        <p:nvSpPr>
+          <p:cNvPr id="27" name="Shape 21"/>
+          <p:cNvSpPr/>
+          <p:nvPr/>
+        </p:nvSpPr>
+        <p:spPr>
+          <a:xfrm>
+            <a:off x="3291840" y="3063240"/>
+            <a:ext cx="2560320" cy="1600200"/>
+          </a:xfrm>
+          <a:prstGeom prst="roundRect">
+            <a:avLst>
+              <a:gd name="adj" fmla="val 6857"/>
+            </a:avLst>
+          </a:prstGeom>
+          <a:solidFill>
+            <a:srgbClr val="E8F4F3"/>
+          </a:solidFill>
+          <a:ln w="12700">
+            <a:solidFill>
+              <a:srgbClr val="E8F4F3"/>
+            </a:solidFill>
+            <a:prstDash val="solid"/>
+          </a:ln>
+        </p:spPr>
+      </p:sp>
+      <p:sp>
+        <p:nvSpPr>
+          <p:cNvPr id="28" name="Shape 22"/>
+          <p:cNvSpPr/>
+          <p:nvPr/>
+        </p:nvSpPr>
+        <p:spPr>
+          <a:xfrm>
+            <a:off x="3474720" y="3246120"/>
+            <a:ext cx="548640" cy="548640"/>
+          </a:xfrm>
+          <a:prstGeom prst="ellipse">
+            <a:avLst/>
+          </a:prstGeom>
+          <a:solidFill>
+            <a:srgbClr val="0E7C86"/>
+          </a:solidFill>
+          <a:ln w="12700">
+            <a:solidFill>
+              <a:srgbClr val="0E7C86"/>
+            </a:solidFill>
+            <a:prstDash val="solid"/>
+          </a:ln>
+        </p:spPr>
+      </p:sp>
+      <p:pic>
+        <p:nvPicPr>
+          <p:cNvPr id="29" name="Image 4" descr="preencoded.png">    </p:cNvPr>
+          <p:cNvPicPr>
+            <a:picLocks noChangeAspect="1"/>
+          </p:cNvPicPr>
+          <p:nvPr/>
+        </p:nvPicPr>
+        <p:blipFill>
+          <a:blip r:embed="rId5"/>
+          <a:stretch>
+            <a:fillRect/>
+          </a:stretch>
+        </p:blipFill>
+        <p:spPr>
+          <a:xfrm>
+            <a:off x="3611880" y="3383280"/>
+            <a:ext cx="274320" cy="274320"/>
+          </a:xfrm>
+          <a:prstGeom prst="rect">
+            <a:avLst/>
+          </a:prstGeom>
+        </p:spPr>
+      </p:pic>
+      <p:sp>
+        <p:nvSpPr>
+          <p:cNvPr id="30" name="Text 23"/>
+          <p:cNvSpPr txBox="1"/>
+          <p:nvPr/>
+        </p:nvSpPr>
+        <p:spPr>
+          <a:xfrm>
+            <a:off x="4160520" y="3200400"/>
+            <a:ext cx="1600200" cy="640080"/>
           </a:xfrm>
           <a:prstGeom prst="rect">
             <a:avLst/>
@@ -6863,7 +7095,46 @@
               <a:buNone/>
             </a:pPr>
             <a:r>
-              <a:rPr lang="en-US" sz="2000" b="1" dirty="0">
+              <a:rPr lang="en-US" sz="1300" b="1" dirty="0">
+                <a:solidFill>
+                  <a:srgbClr val="0B3C49"/>
+                </a:solidFill>
+                <a:latin typeface="Calibri" pitchFamily="34" charset="0"/>
+                <a:ea typeface="Calibri" pitchFamily="34" charset="-122"/>
+                <a:cs typeface="Calibri" pitchFamily="34" charset="-120"/>
+              </a:rPr>
+              <a:t>Eshnazarova Feruza</a:t>
+            </a:r>
+            <a:endParaRPr lang="en-US" sz="1300" dirty="0"/>
+          </a:p>
+        </p:txBody>
+      </p:sp>
+      <p:sp>
+        <p:nvSpPr>
+          <p:cNvPr id="31" name="Text 24"/>
+          <p:cNvSpPr txBox="1"/>
+          <p:nvPr/>
+        </p:nvSpPr>
+        <p:spPr>
+          <a:xfrm>
+            <a:off x="3474720" y="3931920"/>
+            <a:ext cx="2240280" cy="274320"/>
+          </a:xfrm>
+          <a:prstGeom prst="rect">
+            <a:avLst/>
+          </a:prstGeom>
+          <a:noFill/>
+          <a:ln/>
+        </p:spPr>
+        <p:txBody>
+          <a:bodyPr wrap="square" lIns="0" tIns="0" rIns="0" bIns="0" rtlCol="0" anchor="ctr"/>
+          <a:lstStyle/>
+          <a:p>
+            <a:pPr indent="0" marL="0">
+              <a:buNone/>
+            </a:pPr>
+            <a:r>
+              <a:rPr lang="en-US" sz="1300" b="1" dirty="0">
                 <a:solidFill>
                   <a:srgbClr val="0E7C86"/>
                 </a:solidFill>
@@ -6871,9 +7142,241 @@
                 <a:ea typeface="Calibri" pitchFamily="34" charset="-122"/>
                 <a:cs typeface="Calibri" pitchFamily="34" charset="-120"/>
               </a:rPr>
-              <a:t>Hamkorlikka va pilot sinovga tayyormiz</a:t>
-            </a:r>
-            <a:endParaRPr lang="en-US" sz="2000" dirty="0"/>
+              <a:t>Data Analyst</a:t>
+            </a:r>
+            <a:endParaRPr lang="en-US" sz="1300" dirty="0"/>
+          </a:p>
+        </p:txBody>
+      </p:sp>
+      <p:sp>
+        <p:nvSpPr>
+          <p:cNvPr id="32" name="Text 25"/>
+          <p:cNvSpPr txBox="1"/>
+          <p:nvPr/>
+        </p:nvSpPr>
+        <p:spPr>
+          <a:xfrm>
+            <a:off x="3474720" y="4206240"/>
+            <a:ext cx="2240280" cy="411480"/>
+          </a:xfrm>
+          <a:prstGeom prst="rect">
+            <a:avLst/>
+          </a:prstGeom>
+          <a:noFill/>
+          <a:ln/>
+        </p:spPr>
+        <p:txBody>
+          <a:bodyPr wrap="square" lIns="0" tIns="0" rIns="0" bIns="0" rtlCol="0" anchor="ctr"/>
+          <a:lstStyle/>
+          <a:p>
+            <a:pPr indent="0" marL="0">
+              <a:buNone/>
+            </a:pPr>
+            <a:r>
+              <a:rPr lang="en-US" sz="1100" dirty="0">
+                <a:solidFill>
+                  <a:srgbClr val="5E7480"/>
+                </a:solidFill>
+                <a:latin typeface="Calibri" pitchFamily="34" charset="0"/>
+                <a:ea typeface="Calibri" pitchFamily="34" charset="-122"/>
+                <a:cs typeface="Calibri" pitchFamily="34" charset="-120"/>
+              </a:rPr>
+              <a:t>Hisobotlar, ko'rsatkichlar, ma'lumot tahlili</a:t>
+            </a:r>
+            <a:endParaRPr lang="en-US" sz="1100" dirty="0"/>
+          </a:p>
+        </p:txBody>
+      </p:sp>
+      <p:sp>
+        <p:nvSpPr>
+          <p:cNvPr id="33" name="Shape 26"/>
+          <p:cNvSpPr/>
+          <p:nvPr/>
+        </p:nvSpPr>
+        <p:spPr>
+          <a:xfrm>
+            <a:off x="6035040" y="3063240"/>
+            <a:ext cx="2560320" cy="1600200"/>
+          </a:xfrm>
+          <a:prstGeom prst="roundRect">
+            <a:avLst>
+              <a:gd name="adj" fmla="val 6857"/>
+            </a:avLst>
+          </a:prstGeom>
+          <a:solidFill>
+            <a:srgbClr val="E8F4F3"/>
+          </a:solidFill>
+          <a:ln w="12700">
+            <a:solidFill>
+              <a:srgbClr val="E8F4F3"/>
+            </a:solidFill>
+            <a:prstDash val="solid"/>
+          </a:ln>
+        </p:spPr>
+      </p:sp>
+      <p:sp>
+        <p:nvSpPr>
+          <p:cNvPr id="34" name="Shape 27"/>
+          <p:cNvSpPr/>
+          <p:nvPr/>
+        </p:nvSpPr>
+        <p:spPr>
+          <a:xfrm>
+            <a:off x="6217920" y="3246120"/>
+            <a:ext cx="548640" cy="548640"/>
+          </a:xfrm>
+          <a:prstGeom prst="ellipse">
+            <a:avLst/>
+          </a:prstGeom>
+          <a:solidFill>
+            <a:srgbClr val="14A3A8"/>
+          </a:solidFill>
+          <a:ln w="12700">
+            <a:solidFill>
+              <a:srgbClr val="14A3A8"/>
+            </a:solidFill>
+            <a:prstDash val="solid"/>
+          </a:ln>
+        </p:spPr>
+      </p:sp>
+      <p:pic>
+        <p:nvPicPr>
+          <p:cNvPr id="35" name="Image 5" descr="preencoded.png">    </p:cNvPr>
+          <p:cNvPicPr>
+            <a:picLocks noChangeAspect="1"/>
+          </p:cNvPicPr>
+          <p:nvPr/>
+        </p:nvPicPr>
+        <p:blipFill>
+          <a:blip r:embed="rId6"/>
+          <a:stretch>
+            <a:fillRect/>
+          </a:stretch>
+        </p:blipFill>
+        <p:spPr>
+          <a:xfrm>
+            <a:off x="6355080" y="3383280"/>
+            <a:ext cx="274320" cy="274320"/>
+          </a:xfrm>
+          <a:prstGeom prst="rect">
+            <a:avLst/>
+          </a:prstGeom>
+        </p:spPr>
+      </p:pic>
+      <p:sp>
+        <p:nvSpPr>
+          <p:cNvPr id="36" name="Text 28"/>
+          <p:cNvSpPr txBox="1"/>
+          <p:nvPr/>
+        </p:nvSpPr>
+        <p:spPr>
+          <a:xfrm>
+            <a:off x="6903720" y="3200400"/>
+            <a:ext cx="1600200" cy="640080"/>
+          </a:xfrm>
+          <a:prstGeom prst="rect">
+            <a:avLst/>
+          </a:prstGeom>
+          <a:noFill/>
+          <a:ln/>
+        </p:spPr>
+        <p:txBody>
+          <a:bodyPr wrap="square" lIns="0" tIns="0" rIns="0" bIns="0" rtlCol="0" anchor="ctr"/>
+          <a:lstStyle/>
+          <a:p>
+            <a:pPr indent="0" marL="0">
+              <a:buNone/>
+            </a:pPr>
+            <a:r>
+              <a:rPr lang="en-US" sz="1300" b="1" dirty="0">
+                <a:solidFill>
+                  <a:srgbClr val="0B3C49"/>
+                </a:solidFill>
+                <a:latin typeface="Calibri" pitchFamily="34" charset="0"/>
+                <a:ea typeface="Calibri" pitchFamily="34" charset="-122"/>
+                <a:cs typeface="Calibri" pitchFamily="34" charset="-120"/>
+              </a:rPr>
+              <a:t>Tursunov Atham</a:t>
+            </a:r>
+            <a:endParaRPr lang="en-US" sz="1300" dirty="0"/>
+          </a:p>
+        </p:txBody>
+      </p:sp>
+      <p:sp>
+        <p:nvSpPr>
+          <p:cNvPr id="37" name="Text 29"/>
+          <p:cNvSpPr txBox="1"/>
+          <p:nvPr/>
+        </p:nvSpPr>
+        <p:spPr>
+          <a:xfrm>
+            <a:off x="6217920" y="3931920"/>
+            <a:ext cx="2240280" cy="274320"/>
+          </a:xfrm>
+          <a:prstGeom prst="rect">
+            <a:avLst/>
+          </a:prstGeom>
+          <a:noFill/>
+          <a:ln/>
+        </p:spPr>
+        <p:txBody>
+          <a:bodyPr wrap="square" lIns="0" tIns="0" rIns="0" bIns="0" rtlCol="0" anchor="ctr"/>
+          <a:lstStyle/>
+          <a:p>
+            <a:pPr indent="0" marL="0">
+              <a:buNone/>
+            </a:pPr>
+            <a:r>
+              <a:rPr lang="en-US" sz="1300" b="1" dirty="0">
+                <a:solidFill>
+                  <a:srgbClr val="0E7C86"/>
+                </a:solidFill>
+                <a:latin typeface="Calibri" pitchFamily="34" charset="0"/>
+                <a:ea typeface="Calibri" pitchFamily="34" charset="-122"/>
+                <a:cs typeface="Calibri" pitchFamily="34" charset="-120"/>
+              </a:rPr>
+              <a:t>QA va hujjatlar</a:t>
+            </a:r>
+            <a:endParaRPr lang="en-US" sz="1300" dirty="0"/>
+          </a:p>
+        </p:txBody>
+      </p:sp>
+      <p:sp>
+        <p:nvSpPr>
+          <p:cNvPr id="38" name="Text 30"/>
+          <p:cNvSpPr txBox="1"/>
+          <p:nvPr/>
+        </p:nvSpPr>
+        <p:spPr>
+          <a:xfrm>
+            <a:off x="6217920" y="4206240"/>
+            <a:ext cx="2240280" cy="411480"/>
+          </a:xfrm>
+          <a:prstGeom prst="rect">
+            <a:avLst/>
+          </a:prstGeom>
+          <a:noFill/>
+          <a:ln/>
+        </p:spPr>
+        <p:txBody>
+          <a:bodyPr wrap="square" lIns="0" tIns="0" rIns="0" bIns="0" rtlCol="0" anchor="ctr"/>
+          <a:lstStyle/>
+          <a:p>
+            <a:pPr indent="0" marL="0">
+              <a:buNone/>
+            </a:pPr>
+            <a:r>
+              <a:rPr lang="en-US" sz="1100" dirty="0">
+                <a:solidFill>
+                  <a:srgbClr val="5E7480"/>
+                </a:solidFill>
+                <a:latin typeface="Calibri" pitchFamily="34" charset="0"/>
+                <a:ea typeface="Calibri" pitchFamily="34" charset="-122"/>
+                <a:cs typeface="Calibri" pitchFamily="34" charset="-120"/>
+              </a:rPr>
+              <a:t>Testlash, foydalanuvchi qo'llanmasi, demo ma'lumotlar</a:t>
+            </a:r>
+            <a:endParaRPr lang="en-US" sz="1100" dirty="0"/>
           </a:p>
         </p:txBody>
       </p:sp>

</xml_diff>

<commit_message>
Update InvenTrack pitch presentation
</commit_message>
<xml_diff>
--- a/presentation/InvenTrack-Pitch.pptx
+++ b/presentation/InvenTrack-Pitch.pptx
@@ -4,6 +4,9 @@
   <p:sldMasterIdLst>
     <p:sldMasterId id="2147483648" r:id="rId1"/>
   </p:sldMasterIdLst>
+  <p:notesMasterIdLst>
+    <p:notesMasterId r:id="rId18"/>
+  </p:notesMasterIdLst>
   <p:sldIdLst>
     <p:sldId id="256" r:id="rId2"/>
     <p:sldId id="257" r:id="rId3"/>
@@ -22,10 +25,7 @@
     <p:sldId id="270" r:id="rId16"/>
     <p:sldId id="271" r:id="rId17"/>
   </p:sldIdLst>
-  <p:notesMasterIdLst>
-    <p:notesMasterId r:id="rId18"/>
-  </p:notesMasterIdLst>
-  <p:sldSz cx="9144000" cy="5143500"/>
+  <p:sldSz cx="9144000" cy="5143500" type="screen16x9"/>
   <p:notesSz cx="5143500" cy="9144000"/>
   <p:defaultTextStyle>
     <a:lvl1pPr marL="0" algn="l" defTabSz="914400" rtl="0" eaLnBrk="1" latinLnBrk="0" hangingPunct="1">
@@ -119,6 +119,11 @@
       </a:defRPr>
     </a:lvl9pPr>
   </p:defaultTextStyle>
+  <p:extLst>
+    <p:ext uri="{EFAFB233-063F-42B5-8137-9DF3F51BA10A}">
+      <p15:sldGuideLst xmlns:p15="http://schemas.microsoft.com/office/powerpoint/2012/main"/>
+    </p:ext>
+  </p:extLst>
 </p:presentation>
 </file>
 
@@ -144,234 +149,10 @@
           <a:chExt cx="0" cy="0"/>
         </a:xfrm>
       </p:grpSpPr>
-      <p:sp>
-        <p:nvSpPr>
-          <p:cNvPr id="2" name="Header Placeholder 1"/>
-          <p:cNvSpPr>
-            <a:spLocks noGrp="1"/>
-          </p:cNvSpPr>
-          <p:nvPr>
-            <p:ph type="hdr" sz="quarter"/>
-          </p:nvPr>
-        </p:nvSpPr>
-        <p:spPr>
-          <a:xfrm>
-            <a:off x="0" y="0"/>
-            <a:ext cx="2971800" cy="458788"/>
-          </a:xfrm>
-          <a:prstGeom prst="rect">
-            <a:avLst/>
-          </a:prstGeom>
-        </p:spPr>
-        <p:txBody>
-          <a:bodyPr vert="horz" lIns="91440" tIns="45720" rIns="91440" bIns="45720" rtlCol="0"/>
-          <a:lstStyle>
-            <a:lvl1pPr algn="l">
-              <a:defRPr sz="1200"/>
-            </a:lvl1pPr>
-          </a:lstStyle>
-          <a:p>
-            <a:endParaRPr lang="en-US"/>
-          </a:p>
-        </p:txBody>
-      </p:sp>
-      <p:sp>
-        <p:nvSpPr>
-          <p:cNvPr id="3" name="Date Placeholder 2"/>
-          <p:cNvSpPr>
-            <a:spLocks noGrp="1"/>
-          </p:cNvSpPr>
-          <p:nvPr>
-            <p:ph type="dt" idx="1"/>
-          </p:nvPr>
-        </p:nvSpPr>
-        <p:spPr>
-          <a:xfrm>
-            <a:off x="3884613" y="0"/>
-            <a:ext cx="2971800" cy="458788"/>
-          </a:xfrm>
-          <a:prstGeom prst="rect">
-            <a:avLst/>
-          </a:prstGeom>
-        </p:spPr>
-        <p:txBody>
-          <a:bodyPr vert="horz" lIns="91440" tIns="45720" rIns="91440" bIns="45720" rtlCol="0"/>
-          <a:lstStyle>
-            <a:lvl1pPr algn="r">
-              <a:defRPr sz="1200"/>
-            </a:lvl1pPr>
-          </a:lstStyle>
-          <a:p>
-            <a:fld id="{5282F153-3F37-0F45-9E97-73ACFA13230C}" type="datetimeFigureOut">
-              <a:rPr lang="en-US"/>
-              <a:t>7/23/19</a:t>
-            </a:fld>
-            <a:endParaRPr lang="en-US"/>
-          </a:p>
-        </p:txBody>
-      </p:sp>
-      <p:sp>
-        <p:nvSpPr>
-          <p:cNvPr id="4" name="Slide Image Placeholder 3"/>
-          <p:cNvSpPr>
-            <a:spLocks noGrp="1" noRot="1" noChangeAspect="1"/>
-          </p:cNvSpPr>
-          <p:nvPr>
-            <p:ph type="sldImg" idx="2"/>
-          </p:nvPr>
-        </p:nvSpPr>
-        <p:spPr>
-          <a:xfrm>
-            <a:off x="685800" y="1143000"/>
-            <a:ext cx="5486400" cy="3086100"/>
-          </a:xfrm>
-          <a:prstGeom prst="rect">
-            <a:avLst/>
-          </a:prstGeom>
-          <a:noFill/>
-          <a:ln w="12700">
-            <a:solidFill>
-              <a:prstClr val="black"/>
-            </a:solidFill>
-          </a:ln>
-        </p:spPr>
-        <p:txBody>
-          <a:bodyPr vert="horz" lIns="91440" tIns="45720" rIns="91440" bIns="45720" rtlCol="0" anchor="ctr"/>
-          <a:lstStyle/>
-          <a:p>
-            <a:endParaRPr lang="en-US"/>
-          </a:p>
-        </p:txBody>
-      </p:sp>
-      <p:sp>
-        <p:nvSpPr>
-          <p:cNvPr id="5" name="Notes Placeholder 4"/>
-          <p:cNvSpPr>
-            <a:spLocks noGrp="1"/>
-          </p:cNvSpPr>
-          <p:nvPr>
-            <p:ph type="body" sz="quarter" idx="3"/>
-          </p:nvPr>
-        </p:nvSpPr>
-        <p:spPr>
-          <a:xfrm>
-            <a:off x="685800" y="4400550"/>
-            <a:ext cx="5486400" cy="3600450"/>
-          </a:xfrm>
-          <a:prstGeom prst="rect">
-            <a:avLst/>
-          </a:prstGeom>
-        </p:spPr>
-        <p:txBody>
-          <a:bodyPr vert="horz" lIns="91440" tIns="45720" rIns="91440" bIns="45720" rtlCol="0"/>
-          <a:lstStyle/>
-          <a:p>
-            <a:pPr lvl="0"/>
-            <a:r>
-              <a:rPr lang="en-US"/>
-              <a:t>Click to edit Master text styles</a:t>
-            </a:r>
-          </a:p>
-          <a:p>
-            <a:pPr lvl="1"/>
-            <a:r>
-              <a:rPr lang="en-US"/>
-              <a:t>Second level</a:t>
-            </a:r>
-          </a:p>
-          <a:p>
-            <a:pPr lvl="2"/>
-            <a:r>
-              <a:rPr lang="en-US"/>
-              <a:t>Third level</a:t>
-            </a:r>
-          </a:p>
-          <a:p>
-            <a:pPr lvl="3"/>
-            <a:r>
-              <a:rPr lang="en-US"/>
-              <a:t>Fourth level</a:t>
-            </a:r>
-          </a:p>
-          <a:p>
-            <a:pPr lvl="4"/>
-            <a:r>
-              <a:rPr lang="en-US"/>
-              <a:t>Fifth level</a:t>
-            </a:r>
-          </a:p>
-        </p:txBody>
-      </p:sp>
-      <p:sp>
-        <p:nvSpPr>
-          <p:cNvPr id="6" name="Footer Placeholder 5"/>
-          <p:cNvSpPr>
-            <a:spLocks noGrp="1"/>
-          </p:cNvSpPr>
-          <p:nvPr>
-            <p:ph type="ftr" sz="quarter" idx="4"/>
-          </p:nvPr>
-        </p:nvSpPr>
-        <p:spPr>
-          <a:xfrm>
-            <a:off x="0" y="8685213"/>
-            <a:ext cx="2971800" cy="458787"/>
-          </a:xfrm>
-          <a:prstGeom prst="rect">
-            <a:avLst/>
-          </a:prstGeom>
-        </p:spPr>
-        <p:txBody>
-          <a:bodyPr vert="horz" lIns="91440" tIns="45720" rIns="91440" bIns="45720" rtlCol="0" anchor="b"/>
-          <a:lstStyle>
-            <a:lvl1pPr algn="l">
-              <a:defRPr sz="1200"/>
-            </a:lvl1pPr>
-          </a:lstStyle>
-          <a:p>
-            <a:endParaRPr lang="en-US"/>
-          </a:p>
-        </p:txBody>
-      </p:sp>
-      <p:sp>
-        <p:nvSpPr>
-          <p:cNvPr id="7" name="Slide Number Placeholder 6"/>
-          <p:cNvSpPr>
-            <a:spLocks noGrp="1"/>
-          </p:cNvSpPr>
-          <p:nvPr>
-            <p:ph type="sldNum" sz="quarter" idx="5"/>
-          </p:nvPr>
-        </p:nvSpPr>
-        <p:spPr>
-          <a:xfrm>
-            <a:off x="3884613" y="8685213"/>
-            <a:ext cx="2971800" cy="458787"/>
-          </a:xfrm>
-          <a:prstGeom prst="rect">
-            <a:avLst/>
-          </a:prstGeom>
-        </p:spPr>
-        <p:txBody>
-          <a:bodyPr vert="horz" lIns="91440" tIns="45720" rIns="91440" bIns="45720" rtlCol="0" anchor="b"/>
-          <a:lstStyle>
-            <a:lvl1pPr algn="r">
-              <a:defRPr sz="1200"/>
-            </a:lvl1pPr>
-          </a:lstStyle>
-          <a:p>
-            <a:fld id="{CE5E9CC1-C706-0F49-92D6-E571CC5EEA8F}" type="slidenum">
-              <a:rPr lang="en-US"/>
-              <a:t>‹#›</a:t>
-            </a:fld>
-            <a:endParaRPr lang="en-US"/>
-          </a:p>
-        </p:txBody>
-      </p:sp>
     </p:spTree>
     <p:extLst>
       <p:ext uri="{BB962C8B-B14F-4D97-AF65-F5344CB8AC3E}">
-        <p14:creationId xmlns:p14="http://schemas.microsoft.com/office/powerpoint/2010/main" val="1024086991"/>
+        <p14:creationId xmlns:p14="http://schemas.microsoft.com/office/powerpoint/2010/main" val="1169527154"/>
       </p:ext>
     </p:extLst>
   </p:cSld>
@@ -519,7 +300,6 @@
               <a:rPr lang="en-US" dirty="0"/>
               <a:t>Assalomu alaykum! Biz 404 Found jamoasimiz. Bugun sizga InvenTrack — tashkilotdagi kompyuter va texnik vositalarni elektron hisobga olish tizimini taqdim etamiz. Shiorimiz: har bir jihoz hisobda, har bir o'zgarish tarixda.</a:t>
             </a:r>
-            <a:endParaRPr lang="en-US" dirty="0"/>
           </a:p>
         </p:txBody>
       </p:sp>
@@ -607,7 +387,6 @@
               <a:rPr lang="en-US" dirty="0"/>
               <a:t>Uch rol: Administrator hamma narsani boshqaradi, Mas'ul shaxs o'z jihozlarini yangilaydi, Xodim faqat ko'ra oladi. Ruxsatlar serverda tekshiriladi.</a:t>
             </a:r>
-            <a:endParaRPr lang="en-US" dirty="0"/>
           </a:p>
         </p:txBody>
       </p:sp>
@@ -695,7 +474,6 @@
               <a:rPr lang="en-US" dirty="0"/>
               <a:t>Xavfsizlik bo'yicha: parollar bcrypt bilan hashlanadi; JWT qisqa muddatli; ruxsatlar frontendda emas, serverda tekshiriladi; barcha kirish ma'lumotlari Zod bilan tekshiriladi, Prisma parametrlangan so'rovlar ishlatadi; Helmet, CORS va login urinishlari cheklanadi; barcha o'zgarishlar tarixga yoziladi; kalitlar kodda emas, .env faylida.</a:t>
             </a:r>
-            <a:endParaRPr lang="en-US" dirty="0"/>
           </a:p>
         </p:txBody>
       </p:sp>
@@ -783,7 +561,6 @@
               <a:rPr lang="en-US" dirty="0"/>
               <a:t>Frontend React va TypeScript, backend Node.js va Express, ma'lumotlar bazasi PostgreSQL, Prisma ORM orqali. Markazda equipment jadvali, unga turlar, xonalar, ta'mirlar va tarix bog'langan.</a:t>
             </a:r>
-            <a:endParaRPr lang="en-US" dirty="0"/>
           </a:p>
         </p:txBody>
       </p:sp>
@@ -871,7 +648,6 @@
               <a:rPr lang="en-US" dirty="0"/>
               <a:t>Hisobotni xona, bo'lim, tur va holat bo'yicha filtrlash mumkin. Natija Excel yoki PDF'ga yuklanadi, chop etishga qulay ko'rinishi ham bor.</a:t>
             </a:r>
-            <a:endParaRPr lang="en-US" dirty="0"/>
           </a:p>
         </p:txBody>
       </p:sp>
@@ -959,7 +735,6 @@
               <a:rPr lang="en-US" dirty="0"/>
               <a:t>Natijada tashkilot jihozlarining yagona, xavfsiz va yangilanib turadigan hisobi paydo bo'ladi. Kelajakda QR skaner, bildirishnomalar va mobil ilova qo'shishni rejalashtirganmiz.</a:t>
             </a:r>
-            <a:endParaRPr lang="en-US" dirty="0"/>
           </a:p>
         </p:txBody>
       </p:sp>
@@ -1047,7 +822,6 @@
               <a:rPr lang="en-US" dirty="0"/>
               <a:t>Jamoamiz 404 Found, olti kishidan iborat. Nurmuhammad loyihani boshqaradi, Dalerbek arxitektura va AI yordamchi ustida ishladi, G'olibjon backend va xavfsizlikni, Sanobar frontendni qurdi, Feruza hisobot va ko'rsatkichlarni tahlil qildi, Atham testlash va hujjatlarni yuritdi. Biz tizimni pilot sifatida bitta bo'limda sinab ko'rishga tayyormiz.</a:t>
             </a:r>
-            <a:endParaRPr lang="en-US" dirty="0"/>
           </a:p>
         </p:txBody>
       </p:sp>
@@ -1135,7 +909,6 @@
               <a:rPr lang="en-US" dirty="0"/>
               <a:t>E'tiboringiz uchun rahmat! Savollaringiz bo'lsa, javob beramiz.</a:t>
             </a:r>
-            <a:endParaRPr lang="en-US" dirty="0"/>
           </a:p>
         </p:txBody>
       </p:sp>
@@ -1223,7 +996,6 @@
               <a:rPr lang="en-US" dirty="0"/>
               <a:t>Ko'pchilik tashkilotlarda jihozlar qog'oz yoki Excel'da yuritiladi. Natijada ma'lumot eskiradi, texnika yo'qoladi, inventarizatsiya esa juda ko'p vaqt oladi.</a:t>
             </a:r>
-            <a:endParaRPr lang="en-US" dirty="0"/>
           </a:p>
         </p:txBody>
       </p:sp>
@@ -1311,7 +1083,6 @@
               <a:rPr lang="en-US" dirty="0"/>
               <a:t>Maqsadimiz — jihozlarni bitta web-tizimda hisobga olish. Yechim: yagona baza, avtomatik inventar raqam, to'liq tarix va tez hisobot.</a:t>
             </a:r>
-            <a:endParaRPr lang="en-US" dirty="0"/>
           </a:p>
         </p:txBody>
       </p:sp>
@@ -1399,7 +1170,6 @@
               <a:rPr lang="en-US" dirty="0"/>
               <a:t>Funksiyalarni to'rt guruhga ajratdik: hisobga olish, joylashuv va mas'ul, holat va ta'mir, tarix va hisobot.</a:t>
             </a:r>
-            <a:endParaRPr lang="en-US" dirty="0"/>
           </a:p>
         </p:txBody>
       </p:sp>
@@ -1487,7 +1257,6 @@
               <a:rPr lang="en-US" dirty="0"/>
               <a:t>Tizim yettita asosiy jihoz turini qo'llab-quvvatlaydi. Administrator istalgan vaqtda yangi tur qo'sha oladi.</a:t>
             </a:r>
-            <a:endParaRPr lang="en-US" dirty="0"/>
           </a:p>
         </p:txBody>
       </p:sp>
@@ -1575,7 +1344,6 @@
               <a:rPr lang="en-US" dirty="0"/>
               <a:t>Jarayon: foydalanuvchi kiradi, jihoz qo'shiladi va avtomatik raqam oladi, xona va mas'ulga biriktiriladi, holati yangilanadi, oxirida hisobot olinadi. Har bir qadam tarixga yoziladi.</a:t>
             </a:r>
-            <a:endParaRPr lang="en-US" dirty="0"/>
           </a:p>
         </p:txBody>
       </p:sp>
@@ -1663,7 +1431,6 @@
               <a:rPr lang="en-US" dirty="0"/>
               <a:t>Bu ilovaning haqiqiy skrinshotlari: dashboard, jihozlar ro'yxati, jihoz kartochkasi QR-kod va tarix bilan, hamda qo'shish formasi. Ma'lumotlar sinov uchun.</a:t>
             </a:r>
-            <a:endParaRPr lang="en-US" dirty="0"/>
           </a:p>
         </p:txBody>
       </p:sp>
@@ -1751,7 +1518,6 @@
               <a:rPr lang="en-US" dirty="0"/>
               <a:t>Bu bitta jihozning tarixi: kim, qachon, nima o'zgargani yozilgan. Misol uchun sinov ma'lumotlari ishlatilgan. Tarix yozuvlari o'zgartirilmaydi.</a:t>
             </a:r>
-            <a:endParaRPr lang="en-US" dirty="0"/>
           </a:p>
         </p:txBody>
       </p:sp>
@@ -1839,7 +1605,6 @@
               <a:rPr lang="en-US" dirty="0"/>
               <a:t>Tizimga AI yordamchi qo'shiladi: foydalanuvchi oddiy o'zbek tilida savol beradi, masalan qaysi bo'limda nosoz jihoz ko'p. Agent faqat oldindan belgilangan xavfsiz asboblarni chaqiradi, bazani o'zgartira olmaydi va foydalanuvchi roliga ko'ra ma'lumot oladi. Model OpenRouter orqali bepul modellar zanjiri bilan ishlaydi, biri javob bermasa keyingisi ishga tushadi.</a:t>
             </a:r>
-            <a:endParaRPr lang="en-US" dirty="0"/>
           </a:p>
         </p:txBody>
       </p:sp>
@@ -1912,6 +1677,11 @@
 <file path=ppt/slideMasters/slideMaster1.xml><?xml version="1.0" encoding="utf-8"?>
 <p:sldMaster xmlns:a="http://schemas.openxmlformats.org/drawingml/2006/main" xmlns:r="http://schemas.openxmlformats.org/officeDocument/2006/relationships" xmlns:p="http://schemas.openxmlformats.org/presentationml/2006/main">
   <p:cSld>
+    <p:bg>
+      <p:bgRef idx="1001">
+        <a:schemeClr val="bg1"/>
+      </p:bgRef>
+    </p:bg>
     <p:spTree>
       <p:nvGrpSpPr>
         <p:cNvPr id="1" name=""/>
@@ -2194,6 +1964,7 @@
         <a:solidFill>
           <a:srgbClr val="0B3C49"/>
         </a:solidFill>
+        <a:effectLst/>
       </p:bgPr>
     </p:bg>
     <p:spTree>
@@ -2287,14 +2058,14 @@
       </p:sp>
       <p:pic>
         <p:nvPicPr>
-          <p:cNvPr id="5" name="Image 0" descr="preencoded.png">    </p:cNvPr>
+          <p:cNvPr id="5" name="Image 0" descr="preencoded.png"/>
           <p:cNvPicPr>
             <a:picLocks noChangeAspect="1"/>
           </p:cNvPicPr>
           <p:nvPr/>
         </p:nvPicPr>
         <p:blipFill>
-          <a:blip r:embed="rId1"/>
+          <a:blip r:embed="rId3"/>
           <a:stretch>
             <a:fillRect/>
           </a:stretch>
@@ -2330,7 +2101,7 @@
           <a:bodyPr wrap="square" lIns="0" tIns="0" rIns="0" bIns="0" rtlCol="0" anchor="ctr"/>
           <a:lstStyle/>
           <a:p>
-            <a:pPr indent="0" marL="0">
+            <a:pPr marL="0" indent="0">
               <a:buNone/>
             </a:pPr>
             <a:r>
@@ -2369,7 +2140,7 @@
           <a:bodyPr wrap="square" lIns="0" tIns="0" rIns="0" bIns="0" rtlCol="0" anchor="ctr"/>
           <a:lstStyle/>
           <a:p>
-            <a:pPr indent="0" marL="0">
+            <a:pPr marL="0" indent="0">
               <a:buNone/>
             </a:pPr>
             <a:r>
@@ -2408,7 +2179,7 @@
           <a:bodyPr wrap="square" lIns="0" tIns="0" rIns="0" bIns="0" rtlCol="0" anchor="ctr"/>
           <a:lstStyle/>
           <a:p>
-            <a:pPr indent="0" marL="0">
+            <a:pPr marL="0" indent="0">
               <a:buNone/>
             </a:pPr>
             <a:r>
@@ -2420,12 +2191,12 @@
                 <a:ea typeface="Calibri" pitchFamily="34" charset="-122"/>
                 <a:cs typeface="Calibri" pitchFamily="34" charset="-120"/>
               </a:rPr>
-              <a:t>Jamoa: 404 Found</a:t>
+              <a:t>Jamoa: 404</a:t>
             </a:r>
             <a:endParaRPr lang="en-US" sz="1600" dirty="0"/>
           </a:p>
           <a:p>
-            <a:pPr indent="0" marL="0">
+            <a:pPr marL="0" indent="0">
               <a:buNone/>
             </a:pPr>
             <a:r>
@@ -2459,6 +2230,7 @@
         <a:solidFill>
           <a:srgbClr val="FFFFFF"/>
         </a:solidFill>
+        <a:effectLst/>
       </p:bgPr>
     </p:bg>
     <p:spTree>
@@ -2496,7 +2268,7 @@
           <a:bodyPr wrap="square" lIns="0" tIns="0" rIns="0" bIns="0" rtlCol="0" anchor="ctr"/>
           <a:lstStyle/>
           <a:p>
-            <a:pPr indent="0" marL="0">
+            <a:pPr marL="0" indent="0">
               <a:buNone/>
             </a:pPr>
             <a:r>
@@ -2568,14 +2340,14 @@
       </p:sp>
       <p:pic>
         <p:nvPicPr>
-          <p:cNvPr id="5" name="Image 0" descr="preencoded.png">    </p:cNvPr>
+          <p:cNvPr id="5" name="Image 0" descr="preencoded.png"/>
           <p:cNvPicPr>
             <a:picLocks noChangeAspect="1"/>
           </p:cNvPicPr>
           <p:nvPr/>
         </p:nvPicPr>
         <p:blipFill>
-          <a:blip r:embed="rId1"/>
+          <a:blip r:embed="rId3"/>
           <a:stretch>
             <a:fillRect/>
           </a:stretch>
@@ -2611,7 +2383,7 @@
           <a:bodyPr wrap="square" lIns="0" tIns="0" rIns="0" bIns="0" rtlCol="0" anchor="ctr"/>
           <a:lstStyle/>
           <a:p>
-            <a:pPr algn="ctr" indent="0" marL="0">
+            <a:pPr marL="0" indent="0" algn="ctr">
               <a:buNone/>
             </a:pPr>
             <a:r>
@@ -2650,7 +2422,7 @@
           <a:bodyPr wrap="square" lIns="0" tIns="0" rIns="0" bIns="0" rtlCol="0" anchor="ctr"/>
           <a:lstStyle/>
           <a:p>
-            <a:pPr algn="ctr" indent="0" marL="0">
+            <a:pPr marL="0" indent="0" algn="ctr">
               <a:buNone/>
             </a:pPr>
             <a:r>
@@ -2722,14 +2494,14 @@
       </p:sp>
       <p:pic>
         <p:nvPicPr>
-          <p:cNvPr id="10" name="Image 1" descr="preencoded.png">    </p:cNvPr>
+          <p:cNvPr id="10" name="Image 1" descr="preencoded.png"/>
           <p:cNvPicPr>
             <a:picLocks noChangeAspect="1"/>
           </p:cNvPicPr>
           <p:nvPr/>
         </p:nvPicPr>
         <p:blipFill>
-          <a:blip r:embed="rId2"/>
+          <a:blip r:embed="rId4"/>
           <a:stretch>
             <a:fillRect/>
           </a:stretch>
@@ -2765,7 +2537,7 @@
           <a:bodyPr wrap="square" lIns="0" tIns="0" rIns="0" bIns="0" rtlCol="0" anchor="ctr"/>
           <a:lstStyle/>
           <a:p>
-            <a:pPr algn="ctr" indent="0" marL="0">
+            <a:pPr marL="0" indent="0" algn="ctr">
               <a:buNone/>
             </a:pPr>
             <a:r>
@@ -2804,7 +2576,7 @@
           <a:bodyPr wrap="square" lIns="0" tIns="0" rIns="0" bIns="0" rtlCol="0" anchor="ctr"/>
           <a:lstStyle/>
           <a:p>
-            <a:pPr algn="ctr" indent="0" marL="0">
+            <a:pPr marL="0" indent="0" algn="ctr">
               <a:buNone/>
             </a:pPr>
             <a:r>
@@ -2876,14 +2648,14 @@
       </p:sp>
       <p:pic>
         <p:nvPicPr>
-          <p:cNvPr id="15" name="Image 2" descr="preencoded.png">    </p:cNvPr>
+          <p:cNvPr id="15" name="Image 2" descr="preencoded.png"/>
           <p:cNvPicPr>
             <a:picLocks noChangeAspect="1"/>
           </p:cNvPicPr>
           <p:nvPr/>
         </p:nvPicPr>
         <p:blipFill>
-          <a:blip r:embed="rId3"/>
+          <a:blip r:embed="rId5"/>
           <a:stretch>
             <a:fillRect/>
           </a:stretch>
@@ -2919,7 +2691,7 @@
           <a:bodyPr wrap="square" lIns="0" tIns="0" rIns="0" bIns="0" rtlCol="0" anchor="ctr"/>
           <a:lstStyle/>
           <a:p>
-            <a:pPr algn="ctr" indent="0" marL="0">
+            <a:pPr marL="0" indent="0" algn="ctr">
               <a:buNone/>
             </a:pPr>
             <a:r>
@@ -2958,7 +2730,7 @@
           <a:bodyPr wrap="square" lIns="0" tIns="0" rIns="0" bIns="0" rtlCol="0" anchor="ctr"/>
           <a:lstStyle/>
           <a:p>
-            <a:pPr algn="ctr" indent="0" marL="0">
+            <a:pPr marL="0" indent="0" algn="ctr">
               <a:buNone/>
             </a:pPr>
             <a:r>
@@ -2992,6 +2764,7 @@
         <a:solidFill>
           <a:srgbClr val="0B3C49"/>
         </a:solidFill>
+        <a:effectLst/>
       </p:bgPr>
     </p:bg>
     <p:spTree>
@@ -3029,7 +2802,7 @@
           <a:bodyPr wrap="square" lIns="0" tIns="0" rIns="0" bIns="0" rtlCol="0" anchor="ctr"/>
           <a:lstStyle/>
           <a:p>
-            <a:pPr indent="0" marL="0">
+            <a:pPr marL="0" indent="0">
               <a:buNone/>
             </a:pPr>
             <a:r>
@@ -3101,14 +2874,14 @@
       </p:sp>
       <p:pic>
         <p:nvPicPr>
-          <p:cNvPr id="5" name="Image 0" descr="preencoded.png">    </p:cNvPr>
+          <p:cNvPr id="5" name="Image 0" descr="preencoded.png"/>
           <p:cNvPicPr>
             <a:picLocks noChangeAspect="1"/>
           </p:cNvPicPr>
           <p:nvPr/>
         </p:nvPicPr>
         <p:blipFill>
-          <a:blip r:embed="rId1"/>
+          <a:blip r:embed="rId3"/>
           <a:stretch>
             <a:fillRect/>
           </a:stretch>
@@ -3144,7 +2917,7 @@
           <a:bodyPr wrap="square" lIns="0" tIns="0" rIns="0" bIns="0" rtlCol="0" anchor="ctr"/>
           <a:lstStyle/>
           <a:p>
-            <a:pPr indent="0" marL="0">
+            <a:pPr marL="0" indent="0">
               <a:buNone/>
             </a:pPr>
             <a:r>
@@ -3183,7 +2956,7 @@
           <a:bodyPr wrap="square" lIns="0" tIns="0" rIns="0" bIns="0" rtlCol="0" anchor="ctr"/>
           <a:lstStyle/>
           <a:p>
-            <a:pPr indent="0" marL="0">
+            <a:pPr marL="0" indent="0">
               <a:buNone/>
             </a:pPr>
             <a:r>
@@ -3255,14 +3028,14 @@
       </p:sp>
       <p:pic>
         <p:nvPicPr>
-          <p:cNvPr id="10" name="Image 1" descr="preencoded.png">    </p:cNvPr>
+          <p:cNvPr id="10" name="Image 1" descr="preencoded.png"/>
           <p:cNvPicPr>
             <a:picLocks noChangeAspect="1"/>
           </p:cNvPicPr>
           <p:nvPr/>
         </p:nvPicPr>
         <p:blipFill>
-          <a:blip r:embed="rId2"/>
+          <a:blip r:embed="rId4"/>
           <a:stretch>
             <a:fillRect/>
           </a:stretch>
@@ -3298,7 +3071,7 @@
           <a:bodyPr wrap="square" lIns="0" tIns="0" rIns="0" bIns="0" rtlCol="0" anchor="ctr"/>
           <a:lstStyle/>
           <a:p>
-            <a:pPr indent="0" marL="0">
+            <a:pPr marL="0" indent="0">
               <a:buNone/>
             </a:pPr>
             <a:r>
@@ -3337,7 +3110,7 @@
           <a:bodyPr wrap="square" lIns="0" tIns="0" rIns="0" bIns="0" rtlCol="0" anchor="ctr"/>
           <a:lstStyle/>
           <a:p>
-            <a:pPr indent="0" marL="0">
+            <a:pPr marL="0" indent="0">
               <a:buNone/>
             </a:pPr>
             <a:r>
@@ -3409,14 +3182,14 @@
       </p:sp>
       <p:pic>
         <p:nvPicPr>
-          <p:cNvPr id="15" name="Image 2" descr="preencoded.png">    </p:cNvPr>
+          <p:cNvPr id="15" name="Image 2" descr="preencoded.png"/>
           <p:cNvPicPr>
             <a:picLocks noChangeAspect="1"/>
           </p:cNvPicPr>
           <p:nvPr/>
         </p:nvPicPr>
         <p:blipFill>
-          <a:blip r:embed="rId3"/>
+          <a:blip r:embed="rId5"/>
           <a:stretch>
             <a:fillRect/>
           </a:stretch>
@@ -3452,7 +3225,7 @@
           <a:bodyPr wrap="square" lIns="0" tIns="0" rIns="0" bIns="0" rtlCol="0" anchor="ctr"/>
           <a:lstStyle/>
           <a:p>
-            <a:pPr indent="0" marL="0">
+            <a:pPr marL="0" indent="0">
               <a:buNone/>
             </a:pPr>
             <a:r>
@@ -3491,7 +3264,7 @@
           <a:bodyPr wrap="square" lIns="0" tIns="0" rIns="0" bIns="0" rtlCol="0" anchor="ctr"/>
           <a:lstStyle/>
           <a:p>
-            <a:pPr indent="0" marL="0">
+            <a:pPr marL="0" indent="0">
               <a:buNone/>
             </a:pPr>
             <a:r>
@@ -3563,14 +3336,14 @@
       </p:sp>
       <p:pic>
         <p:nvPicPr>
-          <p:cNvPr id="20" name="Image 3" descr="preencoded.png">    </p:cNvPr>
+          <p:cNvPr id="20" name="Image 3" descr="preencoded.png"/>
           <p:cNvPicPr>
             <a:picLocks noChangeAspect="1"/>
           </p:cNvPicPr>
           <p:nvPr/>
         </p:nvPicPr>
         <p:blipFill>
-          <a:blip r:embed="rId4"/>
+          <a:blip r:embed="rId6"/>
           <a:stretch>
             <a:fillRect/>
           </a:stretch>
@@ -3606,7 +3379,7 @@
           <a:bodyPr wrap="square" lIns="0" tIns="0" rIns="0" bIns="0" rtlCol="0" anchor="ctr"/>
           <a:lstStyle/>
           <a:p>
-            <a:pPr indent="0" marL="0">
+            <a:pPr marL="0" indent="0">
               <a:buNone/>
             </a:pPr>
             <a:r>
@@ -3645,7 +3418,7 @@
           <a:bodyPr wrap="square" lIns="0" tIns="0" rIns="0" bIns="0" rtlCol="0" anchor="ctr"/>
           <a:lstStyle/>
           <a:p>
-            <a:pPr indent="0" marL="0">
+            <a:pPr marL="0" indent="0">
               <a:buNone/>
             </a:pPr>
             <a:r>
@@ -3717,14 +3490,14 @@
       </p:sp>
       <p:pic>
         <p:nvPicPr>
-          <p:cNvPr id="25" name="Image 4" descr="preencoded.png">    </p:cNvPr>
+          <p:cNvPr id="25" name="Image 4" descr="preencoded.png"/>
           <p:cNvPicPr>
             <a:picLocks noChangeAspect="1"/>
           </p:cNvPicPr>
           <p:nvPr/>
         </p:nvPicPr>
         <p:blipFill>
-          <a:blip r:embed="rId5"/>
+          <a:blip r:embed="rId7"/>
           <a:stretch>
             <a:fillRect/>
           </a:stretch>
@@ -3760,7 +3533,7 @@
           <a:bodyPr wrap="square" lIns="0" tIns="0" rIns="0" bIns="0" rtlCol="0" anchor="ctr"/>
           <a:lstStyle/>
           <a:p>
-            <a:pPr indent="0" marL="0">
+            <a:pPr marL="0" indent="0">
               <a:buNone/>
             </a:pPr>
             <a:r>
@@ -3799,7 +3572,7 @@
           <a:bodyPr wrap="square" lIns="0" tIns="0" rIns="0" bIns="0" rtlCol="0" anchor="ctr"/>
           <a:lstStyle/>
           <a:p>
-            <a:pPr indent="0" marL="0">
+            <a:pPr marL="0" indent="0">
               <a:buNone/>
             </a:pPr>
             <a:r>
@@ -3871,14 +3644,14 @@
       </p:sp>
       <p:pic>
         <p:nvPicPr>
-          <p:cNvPr id="30" name="Image 5" descr="preencoded.png">    </p:cNvPr>
+          <p:cNvPr id="30" name="Image 5" descr="preencoded.png"/>
           <p:cNvPicPr>
             <a:picLocks noChangeAspect="1"/>
           </p:cNvPicPr>
           <p:nvPr/>
         </p:nvPicPr>
         <p:blipFill>
-          <a:blip r:embed="rId6"/>
+          <a:blip r:embed="rId8"/>
           <a:stretch>
             <a:fillRect/>
           </a:stretch>
@@ -3914,7 +3687,7 @@
           <a:bodyPr wrap="square" lIns="0" tIns="0" rIns="0" bIns="0" rtlCol="0" anchor="ctr"/>
           <a:lstStyle/>
           <a:p>
-            <a:pPr indent="0" marL="0">
+            <a:pPr marL="0" indent="0">
               <a:buNone/>
             </a:pPr>
             <a:r>
@@ -3953,7 +3726,7 @@
           <a:bodyPr wrap="square" lIns="0" tIns="0" rIns="0" bIns="0" rtlCol="0" anchor="ctr"/>
           <a:lstStyle/>
           <a:p>
-            <a:pPr indent="0" marL="0">
+            <a:pPr marL="0" indent="0">
               <a:buNone/>
             </a:pPr>
             <a:r>
@@ -3987,6 +3760,7 @@
         <a:solidFill>
           <a:srgbClr val="FFFFFF"/>
         </a:solidFill>
+        <a:effectLst/>
       </p:bgPr>
     </p:bg>
     <p:spTree>
@@ -4024,7 +3798,7 @@
           <a:bodyPr wrap="square" lIns="0" tIns="0" rIns="0" bIns="0" rtlCol="0" anchor="ctr"/>
           <a:lstStyle/>
           <a:p>
-            <a:pPr indent="0" marL="0">
+            <a:pPr marL="0" indent="0">
               <a:buNone/>
             </a:pPr>
             <a:r>
@@ -4090,7 +3864,7 @@
           <a:bodyPr wrap="square" lIns="0" tIns="0" rIns="0" bIns="0" rtlCol="0" anchor="ctr"/>
           <a:lstStyle/>
           <a:p>
-            <a:pPr indent="0" marL="0">
+            <a:pPr marL="0" indent="0">
               <a:buNone/>
             </a:pPr>
             <a:r>
@@ -4129,7 +3903,7 @@
           <a:bodyPr wrap="square" lIns="0" tIns="0" rIns="0" bIns="0" rtlCol="0" anchor="ctr"/>
           <a:lstStyle/>
           <a:p>
-            <a:pPr indent="0" marL="0">
+            <a:pPr marL="0" indent="0">
               <a:buNone/>
             </a:pPr>
             <a:r>
@@ -4195,7 +3969,7 @@
           <a:bodyPr wrap="square" lIns="0" tIns="0" rIns="0" bIns="0" rtlCol="0" anchor="ctr"/>
           <a:lstStyle/>
           <a:p>
-            <a:pPr indent="0" marL="0">
+            <a:pPr marL="0" indent="0">
               <a:buNone/>
             </a:pPr>
             <a:r>
@@ -4234,7 +4008,7 @@
           <a:bodyPr wrap="square" lIns="0" tIns="0" rIns="0" bIns="0" rtlCol="0" anchor="ctr"/>
           <a:lstStyle/>
           <a:p>
-            <a:pPr indent="0" marL="0">
+            <a:pPr marL="0" indent="0">
               <a:buNone/>
             </a:pPr>
             <a:r>
@@ -4300,7 +4074,7 @@
           <a:bodyPr wrap="square" lIns="0" tIns="0" rIns="0" bIns="0" rtlCol="0" anchor="ctr"/>
           <a:lstStyle/>
           <a:p>
-            <a:pPr indent="0" marL="0">
+            <a:pPr marL="0" indent="0">
               <a:buNone/>
             </a:pPr>
             <a:r>
@@ -4339,7 +4113,7 @@
           <a:bodyPr wrap="square" lIns="0" tIns="0" rIns="0" bIns="0" rtlCol="0" anchor="ctr"/>
           <a:lstStyle/>
           <a:p>
-            <a:pPr indent="0" marL="0">
+            <a:pPr marL="0" indent="0">
               <a:buNone/>
             </a:pPr>
             <a:r>
@@ -4405,7 +4179,7 @@
           <a:bodyPr wrap="square" lIns="0" tIns="0" rIns="0" bIns="0" rtlCol="0" anchor="ctr"/>
           <a:lstStyle/>
           <a:p>
-            <a:pPr indent="0" marL="0">
+            <a:pPr marL="0" indent="0">
               <a:buNone/>
             </a:pPr>
             <a:r>
@@ -4444,7 +4218,7 @@
           <a:bodyPr wrap="square" lIns="0" tIns="0" rIns="0" bIns="0" rtlCol="0" anchor="ctr"/>
           <a:lstStyle/>
           <a:p>
-            <a:pPr indent="0" marL="0">
+            <a:pPr marL="0" indent="0">
               <a:buNone/>
             </a:pPr>
             <a:r>
@@ -4510,7 +4284,7 @@
           <a:bodyPr wrap="square" lIns="0" tIns="0" rIns="0" bIns="0" rtlCol="0" anchor="ctr"/>
           <a:lstStyle/>
           <a:p>
-            <a:pPr indent="0" marL="0">
+            <a:pPr marL="0" indent="0">
               <a:buNone/>
             </a:pPr>
             <a:r>
@@ -4549,7 +4323,7 @@
           <a:bodyPr wrap="square" lIns="0" tIns="0" rIns="0" bIns="0" rtlCol="0" anchor="ctr"/>
           <a:lstStyle/>
           <a:p>
-            <a:pPr indent="0" marL="0">
+            <a:pPr marL="0" indent="0">
               <a:buNone/>
             </a:pPr>
             <a:r>
@@ -4615,7 +4389,7 @@
           <a:bodyPr wrap="square" lIns="0" tIns="0" rIns="0" bIns="0" rtlCol="0" anchor="ctr"/>
           <a:lstStyle/>
           <a:p>
-            <a:pPr algn="ctr" indent="0" marL="0">
+            <a:pPr marL="0" indent="0" algn="ctr">
               <a:buNone/>
             </a:pPr>
             <a:r>
@@ -4681,7 +4455,7 @@
           <a:bodyPr wrap="square" lIns="0" tIns="0" rIns="0" bIns="0" rtlCol="0" anchor="ctr"/>
           <a:lstStyle/>
           <a:p>
-            <a:pPr algn="ctr" indent="0" marL="0">
+            <a:pPr marL="0" indent="0" algn="ctr">
               <a:buNone/>
             </a:pPr>
             <a:r>
@@ -4747,7 +4521,7 @@
           <a:bodyPr wrap="square" lIns="0" tIns="0" rIns="0" bIns="0" rtlCol="0" anchor="ctr"/>
           <a:lstStyle/>
           <a:p>
-            <a:pPr algn="ctr" indent="0" marL="0">
+            <a:pPr marL="0" indent="0" algn="ctr">
               <a:buNone/>
             </a:pPr>
             <a:r>
@@ -4813,7 +4587,7 @@
           <a:bodyPr wrap="square" lIns="0" tIns="0" rIns="0" bIns="0" rtlCol="0" anchor="ctr"/>
           <a:lstStyle/>
           <a:p>
-            <a:pPr algn="ctr" indent="0" marL="0">
+            <a:pPr marL="0" indent="0" algn="ctr">
               <a:buNone/>
             </a:pPr>
             <a:r>
@@ -4879,7 +4653,7 @@
           <a:bodyPr wrap="square" lIns="0" tIns="0" rIns="0" bIns="0" rtlCol="0" anchor="ctr"/>
           <a:lstStyle/>
           <a:p>
-            <a:pPr algn="ctr" indent="0" marL="0">
+            <a:pPr marL="0" indent="0" algn="ctr">
               <a:buNone/>
             </a:pPr>
             <a:r>
@@ -4945,7 +4719,7 @@
           <a:bodyPr wrap="square" lIns="0" tIns="0" rIns="0" bIns="0" rtlCol="0" anchor="ctr"/>
           <a:lstStyle/>
           <a:p>
-            <a:pPr algn="ctr" indent="0" marL="0">
+            <a:pPr marL="0" indent="0" algn="ctr">
               <a:buNone/>
             </a:pPr>
             <a:r>
@@ -5011,7 +4785,7 @@
           <a:bodyPr wrap="square" lIns="0" tIns="0" rIns="0" bIns="0" rtlCol="0" anchor="ctr"/>
           <a:lstStyle/>
           <a:p>
-            <a:pPr algn="ctr" indent="0" marL="0">
+            <a:pPr marL="0" indent="0" algn="ctr">
               <a:buNone/>
             </a:pPr>
             <a:r>
@@ -5045,6 +4819,7 @@
         <a:solidFill>
           <a:srgbClr val="FFFFFF"/>
         </a:solidFill>
+        <a:effectLst/>
       </p:bgPr>
     </p:bg>
     <p:spTree>
@@ -5082,7 +4857,7 @@
           <a:bodyPr wrap="square" lIns="0" tIns="0" rIns="0" bIns="0" rtlCol="0" anchor="ctr"/>
           <a:lstStyle/>
           <a:p>
-            <a:pPr indent="0" marL="0">
+            <a:pPr marL="0" indent="0">
               <a:buNone/>
             </a:pPr>
             <a:r>
@@ -5148,7 +4923,7 @@
           <a:bodyPr wrap="square" lIns="0" tIns="0" rIns="0" bIns="0" rtlCol="0" anchor="ctr"/>
           <a:lstStyle/>
           <a:p>
-            <a:pPr algn="ctr" indent="0" marL="0">
+            <a:pPr marL="0" indent="0" algn="ctr">
               <a:buNone/>
             </a:pPr>
             <a:r>
@@ -5214,7 +4989,7 @@
           <a:bodyPr wrap="square" lIns="0" tIns="0" rIns="0" bIns="0" rtlCol="0" anchor="ctr"/>
           <a:lstStyle/>
           <a:p>
-            <a:pPr algn="ctr" indent="0" marL="0">
+            <a:pPr marL="0" indent="0" algn="ctr">
               <a:buNone/>
             </a:pPr>
             <a:r>
@@ -5280,7 +5055,7 @@
           <a:bodyPr wrap="square" lIns="0" tIns="0" rIns="0" bIns="0" rtlCol="0" anchor="ctr"/>
           <a:lstStyle/>
           <a:p>
-            <a:pPr algn="ctr" indent="0" marL="0">
+            <a:pPr marL="0" indent="0" algn="ctr">
               <a:buNone/>
             </a:pPr>
             <a:r>
@@ -5346,7 +5121,7 @@
           <a:bodyPr wrap="square" lIns="0" tIns="0" rIns="0" bIns="0" rtlCol="0" anchor="ctr"/>
           <a:lstStyle/>
           <a:p>
-            <a:pPr algn="ctr" indent="0" marL="0">
+            <a:pPr marL="0" indent="0" algn="ctr">
               <a:buNone/>
             </a:pPr>
             <a:r>
@@ -5385,7 +5160,7 @@
           <a:bodyPr wrap="square" lIns="0" tIns="0" rIns="0" bIns="0" rtlCol="0" anchor="ctr"/>
           <a:lstStyle/>
           <a:p>
-            <a:pPr indent="0" marL="0">
+            <a:pPr marL="0" indent="0">
               <a:buNone/>
             </a:pPr>
             <a:r>
@@ -5430,15 +5205,15 @@
       </p:sp>
       <p:pic>
         <p:nvPicPr>
-          <p:cNvPr id="13" name="Image 0" descr="screenshots/report.png">    </p:cNvPr>
+          <p:cNvPr id="13" name="Image 0" descr="screenshots/report.png"/>
           <p:cNvPicPr>
             <a:picLocks noChangeAspect="1"/>
           </p:cNvPicPr>
           <p:nvPr/>
         </p:nvPicPr>
         <p:blipFill>
-          <a:blip r:embed="rId1"/>
-          <a:srcRect l="0" r="0" t="0" b="0"/>
+          <a:blip r:embed="rId3"/>
+          <a:srcRect/>
           <a:stretch/>
         </p:blipFill>
         <p:spPr>
@@ -5478,14 +5253,14 @@
       </p:sp>
       <p:pic>
         <p:nvPicPr>
-          <p:cNvPr id="15" name="Image 1" descr="preencoded.png">    </p:cNvPr>
+          <p:cNvPr id="15" name="Image 1" descr="preencoded.png"/>
           <p:cNvPicPr>
             <a:picLocks noChangeAspect="1"/>
           </p:cNvPicPr>
           <p:nvPr/>
         </p:nvPicPr>
         <p:blipFill>
-          <a:blip r:embed="rId2"/>
+          <a:blip r:embed="rId4"/>
           <a:stretch>
             <a:fillRect/>
           </a:stretch>
@@ -5521,7 +5296,7 @@
           <a:bodyPr wrap="square" lIns="0" tIns="0" rIns="0" bIns="0" rtlCol="0" anchor="ctr"/>
           <a:lstStyle/>
           <a:p>
-            <a:pPr indent="0" marL="0">
+            <a:pPr marL="0" indent="0">
               <a:buNone/>
             </a:pPr>
             <a:r>
@@ -5566,14 +5341,14 @@
       </p:sp>
       <p:pic>
         <p:nvPicPr>
-          <p:cNvPr id="18" name="Image 2" descr="preencoded.png">    </p:cNvPr>
+          <p:cNvPr id="18" name="Image 2" descr="preencoded.png"/>
           <p:cNvPicPr>
             <a:picLocks noChangeAspect="1"/>
           </p:cNvPicPr>
           <p:nvPr/>
         </p:nvPicPr>
         <p:blipFill>
-          <a:blip r:embed="rId3"/>
+          <a:blip r:embed="rId5"/>
           <a:stretch>
             <a:fillRect/>
           </a:stretch>
@@ -5609,7 +5384,7 @@
           <a:bodyPr wrap="square" lIns="0" tIns="0" rIns="0" bIns="0" rtlCol="0" anchor="ctr"/>
           <a:lstStyle/>
           <a:p>
-            <a:pPr indent="0" marL="0">
+            <a:pPr marL="0" indent="0">
               <a:buNone/>
             </a:pPr>
             <a:r>
@@ -5654,14 +5429,14 @@
       </p:sp>
       <p:pic>
         <p:nvPicPr>
-          <p:cNvPr id="21" name="Image 3" descr="preencoded.png">    </p:cNvPr>
+          <p:cNvPr id="21" name="Image 3" descr="preencoded.png"/>
           <p:cNvPicPr>
             <a:picLocks noChangeAspect="1"/>
           </p:cNvPicPr>
           <p:nvPr/>
         </p:nvPicPr>
         <p:blipFill>
-          <a:blip r:embed="rId4"/>
+          <a:blip r:embed="rId6"/>
           <a:stretch>
             <a:fillRect/>
           </a:stretch>
@@ -5697,7 +5472,7 @@
           <a:bodyPr wrap="square" lIns="0" tIns="0" rIns="0" bIns="0" rtlCol="0" anchor="ctr"/>
           <a:lstStyle/>
           <a:p>
-            <a:pPr indent="0" marL="0">
+            <a:pPr marL="0" indent="0">
               <a:buNone/>
             </a:pPr>
             <a:r>
@@ -5731,6 +5506,7 @@
         <a:solidFill>
           <a:srgbClr val="FFFFFF"/>
         </a:solidFill>
+        <a:effectLst/>
       </p:bgPr>
     </p:bg>
     <p:spTree>
@@ -5768,7 +5544,7 @@
           <a:bodyPr wrap="square" lIns="0" tIns="0" rIns="0" bIns="0" rtlCol="0" anchor="ctr"/>
           <a:lstStyle/>
           <a:p>
-            <a:pPr indent="0" marL="0">
+            <a:pPr marL="0" indent="0">
               <a:buNone/>
             </a:pPr>
             <a:r>
@@ -5861,7 +5637,7 @@
           <a:bodyPr wrap="square" lIns="0" tIns="0" rIns="0" bIns="0" rtlCol="0" anchor="ctr"/>
           <a:lstStyle/>
           <a:p>
-            <a:pPr indent="0" marL="0">
+            <a:pPr marL="0" indent="0">
               <a:buNone/>
             </a:pPr>
             <a:r>
@@ -6027,7 +5803,7 @@
           <a:bodyPr wrap="square" lIns="0" tIns="0" rIns="0" bIns="0" rtlCol="0" anchor="ctr"/>
           <a:lstStyle/>
           <a:p>
-            <a:pPr indent="0" marL="0">
+            <a:pPr marL="0" indent="0">
               <a:buNone/>
             </a:pPr>
             <a:r>
@@ -6167,6 +5943,7 @@
         <a:solidFill>
           <a:srgbClr val="FFFFFF"/>
         </a:solidFill>
+        <a:effectLst/>
       </p:bgPr>
     </p:bg>
     <p:spTree>
@@ -6204,7 +5981,7 @@
           <a:bodyPr wrap="square" lIns="0" tIns="0" rIns="0" bIns="0" rtlCol="0" anchor="ctr"/>
           <a:lstStyle/>
           <a:p>
-            <a:pPr indent="0" marL="0">
+            <a:pPr marL="0" indent="0">
               <a:buNone/>
             </a:pPr>
             <a:r>
@@ -6216,7 +5993,7 @@
                 <a:ea typeface="Cambria" pitchFamily="34" charset="-122"/>
                 <a:cs typeface="Cambria" pitchFamily="34" charset="-120"/>
               </a:rPr>
-              <a:t>Jamoa: 404 Found</a:t>
+              <a:t>Jamoa: 404</a:t>
             </a:r>
             <a:endParaRPr lang="en-US" sz="3600" dirty="0"/>
           </a:p>
@@ -6276,14 +6053,14 @@
       </p:sp>
       <p:pic>
         <p:nvPicPr>
-          <p:cNvPr id="5" name="Image 0" descr="preencoded.png">    </p:cNvPr>
+          <p:cNvPr id="5" name="Image 0" descr="preencoded.png"/>
           <p:cNvPicPr>
             <a:picLocks noChangeAspect="1"/>
           </p:cNvPicPr>
           <p:nvPr/>
         </p:nvPicPr>
         <p:blipFill>
-          <a:blip r:embed="rId1"/>
+          <a:blip r:embed="rId3"/>
           <a:stretch>
             <a:fillRect/>
           </a:stretch>
@@ -6319,7 +6096,7 @@
           <a:bodyPr wrap="square" lIns="0" tIns="0" rIns="0" bIns="0" rtlCol="0" anchor="ctr"/>
           <a:lstStyle/>
           <a:p>
-            <a:pPr indent="0" marL="0">
+            <a:pPr marL="0" indent="0">
               <a:buNone/>
             </a:pPr>
             <a:r>
@@ -6358,7 +6135,7 @@
           <a:bodyPr wrap="square" lIns="0" tIns="0" rIns="0" bIns="0" rtlCol="0" anchor="ctr"/>
           <a:lstStyle/>
           <a:p>
-            <a:pPr indent="0" marL="0">
+            <a:pPr marL="0" indent="0">
               <a:buNone/>
             </a:pPr>
             <a:r>
@@ -6397,7 +6174,7 @@
           <a:bodyPr wrap="square" lIns="0" tIns="0" rIns="0" bIns="0" rtlCol="0" anchor="ctr"/>
           <a:lstStyle/>
           <a:p>
-            <a:pPr indent="0" marL="0">
+            <a:pPr marL="0" indent="0">
               <a:buNone/>
             </a:pPr>
             <a:r>
@@ -6469,14 +6246,14 @@
       </p:sp>
       <p:pic>
         <p:nvPicPr>
-          <p:cNvPr id="11" name="Image 1" descr="preencoded.png">    </p:cNvPr>
+          <p:cNvPr id="11" name="Image 1" descr="preencoded.png"/>
           <p:cNvPicPr>
             <a:picLocks noChangeAspect="1"/>
           </p:cNvPicPr>
           <p:nvPr/>
         </p:nvPicPr>
         <p:blipFill>
-          <a:blip r:embed="rId2"/>
+          <a:blip r:embed="rId4"/>
           <a:stretch>
             <a:fillRect/>
           </a:stretch>
@@ -6512,7 +6289,7 @@
           <a:bodyPr wrap="square" lIns="0" tIns="0" rIns="0" bIns="0" rtlCol="0" anchor="ctr"/>
           <a:lstStyle/>
           <a:p>
-            <a:pPr indent="0" marL="0">
+            <a:pPr marL="0" indent="0">
               <a:buNone/>
             </a:pPr>
             <a:r>
@@ -6551,7 +6328,7 @@
           <a:bodyPr wrap="square" lIns="0" tIns="0" rIns="0" bIns="0" rtlCol="0" anchor="ctr"/>
           <a:lstStyle/>
           <a:p>
-            <a:pPr indent="0" marL="0">
+            <a:pPr marL="0" indent="0">
               <a:buNone/>
             </a:pPr>
             <a:r>
@@ -6590,7 +6367,7 @@
           <a:bodyPr wrap="square" lIns="0" tIns="0" rIns="0" bIns="0" rtlCol="0" anchor="ctr"/>
           <a:lstStyle/>
           <a:p>
-            <a:pPr indent="0" marL="0">
+            <a:pPr marL="0" indent="0">
               <a:buNone/>
             </a:pPr>
             <a:r>
@@ -6662,14 +6439,14 @@
       </p:sp>
       <p:pic>
         <p:nvPicPr>
-          <p:cNvPr id="17" name="Image 2" descr="preencoded.png">    </p:cNvPr>
+          <p:cNvPr id="17" name="Image 2" descr="preencoded.png"/>
           <p:cNvPicPr>
             <a:picLocks noChangeAspect="1"/>
           </p:cNvPicPr>
           <p:nvPr/>
         </p:nvPicPr>
         <p:blipFill>
-          <a:blip r:embed="rId3"/>
+          <a:blip r:embed="rId5"/>
           <a:stretch>
             <a:fillRect/>
           </a:stretch>
@@ -6705,7 +6482,7 @@
           <a:bodyPr wrap="square" lIns="0" tIns="0" rIns="0" bIns="0" rtlCol="0" anchor="ctr"/>
           <a:lstStyle/>
           <a:p>
-            <a:pPr indent="0" marL="0">
+            <a:pPr marL="0" indent="0">
               <a:buNone/>
             </a:pPr>
             <a:r>
@@ -6744,7 +6521,7 @@
           <a:bodyPr wrap="square" lIns="0" tIns="0" rIns="0" bIns="0" rtlCol="0" anchor="ctr"/>
           <a:lstStyle/>
           <a:p>
-            <a:pPr indent="0" marL="0">
+            <a:pPr marL="0" indent="0">
               <a:buNone/>
             </a:pPr>
             <a:r>
@@ -6783,7 +6560,7 @@
           <a:bodyPr wrap="square" lIns="0" tIns="0" rIns="0" bIns="0" rtlCol="0" anchor="ctr"/>
           <a:lstStyle/>
           <a:p>
-            <a:pPr indent="0" marL="0">
+            <a:pPr marL="0" indent="0">
               <a:buNone/>
             </a:pPr>
             <a:r>
@@ -6855,14 +6632,14 @@
       </p:sp>
       <p:pic>
         <p:nvPicPr>
-          <p:cNvPr id="23" name="Image 3" descr="preencoded.png">    </p:cNvPr>
+          <p:cNvPr id="23" name="Image 3" descr="preencoded.png"/>
           <p:cNvPicPr>
             <a:picLocks noChangeAspect="1"/>
           </p:cNvPicPr>
           <p:nvPr/>
         </p:nvPicPr>
         <p:blipFill>
-          <a:blip r:embed="rId4"/>
+          <a:blip r:embed="rId6"/>
           <a:stretch>
             <a:fillRect/>
           </a:stretch>
@@ -6898,7 +6675,7 @@
           <a:bodyPr wrap="square" lIns="0" tIns="0" rIns="0" bIns="0" rtlCol="0" anchor="ctr"/>
           <a:lstStyle/>
           <a:p>
-            <a:pPr indent="0" marL="0">
+            <a:pPr marL="0" indent="0">
               <a:buNone/>
             </a:pPr>
             <a:r>
@@ -6937,7 +6714,7 @@
           <a:bodyPr wrap="square" lIns="0" tIns="0" rIns="0" bIns="0" rtlCol="0" anchor="ctr"/>
           <a:lstStyle/>
           <a:p>
-            <a:pPr indent="0" marL="0">
+            <a:pPr marL="0" indent="0">
               <a:buNone/>
             </a:pPr>
             <a:r>
@@ -6976,7 +6753,7 @@
           <a:bodyPr wrap="square" lIns="0" tIns="0" rIns="0" bIns="0" rtlCol="0" anchor="ctr"/>
           <a:lstStyle/>
           <a:p>
-            <a:pPr indent="0" marL="0">
+            <a:pPr marL="0" indent="0">
               <a:buNone/>
             </a:pPr>
             <a:r>
@@ -7048,14 +6825,14 @@
       </p:sp>
       <p:pic>
         <p:nvPicPr>
-          <p:cNvPr id="29" name="Image 4" descr="preencoded.png">    </p:cNvPr>
+          <p:cNvPr id="29" name="Image 4" descr="preencoded.png"/>
           <p:cNvPicPr>
             <a:picLocks noChangeAspect="1"/>
           </p:cNvPicPr>
           <p:nvPr/>
         </p:nvPicPr>
         <p:blipFill>
-          <a:blip r:embed="rId5"/>
+          <a:blip r:embed="rId7"/>
           <a:stretch>
             <a:fillRect/>
           </a:stretch>
@@ -7091,7 +6868,7 @@
           <a:bodyPr wrap="square" lIns="0" tIns="0" rIns="0" bIns="0" rtlCol="0" anchor="ctr"/>
           <a:lstStyle/>
           <a:p>
-            <a:pPr indent="0" marL="0">
+            <a:pPr marL="0" indent="0">
               <a:buNone/>
             </a:pPr>
             <a:r>
@@ -7130,7 +6907,7 @@
           <a:bodyPr wrap="square" lIns="0" tIns="0" rIns="0" bIns="0" rtlCol="0" anchor="ctr"/>
           <a:lstStyle/>
           <a:p>
-            <a:pPr indent="0" marL="0">
+            <a:pPr marL="0" indent="0">
               <a:buNone/>
             </a:pPr>
             <a:r>
@@ -7169,7 +6946,7 @@
           <a:bodyPr wrap="square" lIns="0" tIns="0" rIns="0" bIns="0" rtlCol="0" anchor="ctr"/>
           <a:lstStyle/>
           <a:p>
-            <a:pPr indent="0" marL="0">
+            <a:pPr marL="0" indent="0">
               <a:buNone/>
             </a:pPr>
             <a:r>
@@ -7241,14 +7018,14 @@
       </p:sp>
       <p:pic>
         <p:nvPicPr>
-          <p:cNvPr id="35" name="Image 5" descr="preencoded.png">    </p:cNvPr>
+          <p:cNvPr id="35" name="Image 5" descr="preencoded.png"/>
           <p:cNvPicPr>
             <a:picLocks noChangeAspect="1"/>
           </p:cNvPicPr>
           <p:nvPr/>
         </p:nvPicPr>
         <p:blipFill>
-          <a:blip r:embed="rId6"/>
+          <a:blip r:embed="rId8"/>
           <a:stretch>
             <a:fillRect/>
           </a:stretch>
@@ -7284,7 +7061,7 @@
           <a:bodyPr wrap="square" lIns="0" tIns="0" rIns="0" bIns="0" rtlCol="0" anchor="ctr"/>
           <a:lstStyle/>
           <a:p>
-            <a:pPr indent="0" marL="0">
+            <a:pPr marL="0" indent="0">
               <a:buNone/>
             </a:pPr>
             <a:r>
@@ -7323,7 +7100,7 @@
           <a:bodyPr wrap="square" lIns="0" tIns="0" rIns="0" bIns="0" rtlCol="0" anchor="ctr"/>
           <a:lstStyle/>
           <a:p>
-            <a:pPr indent="0" marL="0">
+            <a:pPr marL="0" indent="0">
               <a:buNone/>
             </a:pPr>
             <a:r>
@@ -7362,7 +7139,7 @@
           <a:bodyPr wrap="square" lIns="0" tIns="0" rIns="0" bIns="0" rtlCol="0" anchor="ctr"/>
           <a:lstStyle/>
           <a:p>
-            <a:pPr indent="0" marL="0">
+            <a:pPr marL="0" indent="0">
               <a:buNone/>
             </a:pPr>
             <a:r>
@@ -7396,6 +7173,7 @@
         <a:solidFill>
           <a:srgbClr val="0B3C49"/>
         </a:solidFill>
+        <a:effectLst/>
       </p:bgPr>
     </p:bg>
     <p:spTree>
@@ -7458,7 +7236,7 @@
           <a:bodyPr wrap="square" lIns="0" tIns="0" rIns="0" bIns="0" rtlCol="0" anchor="ctr"/>
           <a:lstStyle/>
           <a:p>
-            <a:pPr algn="ctr" indent="0" marL="0">
+            <a:pPr marL="0" indent="0" algn="ctr">
               <a:buNone/>
             </a:pPr>
             <a:r>
@@ -7497,7 +7275,7 @@
           <a:bodyPr wrap="square" lIns="0" tIns="0" rIns="0" bIns="0" rtlCol="0" anchor="ctr"/>
           <a:lstStyle/>
           <a:p>
-            <a:pPr algn="ctr" indent="0" marL="0">
+            <a:pPr marL="0" indent="0" algn="ctr">
               <a:buNone/>
             </a:pPr>
             <a:r>
@@ -7536,7 +7314,7 @@
           <a:bodyPr wrap="square" lIns="0" tIns="0" rIns="0" bIns="0" rtlCol="0" anchor="ctr"/>
           <a:lstStyle/>
           <a:p>
-            <a:pPr algn="ctr" indent="0" marL="0">
+            <a:pPr marL="0" indent="0" algn="ctr">
               <a:buNone/>
             </a:pPr>
             <a:r>
@@ -7570,6 +7348,7 @@
         <a:solidFill>
           <a:srgbClr val="FFFFFF"/>
         </a:solidFill>
+        <a:effectLst/>
       </p:bgPr>
     </p:bg>
     <p:spTree>
@@ -7607,7 +7386,7 @@
           <a:bodyPr wrap="square" lIns="0" tIns="0" rIns="0" bIns="0" rtlCol="0" anchor="ctr"/>
           <a:lstStyle/>
           <a:p>
-            <a:pPr indent="0" marL="0">
+            <a:pPr marL="0" indent="0">
               <a:buNone/>
             </a:pPr>
             <a:r>
@@ -7679,14 +7458,14 @@
       </p:sp>
       <p:pic>
         <p:nvPicPr>
-          <p:cNvPr id="5" name="Image 0" descr="preencoded.png">    </p:cNvPr>
+          <p:cNvPr id="5" name="Image 0" descr="preencoded.png"/>
           <p:cNvPicPr>
             <a:picLocks noChangeAspect="1"/>
           </p:cNvPicPr>
           <p:nvPr/>
         </p:nvPicPr>
         <p:blipFill>
-          <a:blip r:embed="rId1"/>
+          <a:blip r:embed="rId3"/>
           <a:stretch>
             <a:fillRect/>
           </a:stretch>
@@ -7722,7 +7501,7 @@
           <a:bodyPr wrap="square" lIns="0" tIns="0" rIns="0" bIns="0" rtlCol="0" anchor="ctr"/>
           <a:lstStyle/>
           <a:p>
-            <a:pPr indent="0" marL="0">
+            <a:pPr marL="0" indent="0">
               <a:buNone/>
             </a:pPr>
             <a:r>
@@ -7761,7 +7540,7 @@
           <a:bodyPr wrap="square" lIns="0" tIns="0" rIns="0" bIns="0" rtlCol="0" anchor="ctr"/>
           <a:lstStyle/>
           <a:p>
-            <a:pPr indent="0" marL="0">
+            <a:pPr marL="0" indent="0">
               <a:buNone/>
             </a:pPr>
             <a:r>
@@ -7833,14 +7612,14 @@
       </p:sp>
       <p:pic>
         <p:nvPicPr>
-          <p:cNvPr id="10" name="Image 1" descr="preencoded.png">    </p:cNvPr>
+          <p:cNvPr id="10" name="Image 1" descr="preencoded.png"/>
           <p:cNvPicPr>
             <a:picLocks noChangeAspect="1"/>
           </p:cNvPicPr>
           <p:nvPr/>
         </p:nvPicPr>
         <p:blipFill>
-          <a:blip r:embed="rId2"/>
+          <a:blip r:embed="rId4"/>
           <a:stretch>
             <a:fillRect/>
           </a:stretch>
@@ -7876,7 +7655,7 @@
           <a:bodyPr wrap="square" lIns="0" tIns="0" rIns="0" bIns="0" rtlCol="0" anchor="ctr"/>
           <a:lstStyle/>
           <a:p>
-            <a:pPr indent="0" marL="0">
+            <a:pPr marL="0" indent="0">
               <a:buNone/>
             </a:pPr>
             <a:r>
@@ -7915,7 +7694,7 @@
           <a:bodyPr wrap="square" lIns="0" tIns="0" rIns="0" bIns="0" rtlCol="0" anchor="ctr"/>
           <a:lstStyle/>
           <a:p>
-            <a:pPr indent="0" marL="0">
+            <a:pPr marL="0" indent="0">
               <a:buNone/>
             </a:pPr>
             <a:r>
@@ -7987,14 +7766,14 @@
       </p:sp>
       <p:pic>
         <p:nvPicPr>
-          <p:cNvPr id="15" name="Image 2" descr="preencoded.png">    </p:cNvPr>
+          <p:cNvPr id="15" name="Image 2" descr="preencoded.png"/>
           <p:cNvPicPr>
             <a:picLocks noChangeAspect="1"/>
           </p:cNvPicPr>
           <p:nvPr/>
         </p:nvPicPr>
         <p:blipFill>
-          <a:blip r:embed="rId3"/>
+          <a:blip r:embed="rId5"/>
           <a:stretch>
             <a:fillRect/>
           </a:stretch>
@@ -8030,7 +7809,7 @@
           <a:bodyPr wrap="square" lIns="0" tIns="0" rIns="0" bIns="0" rtlCol="0" anchor="ctr"/>
           <a:lstStyle/>
           <a:p>
-            <a:pPr indent="0" marL="0">
+            <a:pPr marL="0" indent="0">
               <a:buNone/>
             </a:pPr>
             <a:r>
@@ -8069,7 +7848,7 @@
           <a:bodyPr wrap="square" lIns="0" tIns="0" rIns="0" bIns="0" rtlCol="0" anchor="ctr"/>
           <a:lstStyle/>
           <a:p>
-            <a:pPr indent="0" marL="0">
+            <a:pPr marL="0" indent="0">
               <a:buNone/>
             </a:pPr>
             <a:r>
@@ -8141,14 +7920,14 @@
       </p:sp>
       <p:pic>
         <p:nvPicPr>
-          <p:cNvPr id="20" name="Image 3" descr="preencoded.png">    </p:cNvPr>
+          <p:cNvPr id="20" name="Image 3" descr="preencoded.png"/>
           <p:cNvPicPr>
             <a:picLocks noChangeAspect="1"/>
           </p:cNvPicPr>
           <p:nvPr/>
         </p:nvPicPr>
         <p:blipFill>
-          <a:blip r:embed="rId4"/>
+          <a:blip r:embed="rId6"/>
           <a:stretch>
             <a:fillRect/>
           </a:stretch>
@@ -8184,7 +7963,7 @@
           <a:bodyPr wrap="square" lIns="0" tIns="0" rIns="0" bIns="0" rtlCol="0" anchor="ctr"/>
           <a:lstStyle/>
           <a:p>
-            <a:pPr indent="0" marL="0">
+            <a:pPr marL="0" indent="0">
               <a:buNone/>
             </a:pPr>
             <a:r>
@@ -8223,7 +8002,7 @@
           <a:bodyPr wrap="square" lIns="0" tIns="0" rIns="0" bIns="0" rtlCol="0" anchor="ctr"/>
           <a:lstStyle/>
           <a:p>
-            <a:pPr indent="0" marL="0">
+            <a:pPr marL="0" indent="0">
               <a:buNone/>
             </a:pPr>
             <a:r>
@@ -8257,6 +8036,7 @@
         <a:solidFill>
           <a:srgbClr val="FFFFFF"/>
         </a:solidFill>
+        <a:effectLst/>
       </p:bgPr>
     </p:bg>
     <p:spTree>
@@ -8294,7 +8074,7 @@
           <a:bodyPr wrap="square" lIns="0" tIns="0" rIns="0" bIns="0" rtlCol="0" anchor="ctr"/>
           <a:lstStyle/>
           <a:p>
-            <a:pPr indent="0" marL="0">
+            <a:pPr marL="0" indent="0">
               <a:buNone/>
             </a:pPr>
             <a:r>
@@ -8387,7 +8167,7 @@
           <a:bodyPr wrap="square" lIns="0" tIns="0" rIns="0" bIns="0" rtlCol="0" anchor="ctr"/>
           <a:lstStyle/>
           <a:p>
-            <a:pPr indent="0" marL="0">
+            <a:pPr marL="0" indent="0">
               <a:buNone/>
             </a:pPr>
             <a:r>
@@ -8426,7 +8206,7 @@
           <a:bodyPr wrap="square" lIns="0" tIns="0" rIns="0" bIns="0" rtlCol="0" anchor="ctr"/>
           <a:lstStyle/>
           <a:p>
-            <a:pPr indent="0" marL="0">
+            <a:pPr marL="0" indent="0">
               <a:buNone/>
             </a:pPr>
             <a:r>
@@ -8465,7 +8245,7 @@
           <a:bodyPr wrap="square" lIns="0" tIns="0" rIns="0" bIns="0" rtlCol="0" anchor="ctr"/>
           <a:lstStyle/>
           <a:p>
-            <a:pPr indent="0" marL="0">
+            <a:pPr marL="0" indent="0">
               <a:buNone/>
             </a:pPr>
             <a:r>
@@ -8605,6 +8385,7 @@
         <a:solidFill>
           <a:srgbClr val="FFFFFF"/>
         </a:solidFill>
+        <a:effectLst/>
       </p:bgPr>
     </p:bg>
     <p:spTree>
@@ -8642,7 +8423,7 @@
           <a:bodyPr wrap="square" lIns="0" tIns="0" rIns="0" bIns="0" rtlCol="0" anchor="ctr"/>
           <a:lstStyle/>
           <a:p>
-            <a:pPr indent="0" marL="0">
+            <a:pPr marL="0" indent="0">
               <a:buNone/>
             </a:pPr>
             <a:r>
@@ -8714,14 +8495,14 @@
       </p:sp>
       <p:pic>
         <p:nvPicPr>
-          <p:cNvPr id="5" name="Image 0" descr="preencoded.png">    </p:cNvPr>
+          <p:cNvPr id="5" name="Image 0" descr="preencoded.png"/>
           <p:cNvPicPr>
             <a:picLocks noChangeAspect="1"/>
           </p:cNvPicPr>
           <p:nvPr/>
         </p:nvPicPr>
         <p:blipFill>
-          <a:blip r:embed="rId1"/>
+          <a:blip r:embed="rId3"/>
           <a:stretch>
             <a:fillRect/>
           </a:stretch>
@@ -8757,7 +8538,7 @@
           <a:bodyPr wrap="square" lIns="0" tIns="0" rIns="0" bIns="0" rtlCol="0" anchor="ctr"/>
           <a:lstStyle/>
           <a:p>
-            <a:pPr indent="0" marL="0">
+            <a:pPr marL="0" indent="0">
               <a:buNone/>
             </a:pPr>
             <a:r>
@@ -8796,7 +8577,7 @@
           <a:bodyPr wrap="square" lIns="0" tIns="0" rIns="0" bIns="0" rtlCol="0" anchor="ctr"/>
           <a:lstStyle/>
           <a:p>
-            <a:pPr indent="0" marL="0">
+            <a:pPr marL="0" indent="0">
               <a:buNone/>
             </a:pPr>
             <a:r>
@@ -8868,14 +8649,14 @@
       </p:sp>
       <p:pic>
         <p:nvPicPr>
-          <p:cNvPr id="10" name="Image 1" descr="preencoded.png">    </p:cNvPr>
+          <p:cNvPr id="10" name="Image 1" descr="preencoded.png"/>
           <p:cNvPicPr>
             <a:picLocks noChangeAspect="1"/>
           </p:cNvPicPr>
           <p:nvPr/>
         </p:nvPicPr>
         <p:blipFill>
-          <a:blip r:embed="rId2"/>
+          <a:blip r:embed="rId4"/>
           <a:stretch>
             <a:fillRect/>
           </a:stretch>
@@ -8911,7 +8692,7 @@
           <a:bodyPr wrap="square" lIns="0" tIns="0" rIns="0" bIns="0" rtlCol="0" anchor="ctr"/>
           <a:lstStyle/>
           <a:p>
-            <a:pPr indent="0" marL="0">
+            <a:pPr marL="0" indent="0">
               <a:buNone/>
             </a:pPr>
             <a:r>
@@ -8950,7 +8731,7 @@
           <a:bodyPr wrap="square" lIns="0" tIns="0" rIns="0" bIns="0" rtlCol="0" anchor="ctr"/>
           <a:lstStyle/>
           <a:p>
-            <a:pPr indent="0" marL="0">
+            <a:pPr marL="0" indent="0">
               <a:buNone/>
             </a:pPr>
             <a:r>
@@ -9022,14 +8803,14 @@
       </p:sp>
       <p:pic>
         <p:nvPicPr>
-          <p:cNvPr id="15" name="Image 2" descr="preencoded.png">    </p:cNvPr>
+          <p:cNvPr id="15" name="Image 2" descr="preencoded.png"/>
           <p:cNvPicPr>
             <a:picLocks noChangeAspect="1"/>
           </p:cNvPicPr>
           <p:nvPr/>
         </p:nvPicPr>
         <p:blipFill>
-          <a:blip r:embed="rId3"/>
+          <a:blip r:embed="rId5"/>
           <a:stretch>
             <a:fillRect/>
           </a:stretch>
@@ -9065,7 +8846,7 @@
           <a:bodyPr wrap="square" lIns="0" tIns="0" rIns="0" bIns="0" rtlCol="0" anchor="ctr"/>
           <a:lstStyle/>
           <a:p>
-            <a:pPr indent="0" marL="0">
+            <a:pPr marL="0" indent="0">
               <a:buNone/>
             </a:pPr>
             <a:r>
@@ -9104,7 +8885,7 @@
           <a:bodyPr wrap="square" lIns="0" tIns="0" rIns="0" bIns="0" rtlCol="0" anchor="ctr"/>
           <a:lstStyle/>
           <a:p>
-            <a:pPr indent="0" marL="0">
+            <a:pPr marL="0" indent="0">
               <a:buNone/>
             </a:pPr>
             <a:r>
@@ -9176,14 +8957,14 @@
       </p:sp>
       <p:pic>
         <p:nvPicPr>
-          <p:cNvPr id="20" name="Image 3" descr="preencoded.png">    </p:cNvPr>
+          <p:cNvPr id="20" name="Image 3" descr="preencoded.png"/>
           <p:cNvPicPr>
             <a:picLocks noChangeAspect="1"/>
           </p:cNvPicPr>
           <p:nvPr/>
         </p:nvPicPr>
         <p:blipFill>
-          <a:blip r:embed="rId4"/>
+          <a:blip r:embed="rId6"/>
           <a:stretch>
             <a:fillRect/>
           </a:stretch>
@@ -9219,7 +9000,7 @@
           <a:bodyPr wrap="square" lIns="0" tIns="0" rIns="0" bIns="0" rtlCol="0" anchor="ctr"/>
           <a:lstStyle/>
           <a:p>
-            <a:pPr indent="0" marL="0">
+            <a:pPr marL="0" indent="0">
               <a:buNone/>
             </a:pPr>
             <a:r>
@@ -9258,7 +9039,7 @@
           <a:bodyPr wrap="square" lIns="0" tIns="0" rIns="0" bIns="0" rtlCol="0" anchor="ctr"/>
           <a:lstStyle/>
           <a:p>
-            <a:pPr indent="0" marL="0">
+            <a:pPr marL="0" indent="0">
               <a:buNone/>
             </a:pPr>
             <a:r>
@@ -9292,6 +9073,7 @@
         <a:solidFill>
           <a:srgbClr val="0B3C49"/>
         </a:solidFill>
+        <a:effectLst/>
       </p:bgPr>
     </p:bg>
     <p:spTree>
@@ -9329,7 +9111,7 @@
           <a:bodyPr wrap="square" lIns="0" tIns="0" rIns="0" bIns="0" rtlCol="0" anchor="ctr"/>
           <a:lstStyle/>
           <a:p>
-            <a:pPr indent="0" marL="0">
+            <a:pPr marL="0" indent="0">
               <a:buNone/>
             </a:pPr>
             <a:r>
@@ -9374,14 +9156,14 @@
       </p:sp>
       <p:pic>
         <p:nvPicPr>
-          <p:cNvPr id="4" name="Image 0" descr="preencoded.png">    </p:cNvPr>
+          <p:cNvPr id="4" name="Image 0" descr="preencoded.png"/>
           <p:cNvPicPr>
             <a:picLocks noChangeAspect="1"/>
           </p:cNvPicPr>
           <p:nvPr/>
         </p:nvPicPr>
         <p:blipFill>
-          <a:blip r:embed="rId1"/>
+          <a:blip r:embed="rId3"/>
           <a:stretch>
             <a:fillRect/>
           </a:stretch>
@@ -9417,7 +9199,7 @@
           <a:bodyPr wrap="square" lIns="0" tIns="0" rIns="0" bIns="0" rtlCol="0" anchor="ctr"/>
           <a:lstStyle/>
           <a:p>
-            <a:pPr algn="ctr" indent="0" marL="0">
+            <a:pPr marL="0" indent="0" algn="ctr">
               <a:buNone/>
             </a:pPr>
             <a:r>
@@ -9462,14 +9244,14 @@
       </p:sp>
       <p:pic>
         <p:nvPicPr>
-          <p:cNvPr id="7" name="Image 1" descr="preencoded.png">    </p:cNvPr>
+          <p:cNvPr id="7" name="Image 1" descr="preencoded.png"/>
           <p:cNvPicPr>
             <a:picLocks noChangeAspect="1"/>
           </p:cNvPicPr>
           <p:nvPr/>
         </p:nvPicPr>
         <p:blipFill>
-          <a:blip r:embed="rId2"/>
+          <a:blip r:embed="rId4"/>
           <a:stretch>
             <a:fillRect/>
           </a:stretch>
@@ -9505,7 +9287,7 @@
           <a:bodyPr wrap="square" lIns="0" tIns="0" rIns="0" bIns="0" rtlCol="0" anchor="ctr"/>
           <a:lstStyle/>
           <a:p>
-            <a:pPr algn="ctr" indent="0" marL="0">
+            <a:pPr marL="0" indent="0" algn="ctr">
               <a:buNone/>
             </a:pPr>
             <a:r>
@@ -9550,14 +9332,14 @@
       </p:sp>
       <p:pic>
         <p:nvPicPr>
-          <p:cNvPr id="10" name="Image 2" descr="preencoded.png">    </p:cNvPr>
+          <p:cNvPr id="10" name="Image 2" descr="preencoded.png"/>
           <p:cNvPicPr>
             <a:picLocks noChangeAspect="1"/>
           </p:cNvPicPr>
           <p:nvPr/>
         </p:nvPicPr>
         <p:blipFill>
-          <a:blip r:embed="rId3"/>
+          <a:blip r:embed="rId5"/>
           <a:stretch>
             <a:fillRect/>
           </a:stretch>
@@ -9593,7 +9375,7 @@
           <a:bodyPr wrap="square" lIns="0" tIns="0" rIns="0" bIns="0" rtlCol="0" anchor="ctr"/>
           <a:lstStyle/>
           <a:p>
-            <a:pPr algn="ctr" indent="0" marL="0">
+            <a:pPr marL="0" indent="0" algn="ctr">
               <a:buNone/>
             </a:pPr>
             <a:r>
@@ -9638,14 +9420,14 @@
       </p:sp>
       <p:pic>
         <p:nvPicPr>
-          <p:cNvPr id="13" name="Image 3" descr="preencoded.png">    </p:cNvPr>
+          <p:cNvPr id="13" name="Image 3" descr="preencoded.png"/>
           <p:cNvPicPr>
             <a:picLocks noChangeAspect="1"/>
           </p:cNvPicPr>
           <p:nvPr/>
         </p:nvPicPr>
         <p:blipFill>
-          <a:blip r:embed="rId4"/>
+          <a:blip r:embed="rId6"/>
           <a:stretch>
             <a:fillRect/>
           </a:stretch>
@@ -9681,7 +9463,7 @@
           <a:bodyPr wrap="square" lIns="0" tIns="0" rIns="0" bIns="0" rtlCol="0" anchor="ctr"/>
           <a:lstStyle/>
           <a:p>
-            <a:pPr algn="ctr" indent="0" marL="0">
+            <a:pPr marL="0" indent="0" algn="ctr">
               <a:buNone/>
             </a:pPr>
             <a:r>
@@ -9726,14 +9508,14 @@
       </p:sp>
       <p:pic>
         <p:nvPicPr>
-          <p:cNvPr id="16" name="Image 4" descr="preencoded.png">    </p:cNvPr>
+          <p:cNvPr id="16" name="Image 4" descr="preencoded.png"/>
           <p:cNvPicPr>
             <a:picLocks noChangeAspect="1"/>
           </p:cNvPicPr>
           <p:nvPr/>
         </p:nvPicPr>
         <p:blipFill>
-          <a:blip r:embed="rId5"/>
+          <a:blip r:embed="rId7"/>
           <a:stretch>
             <a:fillRect/>
           </a:stretch>
@@ -9769,7 +9551,7 @@
           <a:bodyPr wrap="square" lIns="0" tIns="0" rIns="0" bIns="0" rtlCol="0" anchor="ctr"/>
           <a:lstStyle/>
           <a:p>
-            <a:pPr algn="ctr" indent="0" marL="0">
+            <a:pPr marL="0" indent="0" algn="ctr">
               <a:buNone/>
             </a:pPr>
             <a:r>
@@ -9814,14 +9596,14 @@
       </p:sp>
       <p:pic>
         <p:nvPicPr>
-          <p:cNvPr id="19" name="Image 5" descr="preencoded.png">    </p:cNvPr>
+          <p:cNvPr id="19" name="Image 5" descr="preencoded.png"/>
           <p:cNvPicPr>
             <a:picLocks noChangeAspect="1"/>
           </p:cNvPicPr>
           <p:nvPr/>
         </p:nvPicPr>
         <p:blipFill>
-          <a:blip r:embed="rId6"/>
+          <a:blip r:embed="rId8"/>
           <a:stretch>
             <a:fillRect/>
           </a:stretch>
@@ -9857,7 +9639,7 @@
           <a:bodyPr wrap="square" lIns="0" tIns="0" rIns="0" bIns="0" rtlCol="0" anchor="ctr"/>
           <a:lstStyle/>
           <a:p>
-            <a:pPr algn="ctr" indent="0" marL="0">
+            <a:pPr marL="0" indent="0" algn="ctr">
               <a:buNone/>
             </a:pPr>
             <a:r>
@@ -9902,14 +9684,14 @@
       </p:sp>
       <p:pic>
         <p:nvPicPr>
-          <p:cNvPr id="22" name="Image 6" descr="preencoded.png">    </p:cNvPr>
+          <p:cNvPr id="22" name="Image 6" descr="preencoded.png"/>
           <p:cNvPicPr>
             <a:picLocks noChangeAspect="1"/>
           </p:cNvPicPr>
           <p:nvPr/>
         </p:nvPicPr>
         <p:blipFill>
-          <a:blip r:embed="rId7"/>
+          <a:blip r:embed="rId9"/>
           <a:stretch>
             <a:fillRect/>
           </a:stretch>
@@ -9945,7 +9727,7 @@
           <a:bodyPr wrap="square" lIns="0" tIns="0" rIns="0" bIns="0" rtlCol="0" anchor="ctr"/>
           <a:lstStyle/>
           <a:p>
-            <a:pPr algn="ctr" indent="0" marL="0">
+            <a:pPr marL="0" indent="0" algn="ctr">
               <a:buNone/>
             </a:pPr>
             <a:r>
@@ -9990,14 +9772,14 @@
       </p:sp>
       <p:pic>
         <p:nvPicPr>
-          <p:cNvPr id="25" name="Image 7" descr="preencoded.png">    </p:cNvPr>
+          <p:cNvPr id="25" name="Image 7" descr="preencoded.png"/>
           <p:cNvPicPr>
             <a:picLocks noChangeAspect="1"/>
           </p:cNvPicPr>
           <p:nvPr/>
         </p:nvPicPr>
         <p:blipFill>
-          <a:blip r:embed="rId8"/>
+          <a:blip r:embed="rId10"/>
           <a:stretch>
             <a:fillRect/>
           </a:stretch>
@@ -10033,7 +9815,7 @@
           <a:bodyPr wrap="square" lIns="0" tIns="0" rIns="0" bIns="0" rtlCol="0" anchor="ctr"/>
           <a:lstStyle/>
           <a:p>
-            <a:pPr algn="ctr" indent="0" marL="0">
+            <a:pPr marL="0" indent="0" algn="ctr">
               <a:buNone/>
             </a:pPr>
             <a:r>
@@ -10067,6 +9849,7 @@
         <a:solidFill>
           <a:srgbClr val="FFFFFF"/>
         </a:solidFill>
+        <a:effectLst/>
       </p:bgPr>
     </p:bg>
     <p:spTree>
@@ -10104,7 +9887,7 @@
           <a:bodyPr wrap="square" lIns="0" tIns="0" rIns="0" bIns="0" rtlCol="0" anchor="ctr"/>
           <a:lstStyle/>
           <a:p>
-            <a:pPr indent="0" marL="0">
+            <a:pPr marL="0" indent="0">
               <a:buNone/>
             </a:pPr>
             <a:r>
@@ -10168,7 +9951,7 @@
           <a:bodyPr wrap="square" lIns="0" tIns="0" rIns="0" bIns="0" rtlCol="0" anchor="ctr"/>
           <a:lstStyle/>
           <a:p>
-            <a:pPr algn="ctr" indent="0" marL="0">
+            <a:pPr marL="0" indent="0" algn="ctr">
               <a:buNone/>
             </a:pPr>
             <a:r>
@@ -10207,7 +9990,7 @@
           <a:bodyPr wrap="square" lIns="0" tIns="0" rIns="0" bIns="0" rtlCol="0" anchor="ctr"/>
           <a:lstStyle/>
           <a:p>
-            <a:pPr algn="ctr" indent="0" marL="0">
+            <a:pPr marL="0" indent="0" algn="ctr">
               <a:buNone/>
             </a:pPr>
             <a:r>
@@ -10246,7 +10029,7 @@
           <a:bodyPr wrap="square" lIns="0" tIns="0" rIns="0" bIns="0" rtlCol="0" anchor="ctr"/>
           <a:lstStyle/>
           <a:p>
-            <a:pPr algn="ctr" indent="0" marL="0">
+            <a:pPr marL="0" indent="0" algn="ctr">
               <a:buNone/>
             </a:pPr>
             <a:r>
@@ -10310,7 +10093,7 @@
           <a:bodyPr wrap="square" lIns="0" tIns="0" rIns="0" bIns="0" rtlCol="0" anchor="ctr"/>
           <a:lstStyle/>
           <a:p>
-            <a:pPr algn="ctr" indent="0" marL="0">
+            <a:pPr marL="0" indent="0" algn="ctr">
               <a:buNone/>
             </a:pPr>
             <a:r>
@@ -10349,7 +10132,7 @@
           <a:bodyPr wrap="square" lIns="0" tIns="0" rIns="0" bIns="0" rtlCol="0" anchor="ctr"/>
           <a:lstStyle/>
           <a:p>
-            <a:pPr algn="ctr" indent="0" marL="0">
+            <a:pPr marL="0" indent="0" algn="ctr">
               <a:buNone/>
             </a:pPr>
             <a:r>
@@ -10388,7 +10171,7 @@
           <a:bodyPr wrap="square" lIns="0" tIns="0" rIns="0" bIns="0" rtlCol="0" anchor="ctr"/>
           <a:lstStyle/>
           <a:p>
-            <a:pPr algn="ctr" indent="0" marL="0">
+            <a:pPr marL="0" indent="0" algn="ctr">
               <a:buNone/>
             </a:pPr>
             <a:r>
@@ -10452,7 +10235,7 @@
           <a:bodyPr wrap="square" lIns="0" tIns="0" rIns="0" bIns="0" rtlCol="0" anchor="ctr"/>
           <a:lstStyle/>
           <a:p>
-            <a:pPr algn="ctr" indent="0" marL="0">
+            <a:pPr marL="0" indent="0" algn="ctr">
               <a:buNone/>
             </a:pPr>
             <a:r>
@@ -10491,7 +10274,7 @@
           <a:bodyPr wrap="square" lIns="0" tIns="0" rIns="0" bIns="0" rtlCol="0" anchor="ctr"/>
           <a:lstStyle/>
           <a:p>
-            <a:pPr algn="ctr" indent="0" marL="0">
+            <a:pPr marL="0" indent="0" algn="ctr">
               <a:buNone/>
             </a:pPr>
             <a:r>
@@ -10530,7 +10313,7 @@
           <a:bodyPr wrap="square" lIns="0" tIns="0" rIns="0" bIns="0" rtlCol="0" anchor="ctr"/>
           <a:lstStyle/>
           <a:p>
-            <a:pPr algn="ctr" indent="0" marL="0">
+            <a:pPr marL="0" indent="0" algn="ctr">
               <a:buNone/>
             </a:pPr>
             <a:r>
@@ -10594,7 +10377,7 @@
           <a:bodyPr wrap="square" lIns="0" tIns="0" rIns="0" bIns="0" rtlCol="0" anchor="ctr"/>
           <a:lstStyle/>
           <a:p>
-            <a:pPr algn="ctr" indent="0" marL="0">
+            <a:pPr marL="0" indent="0" algn="ctr">
               <a:buNone/>
             </a:pPr>
             <a:r>
@@ -10633,7 +10416,7 @@
           <a:bodyPr wrap="square" lIns="0" tIns="0" rIns="0" bIns="0" rtlCol="0" anchor="ctr"/>
           <a:lstStyle/>
           <a:p>
-            <a:pPr algn="ctr" indent="0" marL="0">
+            <a:pPr marL="0" indent="0" algn="ctr">
               <a:buNone/>
             </a:pPr>
             <a:r>
@@ -10672,7 +10455,7 @@
           <a:bodyPr wrap="square" lIns="0" tIns="0" rIns="0" bIns="0" rtlCol="0" anchor="ctr"/>
           <a:lstStyle/>
           <a:p>
-            <a:pPr algn="ctr" indent="0" marL="0">
+            <a:pPr marL="0" indent="0" algn="ctr">
               <a:buNone/>
             </a:pPr>
             <a:r>
@@ -10736,7 +10519,7 @@
           <a:bodyPr wrap="square" lIns="0" tIns="0" rIns="0" bIns="0" rtlCol="0" anchor="ctr"/>
           <a:lstStyle/>
           <a:p>
-            <a:pPr algn="ctr" indent="0" marL="0">
+            <a:pPr marL="0" indent="0" algn="ctr">
               <a:buNone/>
             </a:pPr>
             <a:r>
@@ -10775,7 +10558,7 @@
           <a:bodyPr wrap="square" lIns="0" tIns="0" rIns="0" bIns="0" rtlCol="0" anchor="ctr"/>
           <a:lstStyle/>
           <a:p>
-            <a:pPr algn="ctr" indent="0" marL="0">
+            <a:pPr marL="0" indent="0" algn="ctr">
               <a:buNone/>
             </a:pPr>
             <a:r>
@@ -10814,7 +10597,7 @@
           <a:bodyPr wrap="square" lIns="0" tIns="0" rIns="0" bIns="0" rtlCol="0" anchor="ctr"/>
           <a:lstStyle/>
           <a:p>
-            <a:pPr algn="ctr" indent="0" marL="0">
+            <a:pPr marL="0" indent="0" algn="ctr">
               <a:buNone/>
             </a:pPr>
             <a:r>
@@ -10848,6 +10631,7 @@
         <a:solidFill>
           <a:srgbClr val="FFFFFF"/>
         </a:solidFill>
+        <a:effectLst/>
       </p:bgPr>
     </p:bg>
     <p:spTree>
@@ -10885,7 +10669,7 @@
           <a:bodyPr wrap="square" lIns="0" tIns="0" rIns="0" bIns="0" rtlCol="0" anchor="ctr"/>
           <a:lstStyle/>
           <a:p>
-            <a:pPr indent="0" marL="0">
+            <a:pPr marL="0" indent="0">
               <a:buNone/>
             </a:pPr>
             <a:r>
@@ -10930,15 +10714,15 @@
       </p:sp>
       <p:pic>
         <p:nvPicPr>
-          <p:cNvPr id="4" name="Image 0" descr="screenshots/dashboard.png">    </p:cNvPr>
+          <p:cNvPr id="4" name="Image 0" descr="screenshots/dashboard.png"/>
           <p:cNvPicPr>
             <a:picLocks noChangeAspect="1"/>
           </p:cNvPicPr>
           <p:nvPr/>
         </p:nvPicPr>
         <p:blipFill>
-          <a:blip r:embed="rId1"/>
-          <a:srcRect l="0" r="0" t="0" b="0"/>
+          <a:blip r:embed="rId3"/>
+          <a:srcRect/>
           <a:stretch/>
         </p:blipFill>
         <p:spPr>
@@ -10972,7 +10756,7 @@
           <a:bodyPr wrap="square" lIns="0" tIns="0" rIns="0" bIns="0" rtlCol="0" anchor="ctr"/>
           <a:lstStyle/>
           <a:p>
-            <a:pPr algn="ctr" indent="0" marL="0">
+            <a:pPr marL="0" indent="0" algn="ctr">
               <a:buNone/>
             </a:pPr>
             <a:r>
@@ -11017,15 +10801,15 @@
       </p:sp>
       <p:pic>
         <p:nvPicPr>
-          <p:cNvPr id="7" name="Image 1" descr="screenshots/list.png">    </p:cNvPr>
+          <p:cNvPr id="7" name="Image 1" descr="screenshots/list.png"/>
           <p:cNvPicPr>
             <a:picLocks noChangeAspect="1"/>
           </p:cNvPicPr>
           <p:nvPr/>
         </p:nvPicPr>
         <p:blipFill>
-          <a:blip r:embed="rId2"/>
-          <a:srcRect l="0" r="0" t="0" b="0"/>
+          <a:blip r:embed="rId4"/>
+          <a:srcRect/>
           <a:stretch/>
         </p:blipFill>
         <p:spPr>
@@ -11059,7 +10843,7 @@
           <a:bodyPr wrap="square" lIns="0" tIns="0" rIns="0" bIns="0" rtlCol="0" anchor="ctr"/>
           <a:lstStyle/>
           <a:p>
-            <a:pPr algn="ctr" indent="0" marL="0">
+            <a:pPr marL="0" indent="0" algn="ctr">
               <a:buNone/>
             </a:pPr>
             <a:r>
@@ -11104,15 +10888,15 @@
       </p:sp>
       <p:pic>
         <p:nvPicPr>
-          <p:cNvPr id="10" name="Image 2" descr="screenshots/detail.png">    </p:cNvPr>
+          <p:cNvPr id="10" name="Image 2" descr="screenshots/detail.png"/>
           <p:cNvPicPr>
             <a:picLocks noChangeAspect="1"/>
           </p:cNvPicPr>
           <p:nvPr/>
         </p:nvPicPr>
         <p:blipFill>
-          <a:blip r:embed="rId3"/>
-          <a:srcRect l="0" r="0" t="0" b="0"/>
+          <a:blip r:embed="rId5"/>
+          <a:srcRect/>
           <a:stretch/>
         </p:blipFill>
         <p:spPr>
@@ -11146,7 +10930,7 @@
           <a:bodyPr wrap="square" lIns="0" tIns="0" rIns="0" bIns="0" rtlCol="0" anchor="ctr"/>
           <a:lstStyle/>
           <a:p>
-            <a:pPr algn="ctr" indent="0" marL="0">
+            <a:pPr marL="0" indent="0" algn="ctr">
               <a:buNone/>
             </a:pPr>
             <a:r>
@@ -11191,15 +10975,15 @@
       </p:sp>
       <p:pic>
         <p:nvPicPr>
-          <p:cNvPr id="13" name="Image 3" descr="screenshots/form.png">    </p:cNvPr>
+          <p:cNvPr id="13" name="Image 3" descr="screenshots/form.png"/>
           <p:cNvPicPr>
             <a:picLocks noChangeAspect="1"/>
           </p:cNvPicPr>
           <p:nvPr/>
         </p:nvPicPr>
         <p:blipFill>
-          <a:blip r:embed="rId4"/>
-          <a:srcRect l="0" r="0" t="0" b="0"/>
+          <a:blip r:embed="rId6"/>
+          <a:srcRect/>
           <a:stretch/>
         </p:blipFill>
         <p:spPr>
@@ -11233,7 +11017,7 @@
           <a:bodyPr wrap="square" lIns="0" tIns="0" rIns="0" bIns="0" rtlCol="0" anchor="ctr"/>
           <a:lstStyle/>
           <a:p>
-            <a:pPr algn="ctr" indent="0" marL="0">
+            <a:pPr marL="0" indent="0" algn="ctr">
               <a:buNone/>
             </a:pPr>
             <a:r>
@@ -11267,6 +11051,7 @@
         <a:solidFill>
           <a:srgbClr val="FFFFFF"/>
         </a:solidFill>
+        <a:effectLst/>
       </p:bgPr>
     </p:bg>
     <p:spTree>
@@ -11304,7 +11089,7 @@
           <a:bodyPr wrap="square" lIns="0" tIns="0" rIns="0" bIns="0" rtlCol="0" anchor="ctr"/>
           <a:lstStyle/>
           <a:p>
-            <a:pPr indent="0" marL="0">
+            <a:pPr marL="0" indent="0">
               <a:buNone/>
             </a:pPr>
             <a:r>
@@ -11343,7 +11128,7 @@
           <a:bodyPr wrap="square" lIns="0" tIns="0" rIns="0" bIns="0" rtlCol="0" anchor="ctr"/>
           <a:lstStyle/>
           <a:p>
-            <a:pPr indent="0" marL="0">
+            <a:pPr marL="0" indent="0">
               <a:buNone/>
             </a:pPr>
             <a:r>
@@ -11405,7 +11190,7 @@
           <a:bodyPr wrap="square" lIns="0" tIns="0" rIns="0" bIns="0" rtlCol="0" anchor="ctr"/>
           <a:lstStyle/>
           <a:p>
-            <a:pPr algn="r" indent="0" marL="0">
+            <a:pPr marL="0" indent="0" algn="r">
               <a:buNone/>
             </a:pPr>
             <a:r>
@@ -11469,7 +11254,7 @@
           <a:bodyPr wrap="square" lIns="0" tIns="0" rIns="0" bIns="0" rtlCol="0" anchor="ctr"/>
           <a:lstStyle/>
           <a:p>
-            <a:pPr indent="0" marL="0">
+            <a:pPr marL="0" indent="0">
               <a:buNone/>
             </a:pPr>
             <a:r>
@@ -11483,9 +11268,6 @@
               </a:rPr>
               <a:t>Jihoz qo'shildi  </a:t>
             </a:r>
-            <a:pPr indent="0" marL="0">
-              <a:buNone/>
-            </a:pPr>
             <a:r>
               <a:rPr lang="en-US" sz="1600" dirty="0">
                 <a:solidFill>
@@ -11522,7 +11304,7 @@
           <a:bodyPr wrap="square" lIns="0" tIns="0" rIns="0" bIns="0" rtlCol="0" anchor="ctr"/>
           <a:lstStyle/>
           <a:p>
-            <a:pPr algn="r" indent="0" marL="0">
+            <a:pPr marL="0" indent="0" algn="r">
               <a:buNone/>
             </a:pPr>
             <a:r>
@@ -11586,7 +11368,7 @@
           <a:bodyPr wrap="square" lIns="0" tIns="0" rIns="0" bIns="0" rtlCol="0" anchor="ctr"/>
           <a:lstStyle/>
           <a:p>
-            <a:pPr indent="0" marL="0">
+            <a:pPr marL="0" indent="0">
               <a:buNone/>
             </a:pPr>
             <a:r>
@@ -11600,9 +11382,6 @@
               </a:rPr>
               <a:t>Ko'chirildi  </a:t>
             </a:r>
-            <a:pPr indent="0" marL="0">
-              <a:buNone/>
-            </a:pPr>
             <a:r>
               <a:rPr lang="en-US" sz="1600" dirty="0">
                 <a:solidFill>
@@ -11639,7 +11418,7 @@
           <a:bodyPr wrap="square" lIns="0" tIns="0" rIns="0" bIns="0" rtlCol="0" anchor="ctr"/>
           <a:lstStyle/>
           <a:p>
-            <a:pPr algn="r" indent="0" marL="0">
+            <a:pPr marL="0" indent="0" algn="r">
               <a:buNone/>
             </a:pPr>
             <a:r>
@@ -11703,7 +11482,7 @@
           <a:bodyPr wrap="square" lIns="0" tIns="0" rIns="0" bIns="0" rtlCol="0" anchor="ctr"/>
           <a:lstStyle/>
           <a:p>
-            <a:pPr indent="0" marL="0">
+            <a:pPr marL="0" indent="0">
               <a:buNone/>
             </a:pPr>
             <a:r>
@@ -11717,9 +11496,6 @@
               </a:rPr>
               <a:t>Mas'ul o'zgardi  </a:t>
             </a:r>
-            <a:pPr indent="0" marL="0">
-              <a:buNone/>
-            </a:pPr>
             <a:r>
               <a:rPr lang="en-US" sz="1600" dirty="0">
                 <a:solidFill>
@@ -11756,7 +11532,7 @@
           <a:bodyPr wrap="square" lIns="0" tIns="0" rIns="0" bIns="0" rtlCol="0" anchor="ctr"/>
           <a:lstStyle/>
           <a:p>
-            <a:pPr algn="r" indent="0" marL="0">
+            <a:pPr marL="0" indent="0" algn="r">
               <a:buNone/>
             </a:pPr>
             <a:r>
@@ -11820,7 +11596,7 @@
           <a:bodyPr wrap="square" lIns="0" tIns="0" rIns="0" bIns="0" rtlCol="0" anchor="ctr"/>
           <a:lstStyle/>
           <a:p>
-            <a:pPr indent="0" marL="0">
+            <a:pPr marL="0" indent="0">
               <a:buNone/>
             </a:pPr>
             <a:r>
@@ -11834,9 +11610,6 @@
               </a:rPr>
               <a:t>Ta'mirga yuborildi  </a:t>
             </a:r>
-            <a:pPr indent="0" marL="0">
-              <a:buNone/>
-            </a:pPr>
             <a:r>
               <a:rPr lang="en-US" sz="1600" dirty="0">
                 <a:solidFill>
@@ -11873,7 +11646,7 @@
           <a:bodyPr wrap="square" lIns="0" tIns="0" rIns="0" bIns="0" rtlCol="0" anchor="ctr"/>
           <a:lstStyle/>
           <a:p>
-            <a:pPr algn="r" indent="0" marL="0">
+            <a:pPr marL="0" indent="0" algn="r">
               <a:buNone/>
             </a:pPr>
             <a:r>
@@ -11937,7 +11710,7 @@
           <a:bodyPr wrap="square" lIns="0" tIns="0" rIns="0" bIns="0" rtlCol="0" anchor="ctr"/>
           <a:lstStyle/>
           <a:p>
-            <a:pPr indent="0" marL="0">
+            <a:pPr marL="0" indent="0">
               <a:buNone/>
             </a:pPr>
             <a:r>
@@ -11951,9 +11724,6 @@
               </a:rPr>
               <a:t>Ta'mirdan qaytdi  </a:t>
             </a:r>
-            <a:pPr indent="0" marL="0">
-              <a:buNone/>
-            </a:pPr>
             <a:r>
               <a:rPr lang="en-US" sz="1600" dirty="0">
                 <a:solidFill>
@@ -11985,6 +11755,7 @@
         <a:solidFill>
           <a:srgbClr val="0B3C49"/>
         </a:solidFill>
+        <a:effectLst/>
       </p:bgPr>
     </p:bg>
     <p:spTree>
@@ -12022,7 +11793,7 @@
           <a:bodyPr wrap="square" lIns="0" tIns="0" rIns="0" bIns="0" rtlCol="0" anchor="ctr"/>
           <a:lstStyle/>
           <a:p>
-            <a:pPr indent="0" marL="0">
+            <a:pPr marL="0" indent="0">
               <a:buNone/>
             </a:pPr>
             <a:r>
@@ -12115,7 +11886,7 @@
           <a:bodyPr wrap="square" lIns="0" tIns="0" rIns="0" bIns="0" rtlCol="0" anchor="ctr"/>
           <a:lstStyle/>
           <a:p>
-            <a:pPr indent="0" marL="0">
+            <a:pPr marL="0" indent="0">
               <a:buNone/>
             </a:pPr>
             <a:r>
@@ -12181,7 +11952,7 @@
           <a:bodyPr wrap="square" lIns="0" tIns="0" rIns="0" bIns="0" rtlCol="0" anchor="ctr"/>
           <a:lstStyle/>
           <a:p>
-            <a:pPr indent="0" marL="0">
+            <a:pPr marL="0" indent="0">
               <a:buNone/>
             </a:pPr>
             <a:r>
@@ -12220,7 +11991,7 @@
           <a:bodyPr wrap="square" lIns="0" tIns="0" rIns="0" bIns="0" rtlCol="0" anchor="ctr"/>
           <a:lstStyle/>
           <a:p>
-            <a:pPr indent="0" marL="0">
+            <a:pPr marL="0" indent="0">
               <a:buNone/>
             </a:pPr>
             <a:r>
@@ -12265,14 +12036,14 @@
       </p:sp>
       <p:pic>
         <p:nvPicPr>
-          <p:cNvPr id="10" name="Image 0" descr="preencoded.png">    </p:cNvPr>
+          <p:cNvPr id="10" name="Image 0" descr="preencoded.png"/>
           <p:cNvPicPr>
             <a:picLocks noChangeAspect="1"/>
           </p:cNvPicPr>
           <p:nvPr/>
         </p:nvPicPr>
         <p:blipFill>
-          <a:blip r:embed="rId1"/>
+          <a:blip r:embed="rId3"/>
           <a:stretch>
             <a:fillRect/>
           </a:stretch>
@@ -12308,7 +12079,7 @@
           <a:bodyPr wrap="square" lIns="0" tIns="0" rIns="0" bIns="0" rtlCol="0" anchor="ctr"/>
           <a:lstStyle/>
           <a:p>
-            <a:pPr indent="0" marL="0">
+            <a:pPr marL="0" indent="0">
               <a:buNone/>
             </a:pPr>
             <a:r>
@@ -12353,14 +12124,14 @@
       </p:sp>
       <p:pic>
         <p:nvPicPr>
-          <p:cNvPr id="13" name="Image 1" descr="preencoded.png">    </p:cNvPr>
+          <p:cNvPr id="13" name="Image 1" descr="preencoded.png"/>
           <p:cNvPicPr>
             <a:picLocks noChangeAspect="1"/>
           </p:cNvPicPr>
           <p:nvPr/>
         </p:nvPicPr>
         <p:blipFill>
-          <a:blip r:embed="rId2"/>
+          <a:blip r:embed="rId4"/>
           <a:stretch>
             <a:fillRect/>
           </a:stretch>
@@ -12396,7 +12167,7 @@
           <a:bodyPr wrap="square" lIns="0" tIns="0" rIns="0" bIns="0" rtlCol="0" anchor="ctr"/>
           <a:lstStyle/>
           <a:p>
-            <a:pPr indent="0" marL="0">
+            <a:pPr marL="0" indent="0">
               <a:buNone/>
             </a:pPr>
             <a:r>
@@ -12441,14 +12212,14 @@
       </p:sp>
       <p:pic>
         <p:nvPicPr>
-          <p:cNvPr id="16" name="Image 2" descr="preencoded.png">    </p:cNvPr>
+          <p:cNvPr id="16" name="Image 2" descr="preencoded.png"/>
           <p:cNvPicPr>
             <a:picLocks noChangeAspect="1"/>
           </p:cNvPicPr>
           <p:nvPr/>
         </p:nvPicPr>
         <p:blipFill>
-          <a:blip r:embed="rId3"/>
+          <a:blip r:embed="rId5"/>
           <a:stretch>
             <a:fillRect/>
           </a:stretch>
@@ -12484,7 +12255,7 @@
           <a:bodyPr wrap="square" lIns="0" tIns="0" rIns="0" bIns="0" rtlCol="0" anchor="ctr"/>
           <a:lstStyle/>
           <a:p>
-            <a:pPr indent="0" marL="0">
+            <a:pPr marL="0" indent="0">
               <a:buNone/>
             </a:pPr>
             <a:r>
@@ -12803,4 +12574,299 @@
     </a:ext>
   </a:extLst>
 </a:theme>
+</file>
+
+<file path=ppt/theme/theme2.xml><?xml version="1.0" encoding="utf-8"?>
+<a:theme xmlns:a="http://schemas.openxmlformats.org/drawingml/2006/main" name="Тема Office">
+  <a:themeElements>
+    <a:clrScheme name="Стандартная">
+      <a:dk1>
+        <a:sysClr val="windowText" lastClr="000000"/>
+      </a:dk1>
+      <a:lt1>
+        <a:sysClr val="window" lastClr="FFFFFF"/>
+      </a:lt1>
+      <a:dk2>
+        <a:srgbClr val="44546A"/>
+      </a:dk2>
+      <a:lt2>
+        <a:srgbClr val="E7E6E6"/>
+      </a:lt2>
+      <a:accent1>
+        <a:srgbClr val="4472C4"/>
+      </a:accent1>
+      <a:accent2>
+        <a:srgbClr val="ED7D31"/>
+      </a:accent2>
+      <a:accent3>
+        <a:srgbClr val="A5A5A5"/>
+      </a:accent3>
+      <a:accent4>
+        <a:srgbClr val="FFC000"/>
+      </a:accent4>
+      <a:accent5>
+        <a:srgbClr val="5B9BD5"/>
+      </a:accent5>
+      <a:accent6>
+        <a:srgbClr val="70AD47"/>
+      </a:accent6>
+      <a:hlink>
+        <a:srgbClr val="0563C1"/>
+      </a:hlink>
+      <a:folHlink>
+        <a:srgbClr val="954F72"/>
+      </a:folHlink>
+    </a:clrScheme>
+    <a:fontScheme name="Стандартная">
+      <a:majorFont>
+        <a:latin typeface="Calibri Light" panose="020F0302020204030204"/>
+        <a:ea typeface=""/>
+        <a:cs typeface=""/>
+        <a:font script="Jpan" typeface="游ゴシック Light"/>
+        <a:font script="Hang" typeface="맑은 고딕"/>
+        <a:font script="Hans" typeface="等线 Light"/>
+        <a:font script="Hant" typeface="新細明體"/>
+        <a:font script="Arab" typeface="Times New Roman"/>
+        <a:font script="Hebr" typeface="Times New Roman"/>
+        <a:font script="Thai" typeface="Angsana New"/>
+        <a:font script="Ethi" typeface="Nyala"/>
+        <a:font script="Beng" typeface="Vrinda"/>
+        <a:font script="Gujr" typeface="Shruti"/>
+        <a:font script="Khmr" typeface="MoolBoran"/>
+        <a:font script="Knda" typeface="Tunga"/>
+        <a:font script="Guru" typeface="Raavi"/>
+        <a:font script="Cans" typeface="Euphemia"/>
+        <a:font script="Cher" typeface="Plantagenet Cherokee"/>
+        <a:font script="Yiii" typeface="Microsoft Yi Baiti"/>
+        <a:font script="Tibt" typeface="Microsoft Himalaya"/>
+        <a:font script="Thaa" typeface="MV Boli"/>
+        <a:font script="Deva" typeface="Mangal"/>
+        <a:font script="Telu" typeface="Gautami"/>
+        <a:font script="Taml" typeface="Latha"/>
+        <a:font script="Syrc" typeface="Estrangelo Edessa"/>
+        <a:font script="Orya" typeface="Kalinga"/>
+        <a:font script="Mlym" typeface="Kartika"/>
+        <a:font script="Laoo" typeface="DokChampa"/>
+        <a:font script="Sinh" typeface="Iskoola Pota"/>
+        <a:font script="Mong" typeface="Mongolian Baiti"/>
+        <a:font script="Viet" typeface="Times New Roman"/>
+        <a:font script="Uigh" typeface="Microsoft Uighur"/>
+        <a:font script="Geor" typeface="Sylfaen"/>
+        <a:font script="Armn" typeface="Arial"/>
+        <a:font script="Bugi" typeface="Leelawadee UI"/>
+        <a:font script="Bopo" typeface="Microsoft JhengHei"/>
+        <a:font script="Java" typeface="Javanese Text"/>
+        <a:font script="Lisu" typeface="Segoe UI"/>
+        <a:font script="Mymr" typeface="Myanmar Text"/>
+        <a:font script="Nkoo" typeface="Ebrima"/>
+        <a:font script="Olck" typeface="Nirmala UI"/>
+        <a:font script="Osma" typeface="Ebrima"/>
+        <a:font script="Phag" typeface="Phagspa"/>
+        <a:font script="Syrn" typeface="Estrangelo Edessa"/>
+        <a:font script="Syrj" typeface="Estrangelo Edessa"/>
+        <a:font script="Syre" typeface="Estrangelo Edessa"/>
+        <a:font script="Sora" typeface="Nirmala UI"/>
+        <a:font script="Tale" typeface="Microsoft Tai Le"/>
+        <a:font script="Talu" typeface="Microsoft New Tai Lue"/>
+        <a:font script="Tfng" typeface="Ebrima"/>
+      </a:majorFont>
+      <a:minorFont>
+        <a:latin typeface="Calibri" panose="020F0502020204030204"/>
+        <a:ea typeface=""/>
+        <a:cs typeface=""/>
+        <a:font script="Jpan" typeface="游ゴシック"/>
+        <a:font script="Hang" typeface="맑은 고딕"/>
+        <a:font script="Hans" typeface="等线"/>
+        <a:font script="Hant" typeface="新細明體"/>
+        <a:font script="Arab" typeface="Arial"/>
+        <a:font script="Hebr" typeface="Arial"/>
+        <a:font script="Thai" typeface="Cordia New"/>
+        <a:font script="Ethi" typeface="Nyala"/>
+        <a:font script="Beng" typeface="Vrinda"/>
+        <a:font script="Gujr" typeface="Shruti"/>
+        <a:font script="Khmr" typeface="DaunPenh"/>
+        <a:font script="Knda" typeface="Tunga"/>
+        <a:font script="Guru" typeface="Raavi"/>
+        <a:font script="Cans" typeface="Euphemia"/>
+        <a:font script="Cher" typeface="Plantagenet Cherokee"/>
+        <a:font script="Yiii" typeface="Microsoft Yi Baiti"/>
+        <a:font script="Tibt" typeface="Microsoft Himalaya"/>
+        <a:font script="Thaa" typeface="MV Boli"/>
+        <a:font script="Deva" typeface="Mangal"/>
+        <a:font script="Telu" typeface="Gautami"/>
+        <a:font script="Taml" typeface="Latha"/>
+        <a:font script="Syrc" typeface="Estrangelo Edessa"/>
+        <a:font script="Orya" typeface="Kalinga"/>
+        <a:font script="Mlym" typeface="Kartika"/>
+        <a:font script="Laoo" typeface="DokChampa"/>
+        <a:font script="Sinh" typeface="Iskoola Pota"/>
+        <a:font script="Mong" typeface="Mongolian Baiti"/>
+        <a:font script="Viet" typeface="Arial"/>
+        <a:font script="Uigh" typeface="Microsoft Uighur"/>
+        <a:font script="Geor" typeface="Sylfaen"/>
+        <a:font script="Armn" typeface="Arial"/>
+        <a:font script="Bugi" typeface="Leelawadee UI"/>
+        <a:font script="Bopo" typeface="Microsoft JhengHei"/>
+        <a:font script="Java" typeface="Javanese Text"/>
+        <a:font script="Lisu" typeface="Segoe UI"/>
+        <a:font script="Mymr" typeface="Myanmar Text"/>
+        <a:font script="Nkoo" typeface="Ebrima"/>
+        <a:font script="Olck" typeface="Nirmala UI"/>
+        <a:font script="Osma" typeface="Ebrima"/>
+        <a:font script="Phag" typeface="Phagspa"/>
+        <a:font script="Syrn" typeface="Estrangelo Edessa"/>
+        <a:font script="Syrj" typeface="Estrangelo Edessa"/>
+        <a:font script="Syre" typeface="Estrangelo Edessa"/>
+        <a:font script="Sora" typeface="Nirmala UI"/>
+        <a:font script="Tale" typeface="Microsoft Tai Le"/>
+        <a:font script="Talu" typeface="Microsoft New Tai Lue"/>
+        <a:font script="Tfng" typeface="Ebrima"/>
+      </a:minorFont>
+    </a:fontScheme>
+    <a:fmtScheme name="Стандартная">
+      <a:fillStyleLst>
+        <a:solidFill>
+          <a:schemeClr val="phClr"/>
+        </a:solidFill>
+        <a:gradFill rotWithShape="1">
+          <a:gsLst>
+            <a:gs pos="0">
+              <a:schemeClr val="phClr">
+                <a:lumMod val="110000"/>
+                <a:satMod val="105000"/>
+                <a:tint val="67000"/>
+              </a:schemeClr>
+            </a:gs>
+            <a:gs pos="50000">
+              <a:schemeClr val="phClr">
+                <a:lumMod val="105000"/>
+                <a:satMod val="103000"/>
+                <a:tint val="73000"/>
+              </a:schemeClr>
+            </a:gs>
+            <a:gs pos="100000">
+              <a:schemeClr val="phClr">
+                <a:lumMod val="105000"/>
+                <a:satMod val="109000"/>
+                <a:tint val="81000"/>
+              </a:schemeClr>
+            </a:gs>
+          </a:gsLst>
+          <a:lin ang="5400000" scaled="0"/>
+        </a:gradFill>
+        <a:gradFill rotWithShape="1">
+          <a:gsLst>
+            <a:gs pos="0">
+              <a:schemeClr val="phClr">
+                <a:satMod val="103000"/>
+                <a:lumMod val="102000"/>
+                <a:tint val="94000"/>
+              </a:schemeClr>
+            </a:gs>
+            <a:gs pos="50000">
+              <a:schemeClr val="phClr">
+                <a:satMod val="110000"/>
+                <a:lumMod val="100000"/>
+                <a:shade val="100000"/>
+              </a:schemeClr>
+            </a:gs>
+            <a:gs pos="100000">
+              <a:schemeClr val="phClr">
+                <a:lumMod val="99000"/>
+                <a:satMod val="120000"/>
+                <a:shade val="78000"/>
+              </a:schemeClr>
+            </a:gs>
+          </a:gsLst>
+          <a:lin ang="5400000" scaled="0"/>
+        </a:gradFill>
+      </a:fillStyleLst>
+      <a:lnStyleLst>
+        <a:ln w="6350" cap="flat" cmpd="sng" algn="ctr">
+          <a:solidFill>
+            <a:schemeClr val="phClr"/>
+          </a:solidFill>
+          <a:prstDash val="solid"/>
+          <a:miter lim="800000"/>
+        </a:ln>
+        <a:ln w="12700" cap="flat" cmpd="sng" algn="ctr">
+          <a:solidFill>
+            <a:schemeClr val="phClr"/>
+          </a:solidFill>
+          <a:prstDash val="solid"/>
+          <a:miter lim="800000"/>
+        </a:ln>
+        <a:ln w="19050" cap="flat" cmpd="sng" algn="ctr">
+          <a:solidFill>
+            <a:schemeClr val="phClr"/>
+          </a:solidFill>
+          <a:prstDash val="solid"/>
+          <a:miter lim="800000"/>
+        </a:ln>
+      </a:lnStyleLst>
+      <a:effectStyleLst>
+        <a:effectStyle>
+          <a:effectLst/>
+        </a:effectStyle>
+        <a:effectStyle>
+          <a:effectLst/>
+        </a:effectStyle>
+        <a:effectStyle>
+          <a:effectLst>
+            <a:outerShdw blurRad="57150" dist="19050" dir="5400000" algn="ctr" rotWithShape="0">
+              <a:srgbClr val="000000">
+                <a:alpha val="63000"/>
+              </a:srgbClr>
+            </a:outerShdw>
+          </a:effectLst>
+        </a:effectStyle>
+      </a:effectStyleLst>
+      <a:bgFillStyleLst>
+        <a:solidFill>
+          <a:schemeClr val="phClr"/>
+        </a:solidFill>
+        <a:solidFill>
+          <a:schemeClr val="phClr">
+            <a:tint val="95000"/>
+            <a:satMod val="170000"/>
+          </a:schemeClr>
+        </a:solidFill>
+        <a:gradFill rotWithShape="1">
+          <a:gsLst>
+            <a:gs pos="0">
+              <a:schemeClr val="phClr">
+                <a:tint val="93000"/>
+                <a:satMod val="150000"/>
+                <a:shade val="98000"/>
+                <a:lumMod val="102000"/>
+              </a:schemeClr>
+            </a:gs>
+            <a:gs pos="50000">
+              <a:schemeClr val="phClr">
+                <a:tint val="98000"/>
+                <a:satMod val="130000"/>
+                <a:shade val="90000"/>
+                <a:lumMod val="103000"/>
+              </a:schemeClr>
+            </a:gs>
+            <a:gs pos="100000">
+              <a:schemeClr val="phClr">
+                <a:shade val="63000"/>
+                <a:satMod val="120000"/>
+              </a:schemeClr>
+            </a:gs>
+          </a:gsLst>
+          <a:lin ang="5400000" scaled="0"/>
+        </a:gradFill>
+      </a:bgFillStyleLst>
+    </a:fmtScheme>
+  </a:themeElements>
+  <a:objectDefaults/>
+  <a:extraClrSchemeLst/>
+  <a:extLst>
+    <a:ext uri="{05A4C25C-085E-4340-85A3-A5531E510DB2}">
+      <thm15:themeFamily xmlns:thm15="http://schemas.microsoft.com/office/thememl/2012/main" name="Office Theme" id="{62F939B6-93AF-4DB8-9C6B-D6C7DFDC589F}" vid="{4A3C46E8-61CC-4603-A589-7422A47A8E4A}"/>
+    </a:ext>
+  </a:extLst>
+</a:theme>
 </file>
</xml_diff>